<commit_message>
Update notebook to showcase training resumption and no impact to general model behaviour
</commit_message>
<xml_diff>
--- a/docs/AMD-Unsloth-GRPO-Fine-tuning1.pptx
+++ b/docs/AMD-Unsloth-GRPO-Fine-tuning1.pptx
@@ -337,7 +337,7 @@
             <a:fld id="{076B0810-FC62-EE4E-BF04-55F4B7654175}" type="datetime8">
               <a:rPr lang="en-US" smtClean="0"/>
               <a:pPr/>
-              <a:t>8/8/2026 12:06 AM</a:t>
+              <a:t>9/28/2026 12:50 PM</a:t>
             </a:fld>
             <a:endParaRPr lang="en-US" dirty="0"/>
           </a:p>
@@ -577,7 +577,7 @@
             <a:fld id="{076B0810-FC62-EE4E-BF04-55F4B7654175}" type="datetime8">
               <a:rPr lang="en-US" smtClean="0"/>
               <a:pPr/>
-              <a:t>8/8/2026 12:06 AM</a:t>
+              <a:t>9/28/2026 12:50 PM</a:t>
             </a:fld>
             <a:endParaRPr lang="en-US" dirty="0"/>
           </a:p>
@@ -2254,7 +2254,7 @@
         <p:fade/>
       </p:transition>
     </mc:Choice>
-    <mc:Fallback xmlns="" xmlns:a16="http://schemas.microsoft.com/office/drawing/2014/main" xmlns:a14="http://schemas.microsoft.com/office/drawing/2010/main" xmlns:p15="http://schemas.microsoft.com/office/powerpoint/2012/main">
+    <mc:Fallback xmlns:p15="http://schemas.microsoft.com/office/powerpoint/2012/main" xmlns:a14="http://schemas.microsoft.com/office/drawing/2010/main" xmlns:a16="http://schemas.microsoft.com/office/drawing/2014/main" xmlns="">
       <p:transition spd="med">
         <p:fade/>
       </p:transition>
@@ -10451,7 +10451,7 @@
         <p:fade/>
       </p:transition>
     </mc:Choice>
-    <mc:Fallback xmlns:a16="http://schemas.microsoft.com/office/drawing/2014/main" xmlns:a14="http://schemas.microsoft.com/office/drawing/2010/main" xmlns:p15="http://schemas.microsoft.com/office/powerpoint/2012/main" xmlns="">
+    <mc:Fallback xmlns="" xmlns:p15="http://schemas.microsoft.com/office/powerpoint/2012/main" xmlns:a14="http://schemas.microsoft.com/office/drawing/2010/main" xmlns:a16="http://schemas.microsoft.com/office/drawing/2014/main">
       <p:transition spd="med">
         <p:fade/>
       </p:transition>
@@ -14577,7 +14577,7 @@
         <p:fade/>
       </p:transition>
     </mc:Choice>
-    <mc:Fallback xmlns="" xmlns:a16="http://schemas.microsoft.com/office/drawing/2014/main" xmlns:a14="http://schemas.microsoft.com/office/drawing/2010/main" xmlns:p15="http://schemas.microsoft.com/office/powerpoint/2012/main">
+    <mc:Fallback xmlns:p15="http://schemas.microsoft.com/office/powerpoint/2012/main" xmlns:a14="http://schemas.microsoft.com/office/drawing/2010/main" xmlns:a16="http://schemas.microsoft.com/office/drawing/2014/main" xmlns="">
       <p:transition spd="med">
         <p:fade/>
       </p:transition>
@@ -19524,20 +19524,31 @@
             <p:ph type="body" sz="quarter" idx="12"/>
           </p:nvPr>
         </p:nvSpPr>
-        <p:spPr/>
+        <p:spPr>
+          <a:xfrm>
+            <a:off x="5350260" y="3875650"/>
+            <a:ext cx="6244332" cy="246221"/>
+          </a:xfrm>
+        </p:spPr>
         <p:txBody>
           <a:bodyPr/>
           <a:lstStyle/>
           <a:p>
             <a:r>
-              <a:rPr sz="1600" b="0">
+              <a:rPr lang="en-US" sz="1600" b="0" dirty="0">
                 <a:solidFill>
                   <a:srgbClr val="C6C8CC"/>
                 </a:solidFill>
                 <a:latin typeface="Klavika Medium"/>
               </a:rPr>
-              <a:t>Malini Bhandaru  |  Shailen Sobhee</a:t>
-            </a:r>
+              <a:t>Eddie Zhou</a:t>
+            </a:r>
+            <a:endParaRPr sz="1600" b="0" dirty="0">
+              <a:solidFill>
+                <a:srgbClr val="C6C8CC"/>
+              </a:solidFill>
+              <a:latin typeface="Klavika Medium"/>
+            </a:endParaRPr>
           </a:p>
         </p:txBody>
       </p:sp>
@@ -19834,7 +19845,7 @@
         <p:spPr>
           <a:xfrm>
             <a:off x="822960" y="3813048"/>
-            <a:ext cx="2073402" cy="475488"/>
+            <a:ext cx="2073402" cy="214033"/>
           </a:xfrm>
           <a:prstGeom prst="rect">
             <a:avLst/>
@@ -19859,13 +19870,40 @@
               </a:spcAft>
             </a:pPr>
             <a:r>
-              <a:rPr sz="1250" b="0">
+              <a:rPr lang="en-US" sz="1250" dirty="0">
                 <a:solidFill>
                   <a:srgbClr val="D8DADE"/>
                 </a:solidFill>
                 <a:latin typeface="Klavika Regular"/>
               </a:rPr>
-              <a:t>built in, no glue code</a:t>
+              <a:t>bu</a:t>
+            </a:r>
+            <a:r>
+              <a:rPr sz="1250" b="0" dirty="0">
+                <a:solidFill>
+                  <a:srgbClr val="D8DADE"/>
+                </a:solidFill>
+                <a:latin typeface="Klavika Regular"/>
+              </a:rPr>
+              <a:t>ilt</a:t>
+            </a:r>
+            <a:r>
+              <a:rPr lang="en-US" sz="1250" b="0" dirty="0">
+                <a:solidFill>
+                  <a:srgbClr val="D8DADE"/>
+                </a:solidFill>
+                <a:latin typeface="Klavika Regular"/>
+              </a:rPr>
+              <a:t>-</a:t>
+            </a:r>
+            <a:r>
+              <a:rPr sz="1250" b="0" dirty="0">
+                <a:solidFill>
+                  <a:srgbClr val="D8DADE"/>
+                </a:solidFill>
+                <a:latin typeface="Klavika Regular"/>
+              </a:rPr>
+              <a:t>in</a:t>
             </a:r>
           </a:p>
         </p:txBody>
@@ -20535,7 +20573,7 @@
               </a:spcAft>
             </a:pPr>
             <a:r>
-              <a:rPr sz="1300" b="0">
+              <a:rPr sz="1300" b="0" dirty="0">
                 <a:solidFill>
                   <a:srgbClr val="FFFFFF"/>
                 </a:solidFill>
@@ -20554,13 +20592,22 @@
               </a:spcAft>
             </a:pPr>
             <a:r>
-              <a:rPr sz="1400" b="0">
+              <a:rPr sz="1400" b="0" dirty="0" err="1">
                 <a:solidFill>
                   <a:srgbClr val="D8DADE"/>
                 </a:solidFill>
                 <a:latin typeface="Klavika Regular"/>
               </a:rPr>
-              <a:t>Unsloth is what makes a GRPO run finish inside a session slot instead of overnight.</a:t>
+              <a:t>Unsloth</a:t>
+            </a:r>
+            <a:r>
+              <a:rPr sz="1400" b="0" dirty="0">
+                <a:solidFill>
+                  <a:srgbClr val="D8DADE"/>
+                </a:solidFill>
+                <a:latin typeface="Klavika Regular"/>
+              </a:rPr>
+              <a:t> is what makes a GRPO run finish inside a session slot instead of overnight.</a:t>
             </a:r>
           </a:p>
         </p:txBody>
@@ -20749,7 +20796,7 @@
               </a:spcAft>
             </a:pPr>
             <a:r>
-              <a:rPr sz="1700" b="0">
+              <a:rPr sz="1700" b="0" dirty="0">
                 <a:solidFill>
                   <a:srgbClr val="D8DADE"/>
                 </a:solidFill>
@@ -20758,7 +20805,7 @@
               <a:t>Sudoku means </a:t>
             </a:r>
             <a:r>
-              <a:rPr sz="1700" b="1">
+              <a:rPr sz="1700" b="1" dirty="0">
                 <a:solidFill>
                   <a:srgbClr val="FFFFFF"/>
                 </a:solidFill>
@@ -20767,7 +20814,7 @@
               <a:t>“single number”</a:t>
             </a:r>
             <a:r>
-              <a:rPr sz="1700" b="0">
+              <a:rPr sz="1700" b="0" dirty="0">
                 <a:solidFill>
                   <a:srgbClr val="D8DADE"/>
                 </a:solidFill>
@@ -20789,7 +20836,7 @@
               </a:spcAft>
             </a:pPr>
             <a:r>
-              <a:rPr sz="1500" b="0">
+              <a:rPr sz="1500" b="0" dirty="0">
                 <a:solidFill>
                   <a:srgbClr val="D8DADE"/>
                 </a:solidFill>
@@ -20964,7 +21011,7 @@
               </a:spcAft>
             </a:pPr>
             <a:r>
-              <a:rPr sz="1250" b="0">
+              <a:rPr sz="1250" b="0" dirty="0">
                 <a:solidFill>
                   <a:srgbClr val="D8DADE"/>
                 </a:solidFill>
@@ -21139,7 +21186,7 @@
               </a:spcAft>
             </a:pPr>
             <a:r>
-              <a:rPr sz="1250" b="0">
+              <a:rPr sz="1250" b="0" dirty="0">
                 <a:solidFill>
                   <a:srgbClr val="D8DADE"/>
                 </a:solidFill>
@@ -21314,7 +21361,7 @@
               </a:spcAft>
             </a:pPr>
             <a:r>
-              <a:rPr sz="1250" b="0">
+              <a:rPr sz="1250" b="0" dirty="0">
                 <a:solidFill>
                   <a:srgbClr val="D8DADE"/>
                 </a:solidFill>
@@ -22155,181 +22202,6 @@
                 <a:latin typeface="Klavika Regular"/>
               </a:rPr>
               <a:t>Lands you on an AMD Radeon GPU</a:t>
-            </a:r>
-          </a:p>
-        </p:txBody>
-      </p:sp>
-      <p:sp>
-        <p:nvSpPr>
-          <p:cNvPr id="18" name="Rectangle 17"/>
-          <p:cNvSpPr/>
-          <p:nvPr/>
-        </p:nvSpPr>
-        <p:spPr>
-          <a:xfrm>
-            <a:off x="585216" y="4983480"/>
-            <a:ext cx="4892040" cy="777240"/>
-          </a:xfrm>
-          <a:prstGeom prst="rect">
-            <a:avLst/>
-          </a:prstGeom>
-          <a:solidFill>
-            <a:srgbClr val="151515"/>
-          </a:solidFill>
-          <a:ln w="9525">
-            <a:solidFill>
-              <a:srgbClr val="333333"/>
-            </a:solidFill>
-          </a:ln>
-          <a:effectLst/>
-        </p:spPr>
-        <p:style>
-          <a:lnRef idx="1">
-            <a:schemeClr val="accent1"/>
-          </a:lnRef>
-          <a:fillRef idx="3">
-            <a:schemeClr val="accent1"/>
-          </a:fillRef>
-          <a:effectRef idx="2">
-            <a:schemeClr val="accent1"/>
-          </a:effectRef>
-          <a:fontRef idx="minor">
-            <a:schemeClr val="lt1"/>
-          </a:fontRef>
-        </p:style>
-        <p:txBody>
-          <a:bodyPr rtlCol="0" anchor="ctr"/>
-          <a:lstStyle/>
-          <a:p>
-            <a:endParaRPr/>
-          </a:p>
-        </p:txBody>
-      </p:sp>
-      <p:sp>
-        <p:nvSpPr>
-          <p:cNvPr id="19" name="Rectangle 18"/>
-          <p:cNvSpPr/>
-          <p:nvPr/>
-        </p:nvSpPr>
-        <p:spPr>
-          <a:xfrm>
-            <a:off x="585216" y="4983480"/>
-            <a:ext cx="64008" cy="777240"/>
-          </a:xfrm>
-          <a:prstGeom prst="rect">
-            <a:avLst/>
-          </a:prstGeom>
-          <a:solidFill>
-            <a:srgbClr val="F26522"/>
-          </a:solidFill>
-          <a:ln>
-            <a:noFill/>
-          </a:ln>
-          <a:effectLst/>
-        </p:spPr>
-        <p:style>
-          <a:lnRef idx="1">
-            <a:schemeClr val="accent1"/>
-          </a:lnRef>
-          <a:fillRef idx="3">
-            <a:schemeClr val="accent1"/>
-          </a:fillRef>
-          <a:effectRef idx="2">
-            <a:schemeClr val="accent1"/>
-          </a:effectRef>
-          <a:fontRef idx="minor">
-            <a:schemeClr val="lt1"/>
-          </a:fontRef>
-        </p:style>
-        <p:txBody>
-          <a:bodyPr rtlCol="0" anchor="ctr"/>
-          <a:lstStyle/>
-          <a:p>
-            <a:pPr algn="ctr"/>
-            <a:endParaRPr/>
-          </a:p>
-        </p:txBody>
-      </p:sp>
-      <p:sp>
-        <p:nvSpPr>
-          <p:cNvPr id="20" name="TextBox 19"/>
-          <p:cNvSpPr txBox="1"/>
-          <p:nvPr/>
-        </p:nvSpPr>
-        <p:spPr>
-          <a:xfrm>
-            <a:off x="859536" y="5129784"/>
-            <a:ext cx="4389120" cy="256032"/>
-          </a:xfrm>
-          <a:prstGeom prst="rect">
-            <a:avLst/>
-          </a:prstGeom>
-          <a:noFill/>
-        </p:spPr>
-        <p:txBody>
-          <a:bodyPr wrap="square" lIns="0" tIns="0" rIns="0" bIns="0">
-            <a:spAutoFit/>
-          </a:bodyPr>
-          <a:lstStyle/>
-          <a:p>
-            <a:pPr algn="l">
-              <a:spcBef>
-                <a:spcPts val="0"/>
-              </a:spcBef>
-              <a:spcAft>
-                <a:spcPts val="600"/>
-              </a:spcAft>
-            </a:pPr>
-            <a:r>
-              <a:rPr sz="1300" b="0">
-                <a:solidFill>
-                  <a:srgbClr val="FFFFFF"/>
-                </a:solidFill>
-                <a:latin typeface="Klavika Bold"/>
-              </a:rPr>
-              <a:t>It is a real GPU, not a simulator</a:t>
-            </a:r>
-          </a:p>
-        </p:txBody>
-      </p:sp>
-      <p:sp>
-        <p:nvSpPr>
-          <p:cNvPr id="21" name="TextBox 20"/>
-          <p:cNvSpPr txBox="1"/>
-          <p:nvPr/>
-        </p:nvSpPr>
-        <p:spPr>
-          <a:xfrm>
-            <a:off x="859536" y="5422392"/>
-            <a:ext cx="4389120" cy="256032"/>
-          </a:xfrm>
-          <a:prstGeom prst="rect">
-            <a:avLst/>
-          </a:prstGeom>
-          <a:noFill/>
-        </p:spPr>
-        <p:txBody>
-          <a:bodyPr wrap="square" lIns="0" tIns="0" rIns="0" bIns="0">
-            <a:spAutoFit/>
-          </a:bodyPr>
-          <a:lstStyle/>
-          <a:p>
-            <a:pPr algn="l">
-              <a:spcBef>
-                <a:spcPts val="0"/>
-              </a:spcBef>
-              <a:spcAft>
-                <a:spcPts val="600"/>
-              </a:spcAft>
-            </a:pPr>
-            <a:r>
-              <a:rPr sz="1250" b="0">
-                <a:solidFill>
-                  <a:srgbClr val="D8DADE"/>
-                </a:solidFill>
-                <a:latin typeface="Klavika Regular"/>
-              </a:rPr>
-              <a:t>Hosted Jupyter, nothing to install locally</a:t>
             </a:r>
           </a:p>
         </p:txBody>
@@ -29239,7 +29111,7 @@
               </a:spcAft>
             </a:pPr>
             <a:r>
-              <a:rPr sz="1700" b="0">
+              <a:rPr sz="1700" b="0" dirty="0">
                 <a:solidFill>
                   <a:srgbClr val="D8DADE"/>
                 </a:solidFill>
@@ -29248,7 +29120,7 @@
               <a:t>A neural network trained on a huge amount of text so it can predict </a:t>
             </a:r>
             <a:r>
-              <a:rPr sz="1700" b="1">
+              <a:rPr sz="1700" b="1" dirty="0">
                 <a:solidFill>
                   <a:srgbClr val="FFFFFF"/>
                 </a:solidFill>
@@ -29257,7 +29129,7 @@
               <a:t>the next token</a:t>
             </a:r>
             <a:r>
-              <a:rPr sz="1700" b="0">
+              <a:rPr sz="1700" b="0" dirty="0">
                 <a:solidFill>
                   <a:srgbClr val="D8DADE"/>
                 </a:solidFill>
@@ -29279,13 +29151,31 @@
               </a:spcAft>
             </a:pPr>
             <a:r>
-              <a:rPr sz="1500" b="0">
+              <a:rPr sz="1500" b="0" dirty="0">
                 <a:solidFill>
                   <a:srgbClr val="C6C8CC"/>
                 </a:solidFill>
                 <a:latin typeface="Klavika Regular"/>
               </a:rPr>
-              <a:t>That one simple skill, done at enormous scale, is enough to chat, summarise, write code and reason.</a:t>
+              <a:t>That one simple skill, done at enormous scale, is enough to chat, </a:t>
+            </a:r>
+            <a:r>
+              <a:rPr sz="1500" b="0" dirty="0" err="1">
+                <a:solidFill>
+                  <a:srgbClr val="C6C8CC"/>
+                </a:solidFill>
+                <a:latin typeface="Klavika Regular"/>
+              </a:rPr>
+              <a:t>summarise</a:t>
+            </a:r>
+            <a:r>
+              <a:rPr sz="1500" b="0" dirty="0">
+                <a:solidFill>
+                  <a:srgbClr val="C6C8CC"/>
+                </a:solidFill>
+                <a:latin typeface="Klavika Regular"/>
+              </a:rPr>
+              <a:t>, write code and reason.</a:t>
             </a:r>
           </a:p>
         </p:txBody>
@@ -29786,7 +29676,7 @@
         <p:spPr>
           <a:xfrm>
             <a:off x="841248" y="4032504"/>
-            <a:ext cx="2977896" cy="1143000"/>
+            <a:ext cx="2977896" cy="737510"/>
           </a:xfrm>
           <a:prstGeom prst="rect">
             <a:avLst/>
@@ -29811,13 +29701,31 @@
               </a:spcAft>
             </a:pPr>
             <a:r>
-              <a:rPr sz="1350" b="0">
+              <a:rPr sz="1350" b="0" dirty="0">
                 <a:solidFill>
                   <a:srgbClr val="D8DADE"/>
                 </a:solidFill>
                 <a:latin typeface="Klavika Regular"/>
               </a:rPr>
-              <a:t>Raw next-token predictors. Great starting point for training, awkward to chat with.</a:t>
+              <a:t>Raw next-token predictors. Great starting point for training</a:t>
+            </a:r>
+            <a:r>
+              <a:rPr lang="en-US" sz="1350" b="0" dirty="0">
+                <a:solidFill>
+                  <a:srgbClr val="D8DADE"/>
+                </a:solidFill>
+                <a:latin typeface="Klavika Regular"/>
+              </a:rPr>
+              <a:t> but</a:t>
+            </a:r>
+            <a:r>
+              <a:rPr sz="1350" b="0" dirty="0">
+                <a:solidFill>
+                  <a:srgbClr val="D8DADE"/>
+                </a:solidFill>
+                <a:latin typeface="Klavika Regular"/>
+              </a:rPr>
+              <a:t> awkward to chat with.</a:t>
             </a:r>
           </a:p>
         </p:txBody>
@@ -29989,7 +29897,7 @@
               </a:spcAft>
             </a:pPr>
             <a:r>
-              <a:rPr sz="1350" b="0">
+              <a:rPr sz="1350" b="0" dirty="0">
                 <a:solidFill>
                   <a:srgbClr val="D8DADE"/>
                 </a:solidFill>
@@ -30142,7 +30050,7 @@
         <p:spPr>
           <a:xfrm>
             <a:off x="8369808" y="4032504"/>
-            <a:ext cx="2977896" cy="1143000"/>
+            <a:ext cx="2977896" cy="737510"/>
           </a:xfrm>
           <a:prstGeom prst="rect">
             <a:avLst/>
@@ -30167,13 +30075,31 @@
               </a:spcAft>
             </a:pPr>
             <a:r>
-              <a:rPr sz="1350" b="0">
+              <a:rPr sz="1350" b="0" dirty="0">
                 <a:solidFill>
                   <a:srgbClr val="D8DADE"/>
                 </a:solidFill>
                 <a:latin typeface="Klavika Regular"/>
               </a:rPr>
-              <a:t>Llama, Qwen, Mistral on Hugging Face know a bit of everything, your job in particular: no.</a:t>
+              <a:t>Llama, Qwen, Mistral on Hugging Face know a bit of everythin</a:t>
+            </a:r>
+            <a:r>
+              <a:rPr lang="en-US" sz="1350" b="0" dirty="0">
+                <a:solidFill>
+                  <a:srgbClr val="D8DADE"/>
+                </a:solidFill>
+                <a:latin typeface="Klavika Regular"/>
+              </a:rPr>
+              <a:t>g, but not something specific to you</a:t>
+            </a:r>
+            <a:r>
+              <a:rPr sz="1350" b="0" dirty="0">
+                <a:solidFill>
+                  <a:srgbClr val="D8DADE"/>
+                </a:solidFill>
+                <a:latin typeface="Klavika Regular"/>
+              </a:rPr>
+              <a:t>.</a:t>
             </a:r>
           </a:p>
         </p:txBody>
@@ -30542,7 +30468,7 @@
               </a:spcAft>
             </a:pPr>
             <a:r>
-              <a:rPr sz="1250" b="0">
+              <a:rPr sz="1250" b="0" dirty="0">
                 <a:solidFill>
                   <a:srgbClr val="D8DADE"/>
                 </a:solidFill>
@@ -30773,7 +30699,7 @@
               </a:spcAft>
             </a:pPr>
             <a:r>
-              <a:rPr sz="1250" b="0">
+              <a:rPr sz="1250" b="0" dirty="0">
                 <a:solidFill>
                   <a:srgbClr val="D8DADE"/>
                 </a:solidFill>
@@ -30979,7 +30905,7 @@
         <p:spPr>
           <a:xfrm>
             <a:off x="6469379" y="3282696"/>
-            <a:ext cx="2073402" cy="548640"/>
+            <a:ext cx="2073402" cy="435247"/>
           </a:xfrm>
           <a:prstGeom prst="rect">
             <a:avLst/>
@@ -31004,14 +30930,29 @@
               </a:spcAft>
             </a:pPr>
             <a:r>
-              <a:rPr sz="1250" b="0">
+              <a:rPr sz="1250" b="0" dirty="0">
                 <a:solidFill>
                   <a:srgbClr val="D8DADE"/>
                 </a:solidFill>
                 <a:latin typeface="Klavika Regular"/>
               </a:rPr>
-              <a:t>Always return JSON. Always cite sources. Every time.</a:t>
-            </a:r>
+              <a:t>Always return JSON. Always cite sources</a:t>
+            </a:r>
+            <a:r>
+              <a:rPr lang="en-US" sz="1250" b="0" dirty="0">
+                <a:solidFill>
+                  <a:srgbClr val="D8DADE"/>
+                </a:solidFill>
+                <a:latin typeface="Klavika Regular"/>
+              </a:rPr>
+              <a:t>.</a:t>
+            </a:r>
+            <a:endParaRPr sz="1250" b="0" dirty="0">
+              <a:solidFill>
+                <a:srgbClr val="D8DADE"/>
+              </a:solidFill>
+              <a:latin typeface="Klavika Regular"/>
+            </a:endParaRPr>
           </a:p>
         </p:txBody>
       </p:sp>
@@ -31346,7 +31287,7 @@
         <p:spPr>
           <a:xfrm>
             <a:off x="877824" y="4462272"/>
-            <a:ext cx="10378440" cy="566928"/>
+            <a:ext cx="10378440" cy="543931"/>
           </a:xfrm>
           <a:prstGeom prst="rect">
             <a:avLst/>
@@ -31371,7 +31312,7 @@
               </a:spcAft>
             </a:pPr>
             <a:r>
-              <a:rPr sz="1450" b="1">
+              <a:rPr sz="1450" b="1" dirty="0">
                 <a:solidFill>
                   <a:srgbClr val="FFFFFF"/>
                 </a:solidFill>
@@ -31380,16 +31321,16 @@
               <a:t>Often cheaper and more reliable</a:t>
             </a:r>
             <a:r>
-              <a:rPr sz="1450" b="0">
+              <a:rPr sz="1450" b="0" dirty="0">
                 <a:solidFill>
                   <a:srgbClr val="D8DADE"/>
                 </a:solidFill>
                 <a:latin typeface="Klavika Regular"/>
               </a:rPr>
-              <a:t> than stuffing everything into a giant prompt, or paying for an even bigger model. </a:t>
-            </a:r>
-            <a:r>
-              <a:rPr sz="1450" b="1">
+              <a:t> than stuffing everything into a giant prompt or paying for an even bigger model. </a:t>
+            </a:r>
+            <a:r>
+              <a:rPr sz="1450" b="1" dirty="0">
                 <a:solidFill>
                   <a:srgbClr val="00A8CC"/>
                 </a:solidFill>
@@ -31494,7 +31435,7 @@
               </a:spcAft>
             </a:pPr>
             <a:r>
-              <a:rPr sz="1600" b="0">
+              <a:rPr sz="1600" b="0" dirty="0">
                 <a:solidFill>
                   <a:srgbClr val="D8DADE"/>
                 </a:solidFill>
@@ -31700,7 +31641,7 @@
         <p:spPr>
           <a:xfrm>
             <a:off x="841248" y="2697480"/>
-            <a:ext cx="4837176" cy="1417320"/>
+            <a:ext cx="4837176" cy="828432"/>
           </a:xfrm>
           <a:prstGeom prst="rect">
             <a:avLst/>
@@ -31722,7 +31663,7 @@
               </a:spcAft>
             </a:pPr>
             <a:r>
-              <a:rPr sz="1350">
+              <a:rPr sz="1350" dirty="0">
                 <a:solidFill>
                   <a:srgbClr val="F26522"/>
                 </a:solidFill>
@@ -31731,7 +31672,7 @@
               <a:t>•  </a:t>
             </a:r>
             <a:r>
-              <a:rPr sz="1350">
+              <a:rPr sz="1350" dirty="0">
                 <a:solidFill>
                   <a:srgbClr val="D8DADE"/>
                 </a:solidFill>
@@ -31750,7 +31691,7 @@
               </a:spcAft>
             </a:pPr>
             <a:r>
-              <a:rPr sz="1350">
+              <a:rPr sz="1350" dirty="0">
                 <a:solidFill>
                   <a:srgbClr val="F26522"/>
                 </a:solidFill>
@@ -31759,14 +31700,47 @@
               <a:t>•  </a:t>
             </a:r>
             <a:r>
-              <a:rPr sz="1350">
+              <a:rPr sz="1350" dirty="0">
                 <a:solidFill>
                   <a:srgbClr val="D8DADE"/>
                 </a:solidFill>
                 <a:latin typeface="Klavika Regular"/>
               </a:rPr>
-              <a:t>Original weights stay frozen, only adapters train</a:t>
-            </a:r>
+              <a:t>Original weights stay frozen, only adapters </a:t>
+            </a:r>
+            <a:r>
+              <a:rPr lang="en-US" sz="1350" dirty="0">
+                <a:solidFill>
+                  <a:srgbClr val="D8DADE"/>
+                </a:solidFill>
+                <a:latin typeface="Klavika Regular"/>
+              </a:rPr>
+              <a:t>are </a:t>
+            </a:r>
+            <a:r>
+              <a:rPr sz="1350" dirty="0">
+                <a:solidFill>
+                  <a:srgbClr val="D8DADE"/>
+                </a:solidFill>
+                <a:latin typeface="Klavika Regular"/>
+              </a:rPr>
+              <a:t>train</a:t>
+            </a:r>
+            <a:r>
+              <a:rPr lang="en-US" sz="1350" dirty="0">
+                <a:solidFill>
+                  <a:srgbClr val="D8DADE"/>
+                </a:solidFill>
+                <a:latin typeface="Klavika Regular"/>
+              </a:rPr>
+              <a:t>ed</a:t>
+            </a:r>
+            <a:endParaRPr sz="1350" dirty="0">
+              <a:solidFill>
+                <a:srgbClr val="D8DADE"/>
+              </a:solidFill>
+              <a:latin typeface="Klavika Regular"/>
+            </a:endParaRPr>
           </a:p>
           <a:p>
             <a:pPr>
@@ -31778,7 +31752,7 @@
               </a:spcAft>
             </a:pPr>
             <a:r>
-              <a:rPr sz="1350">
+              <a:rPr sz="1350" dirty="0">
                 <a:solidFill>
                   <a:srgbClr val="F26522"/>
                 </a:solidFill>
@@ -31787,7 +31761,7 @@
               <a:t>•  </a:t>
             </a:r>
             <a:r>
-              <a:rPr sz="1350">
+              <a:rPr sz="1350" dirty="0">
                 <a:solidFill>
                   <a:srgbClr val="D8DADE"/>
                 </a:solidFill>
@@ -32015,7 +31989,7 @@
               </a:spcAft>
             </a:pPr>
             <a:r>
-              <a:rPr sz="1350">
+              <a:rPr sz="1350" dirty="0">
                 <a:solidFill>
                   <a:srgbClr val="007C97"/>
                 </a:solidFill>
@@ -32024,13 +31998,31 @@
               <a:t>•  </a:t>
             </a:r>
             <a:r>
-              <a:rPr sz="1350">
+              <a:rPr sz="1350" dirty="0">
                 <a:solidFill>
                   <a:srgbClr val="D8DADE"/>
                 </a:solidFill>
                 <a:latin typeface="Klavika Regular"/>
               </a:rPr>
-              <a:t>Everything LoRA does, plus a 4-bit base model</a:t>
+              <a:t>Everything </a:t>
+            </a:r>
+            <a:r>
+              <a:rPr sz="1350" dirty="0" err="1">
+                <a:solidFill>
+                  <a:srgbClr val="D8DADE"/>
+                </a:solidFill>
+                <a:latin typeface="Klavika Regular"/>
+              </a:rPr>
+              <a:t>LoRA</a:t>
+            </a:r>
+            <a:r>
+              <a:rPr sz="1350" dirty="0">
+                <a:solidFill>
+                  <a:srgbClr val="D8DADE"/>
+                </a:solidFill>
+                <a:latin typeface="Klavika Regular"/>
+              </a:rPr>
+              <a:t> does, plus a 4-bit base model</a:t>
             </a:r>
           </a:p>
           <a:p>
@@ -32043,7 +32035,7 @@
               </a:spcAft>
             </a:pPr>
             <a:r>
-              <a:rPr sz="1350">
+              <a:rPr sz="1350" dirty="0">
                 <a:solidFill>
                   <a:srgbClr val="007C97"/>
                 </a:solidFill>
@@ -32052,7 +32044,7 @@
               <a:t>•  </a:t>
             </a:r>
             <a:r>
-              <a:rPr sz="1350">
+              <a:rPr sz="1350" dirty="0">
                 <a:solidFill>
                   <a:srgbClr val="D8DADE"/>
                 </a:solidFill>
@@ -32071,7 +32063,7 @@
               </a:spcAft>
             </a:pPr>
             <a:r>
-              <a:rPr sz="1350">
+              <a:rPr sz="1350" dirty="0">
                 <a:solidFill>
                   <a:srgbClr val="007C97"/>
                 </a:solidFill>
@@ -32080,7 +32072,7 @@
               <a:t>•  </a:t>
             </a:r>
             <a:r>
-              <a:rPr sz="1350">
+              <a:rPr sz="1350" dirty="0">
                 <a:solidFill>
                   <a:srgbClr val="D8DADE"/>
                 </a:solidFill>
@@ -32605,7 +32597,7 @@
               </a:spcAft>
             </a:pPr>
             <a:r>
-              <a:rPr sz="1300" b="0">
+              <a:rPr sz="1300" b="0" dirty="0">
                 <a:solidFill>
                   <a:srgbClr val="D8DADE"/>
                 </a:solidFill>
@@ -32688,7 +32680,7 @@
         <p:spPr>
           <a:xfrm>
             <a:off x="585216" y="1280160"/>
-            <a:ext cx="11018520" cy="365760"/>
+            <a:ext cx="11018520" cy="271613"/>
           </a:xfrm>
           <a:prstGeom prst="rect">
             <a:avLst/>
@@ -32710,13 +32702,53 @@
               </a:spcAft>
             </a:pPr>
             <a:r>
-              <a:rPr sz="1600" b="0">
+              <a:rPr sz="1600" b="0" dirty="0">
                 <a:solidFill>
                   <a:srgbClr val="D8DADE"/>
                 </a:solidFill>
                 <a:latin typeface="Klavika Regular"/>
               </a:rPr>
-              <a:t>Two ways to tell a model it did well. One shows the answer, the other scores attempts.</a:t>
+              <a:t>Two ways to tell a model it did well. </a:t>
+            </a:r>
+            <a:r>
+              <a:rPr lang="en-US" sz="1600" b="0" dirty="0">
+                <a:solidFill>
+                  <a:srgbClr val="D8DADE"/>
+                </a:solidFill>
+                <a:latin typeface="Klavika Regular"/>
+              </a:rPr>
+              <a:t>SFT</a:t>
+            </a:r>
+            <a:r>
+              <a:rPr lang="en-US" dirty="0"/>
+              <a:t> </a:t>
+            </a:r>
+            <a:r>
+              <a:rPr sz="1600" b="0" dirty="0">
+                <a:solidFill>
+                  <a:srgbClr val="D8DADE"/>
+                </a:solidFill>
+                <a:latin typeface="Klavika Regular"/>
+              </a:rPr>
+              <a:t>shows the answer,</a:t>
+            </a:r>
+            <a:r>
+              <a:rPr lang="en-US" sz="1600" b="0" dirty="0">
+                <a:solidFill>
+                  <a:srgbClr val="D8DADE"/>
+                </a:solidFill>
+                <a:latin typeface="Klavika Regular"/>
+              </a:rPr>
+              <a:t> while GRPO </a:t>
+            </a:r>
+            <a:r>
+              <a:rPr sz="1600" b="0" dirty="0">
+                <a:solidFill>
+                  <a:srgbClr val="D8DADE"/>
+                </a:solidFill>
+                <a:latin typeface="Klavika Regular"/>
+              </a:rPr>
+              <a:t>scores attempts.</a:t>
             </a:r>
           </a:p>
         </p:txBody>
@@ -32938,7 +32970,7 @@
               </a:spcAft>
             </a:pPr>
             <a:r>
-              <a:rPr sz="1350">
+              <a:rPr sz="1350" dirty="0">
                 <a:solidFill>
                   <a:srgbClr val="F26522"/>
                 </a:solidFill>
@@ -32947,7 +32979,7 @@
               <a:t>•  </a:t>
             </a:r>
             <a:r>
-              <a:rPr sz="1350">
+              <a:rPr sz="1350" dirty="0">
                 <a:solidFill>
                   <a:srgbClr val="D8DADE"/>
                 </a:solidFill>
@@ -32966,7 +32998,7 @@
               </a:spcAft>
             </a:pPr>
             <a:r>
-              <a:rPr sz="1350">
+              <a:rPr sz="1350" dirty="0">
                 <a:solidFill>
                   <a:srgbClr val="F26522"/>
                 </a:solidFill>
@@ -32975,7 +33007,7 @@
               <a:t>•  </a:t>
             </a:r>
             <a:r>
-              <a:rPr sz="1350">
+              <a:rPr sz="1350" dirty="0">
                 <a:solidFill>
                   <a:srgbClr val="D8DADE"/>
                 </a:solidFill>
@@ -33067,7 +33099,7 @@
               </a:spcAft>
             </a:pPr>
             <a:r>
-              <a:rPr sz="1050" b="0">
+              <a:rPr sz="1050" b="0" dirty="0">
                 <a:solidFill>
                   <a:srgbClr val="C6C8CC"/>
                 </a:solidFill>
@@ -33089,7 +33121,7 @@
               </a:spcAft>
             </a:pPr>
             <a:r>
-              <a:rPr sz="1050" b="0">
+              <a:rPr sz="1050" b="0" dirty="0">
                 <a:solidFill>
                   <a:srgbClr val="C6C8CC"/>
                 </a:solidFill>
@@ -33111,7 +33143,7 @@
               </a:spcAft>
             </a:pPr>
             <a:r>
-              <a:rPr sz="1050" b="0">
+              <a:rPr sz="1050" b="0" dirty="0">
                 <a:solidFill>
                   <a:srgbClr val="00A8CC"/>
                 </a:solidFill>
@@ -33339,7 +33371,7 @@
               </a:spcAft>
             </a:pPr>
             <a:r>
-              <a:rPr sz="1350">
+              <a:rPr sz="1350" dirty="0">
                 <a:solidFill>
                   <a:srgbClr val="007C97"/>
                 </a:solidFill>
@@ -33348,7 +33380,7 @@
               <a:t>•  </a:t>
             </a:r>
             <a:r>
-              <a:rPr sz="1350">
+              <a:rPr sz="1350" dirty="0">
                 <a:solidFill>
                   <a:srgbClr val="D8DADE"/>
                 </a:solidFill>
@@ -33367,7 +33399,7 @@
               </a:spcAft>
             </a:pPr>
             <a:r>
-              <a:rPr sz="1350">
+              <a:rPr sz="1350" dirty="0">
                 <a:solidFill>
                   <a:srgbClr val="007C97"/>
                 </a:solidFill>
@@ -33376,7 +33408,7 @@
               <a:t>•  </a:t>
             </a:r>
             <a:r>
-              <a:rPr sz="1350">
+              <a:rPr sz="1350" dirty="0">
                 <a:solidFill>
                   <a:srgbClr val="D8DADE"/>
                 </a:solidFill>
@@ -33471,7 +33503,7 @@
               </a:spcAft>
             </a:pPr>
             <a:r>
-              <a:rPr sz="1250" b="1">
+              <a:rPr sz="1250" b="1" dirty="0">
                 <a:solidFill>
                   <a:srgbClr val="FFFFFF"/>
                 </a:solidFill>
@@ -33480,7 +33512,7 @@
               <a:t>Generate  </a:t>
             </a:r>
             <a:r>
-              <a:rPr sz="1250" b="0">
+              <a:rPr sz="1250" b="0" dirty="0">
                 <a:solidFill>
                   <a:srgbClr val="D8DADE"/>
                 </a:solidFill>
@@ -36185,31 +36217,31 @@
 </file>
 
 <file path=customXml/item1.xml><?xml version="1.0" encoding="utf-8"?>
-<TemplafySlideTemplateConfiguration><![CDATA[{"slideVersion":1,"isValidatorEnabled":false,"isLocked":false,"elementsMetadata":[],"slideId":"637629098780818133","enableDocumentContentUpdater":true,"version":"2.0"}]]></TemplafySlideTemplateConfiguration>
+<TemplafySlideFormConfiguration><![CDATA[{"formFields":[],"formDataEntries":[]}]]></TemplafySlideFormConfiguration>
 </file>
 
 <file path=customXml/item10.xml><?xml version="1.0" encoding="utf-8"?>
+<TemplafySlideTemplateConfiguration><![CDATA[{"slideVersion":1,"isValidatorEnabled":false,"isLocked":false,"elementsMetadata":[],"slideId":"637629098780891892","enableDocumentContentUpdater":true,"version":"2.0"}]]></TemplafySlideTemplateConfiguration>
+</file>
+
+<file path=customXml/item11.xml><?xml version="1.0" encoding="utf-8"?>
 <TemplafySlideFormConfiguration><![CDATA[{"formFields":[],"formDataEntries":[]}]]></TemplafySlideFormConfiguration>
 </file>
 
-<file path=customXml/item11.xml><?xml version="1.0" encoding="utf-8"?>
-<TemplafySlideTemplateConfiguration><![CDATA[{"slideVersion":1,"isValidatorEnabled":false,"isLocked":false,"elementsMetadata":[],"slideId":"637629098780808397","enableDocumentContentUpdater":true,"version":"2.0"}]]></TemplafySlideTemplateConfiguration>
-</file>
-
 <file path=customXml/item12.xml><?xml version="1.0" encoding="utf-8"?>
-<TemplafySlideTemplateConfiguration><![CDATA[{"slideVersion":1,"isValidatorEnabled":false,"isLocked":false,"elementsMetadata":[],"slideId":"637629098780868991","enableDocumentContentUpdater":true,"version":"2.0"}]]></TemplafySlideTemplateConfiguration>
+<TemplafySlideFormConfiguration><![CDATA[{"formFields":[],"formDataEntries":[]}]]></TemplafySlideFormConfiguration>
 </file>
 
 <file path=customXml/item13.xml><?xml version="1.0" encoding="utf-8"?>
+<TemplafySlideTemplateConfiguration><![CDATA[{"slideVersion":1,"isValidatorEnabled":false,"isLocked":false,"elementsMetadata":[],"slideId":"637629098780861368","enableDocumentContentUpdater":true,"version":"2.0"}]]></TemplafySlideTemplateConfiguration>
+</file>
+
+<file path=customXml/item14.xml><?xml version="1.0" encoding="utf-8"?>
 <TemplafySlideFormConfiguration><![CDATA[{"formFields":[],"formDataEntries":[]}]]></TemplafySlideFormConfiguration>
 </file>
 
-<file path=customXml/item14.xml><?xml version="1.0" encoding="utf-8"?>
-<TemplafySlideTemplateConfiguration><![CDATA[{"slideVersion":1,"isValidatorEnabled":false,"isLocked":false,"elementsMetadata":[],"slideId":"637629098780938389","enableDocumentContentUpdater":true,"version":"2.0"}]]></TemplafySlideTemplateConfiguration>
-</file>
-
 <file path=customXml/item15.xml><?xml version="1.0" encoding="utf-8"?>
-<TemplafySlideTemplateConfiguration><![CDATA[{"slideVersion":1,"isValidatorEnabled":false,"isLocked":false,"elementsMetadata":[],"slideId":"637629098780820470","enableDocumentContentUpdater":true,"version":"2.0"}]]></TemplafySlideTemplateConfiguration>
+<TemplafySlideFormConfiguration><![CDATA[{"formFields":[],"formDataEntries":[]}]]></TemplafySlideFormConfiguration>
 </file>
 
 <file path=customXml/item16.xml><?xml version="1.0" encoding="utf-8"?>
@@ -36217,22 +36249,56 @@
 </file>
 
 <file path=customXml/item17.xml><?xml version="1.0" encoding="utf-8"?>
+<TemplafySlideTemplateConfiguration><![CDATA[{"slideVersion":1,"isValidatorEnabled":false,"isLocked":false,"elementsMetadata":[],"slideId":"637629098780938070","enableDocumentContentUpdater":true,"version":"2.0"}]]></TemplafySlideTemplateConfiguration>
+</file>
+
+<file path=customXml/item18.xml><?xml version="1.0" encoding="utf-8"?>
+<TemplafySlideFormConfiguration><![CDATA[{"formFields":[],"formDataEntries":[]}]]></TemplafySlideFormConfiguration>
+</file>
+
+<file path=customXml/item19.xml><?xml version="1.0" encoding="utf-8"?>
+<p:properties xmlns:p="http://schemas.microsoft.com/office/2006/metadata/properties" xmlns:xsi="http://www.w3.org/2001/XMLSchema-instance" xmlns:pc="http://schemas.microsoft.com/office/infopath/2007/PartnerControls">
+  <documentManagement>
+    <_ip_UnifiedCompliancePolicyUIAction xmlns="http://schemas.microsoft.com/sharepoint/v3" xsi:nil="true"/>
+    <_ip_UnifiedCompliancePolicyProperties xmlns="http://schemas.microsoft.com/sharepoint/v3" xsi:nil="true"/>
+    <MediaServiceKeyPoints xmlns="e4aa919a-b200-49cb-beca-4c7e0810321e" xsi:nil="true"/>
+  </documentManagement>
+</p:properties>
+</file>
+
+<file path=customXml/item2.xml><?xml version="1.0" encoding="utf-8"?>
+<TemplafySlideTemplateConfiguration><![CDATA[{"slideVersion":1,"isValidatorEnabled":false,"isLocked":false,"elementsMetadata":[],"slideId":"637629098780808397","enableDocumentContentUpdater":true,"version":"2.0"}]]></TemplafySlideTemplateConfiguration>
+</file>
+
+<file path=customXml/item20.xml><?xml version="1.0" encoding="utf-8"?>
+<TemplafySlideTemplateConfiguration><![CDATA[{"slideVersion":1,"isValidatorEnabled":false,"isLocked":false,"elementsMetadata":[],"slideId":"637629098780868991","enableDocumentContentUpdater":true,"version":"2.0"}]]></TemplafySlideTemplateConfiguration>
+</file>
+
+<file path=customXml/item21.xml><?xml version="1.0" encoding="utf-8"?>
 <TemplafySlideTemplateConfiguration><![CDATA[{"slideVersion":1,"isValidatorEnabled":false,"isLocked":false,"elementsMetadata":[],"slideId":"637629098780882757","enableDocumentContentUpdater":true,"version":"2.0"}]]></TemplafySlideTemplateConfiguration>
 </file>
 
-<file path=customXml/item18.xml><?xml version="1.0" encoding="utf-8"?>
-<TemplafyTemplateConfiguration><![CDATA[{"elementsMetadata":[],"transformationConfigurations":[{"colorTheme":"{{DataSources.ColorThemes[\"Corporate\"].ColorTheme}}","disableUpdates":false,"type":"colorTheme"}],"enableDocumentContentUpdater":true,"version":"2.0"}]]></TemplafyTemplateConfiguration>
+<file path=customXml/item22.xml><?xml version="1.0" encoding="utf-8"?>
+<TemplafySlideTemplateConfiguration><![CDATA[{"slideVersion":1,"isValidatorEnabled":false,"isLocked":false,"elementsMetadata":[],"slideId":"637629098780931945","enableDocumentContentUpdater":true,"version":"2.0"}]]></TemplafySlideTemplateConfiguration>
 </file>
 
-<file path=customXml/item19.xml><?xml version="1.0" encoding="utf-8"?>
-<TemplafySlideTemplateConfiguration><![CDATA[{"slideVersion":1,"isValidatorEnabled":false,"isLocked":false,"elementsMetadata":[],"slideId":"637629098780944294","enableDocumentContentUpdater":true,"version":"2.0"}]]></TemplafySlideTemplateConfiguration>
+<file path=customXml/item23.xml><?xml version="1.0" encoding="utf-8"?>
+<TemplafySlideFormConfiguration><![CDATA[{"formFields":[],"formDataEntries":[]}]]></TemplafySlideFormConfiguration>
 </file>
 
-<file path=customXml/item2.xml><?xml version="1.0" encoding="utf-8"?>
-<TemplafySlideTemplateConfiguration><![CDATA[{"slideVersion":1,"isValidatorEnabled":false,"isLocked":false,"elementsMetadata":[],"slideId":"637629098780933985","enableDocumentContentUpdater":true,"version":"2.0"}]]></TemplafySlideTemplateConfiguration>
+<file path=customXml/item24.xml><?xml version="1.0" encoding="utf-8"?>
+<TemplafySlideTemplateConfiguration><![CDATA[{"slideVersion":1,"isValidatorEnabled":false,"isLocked":false,"elementsMetadata":[],"slideId":"637629098780810453","enableDocumentContentUpdater":true,"version":"2.0"}]]></TemplafySlideTemplateConfiguration>
 </file>
 
-<file path=customXml/item20.xml><?xml version="1.0" encoding="utf-8"?>
+<file path=customXml/item25.xml><?xml version="1.0" encoding="utf-8"?>
+<TemplafySlideTemplateConfiguration><![CDATA[{"slideVersion":1,"isValidatorEnabled":false,"isLocked":false,"elementsMetadata":[],"slideId":"637629098780812520","enableDocumentContentUpdater":true,"version":"2.0"}]]></TemplafySlideTemplateConfiguration>
+</file>
+
+<file path=customXml/item26.xml><?xml version="1.0" encoding="utf-8"?>
+<TemplafySlideTemplateConfiguration><![CDATA[{"slideVersion":1,"isValidatorEnabled":false,"isLocked":false,"elementsMetadata":[],"slideId":"637629098780815282","enableDocumentContentUpdater":true,"version":"2.0"}]]></TemplafySlideTemplateConfiguration>
+</file>
+
+<file path=customXml/item27.xml><?xml version="1.0" encoding="utf-8"?>
 <ct:contentTypeSchema xmlns:ct="http://schemas.microsoft.com/office/2006/metadata/contentType" xmlns:ma="http://schemas.microsoft.com/office/2006/metadata/properties/metaAttributes" ct:_="" ma:_="" ma:contentTypeName="Document" ma:contentTypeID="0x010100778A2EBC6E34694C80F43E94FCA993B5" ma:contentTypeVersion="14" ma:contentTypeDescription="Create a new document." ma:contentTypeScope="" ma:versionID="1a7ced39ac191f9ec8deffde533b0c1c">
   <xsd:schema xmlns:xsd="http://www.w3.org/2001/XMLSchema" xmlns:xs="http://www.w3.org/2001/XMLSchema" xmlns:p="http://schemas.microsoft.com/office/2006/metadata/properties" xmlns:ns1="http://schemas.microsoft.com/sharepoint/v3" xmlns:ns2="e4aa919a-b200-49cb-beca-4c7e0810321e" xmlns:ns3="06670dda-0291-4061-b6e0-f6c0cb392c51" targetNamespace="http://schemas.microsoft.com/office/2006/metadata/properties" ma:root="true" ma:fieldsID="bedea8c8816a4e5934c808becd103583" ns1:_="" ns2:_="" ns3:_="">
     <xsd:import namespace="http://schemas.microsoft.com/sharepoint/v3"/>
@@ -36466,36 +36532,8 @@
 </ct:contentTypeSchema>
 </file>
 
-<file path=customXml/item21.xml><?xml version="1.0" encoding="utf-8"?>
-<TemplafySlideTemplateConfiguration><![CDATA[{"slideVersion":1,"isValidatorEnabled":false,"isLocked":false,"elementsMetadata":[],"slideId":"637629098780855834","enableDocumentContentUpdater":true,"version":"2.0"}]]></TemplafySlideTemplateConfiguration>
-</file>
-
-<file path=customXml/item22.xml><?xml version="1.0" encoding="utf-8"?>
-<TemplafySlideTemplateConfiguration><![CDATA[{"slideVersion":1,"isValidatorEnabled":false,"isLocked":false,"elementsMetadata":[],"slideId":"637629098780891892","enableDocumentContentUpdater":true,"version":"2.0"}]]></TemplafySlideTemplateConfiguration>
-</file>
-
-<file path=customXml/item23.xml><?xml version="1.0" encoding="utf-8"?>
-<TemplafySlideFormConfiguration><![CDATA[{"formFields":[],"formDataEntries":[]}]]></TemplafySlideFormConfiguration>
-</file>
-
-<file path=customXml/item24.xml><?xml version="1.0" encoding="utf-8"?>
-<TemplafySlideTemplateConfiguration><![CDATA[{"slideVersion":1,"isValidatorEnabled":false,"isLocked":false,"elementsMetadata":[],"slideId":"637629098780805369","enableDocumentContentUpdater":true,"version":"2.0"}]]></TemplafySlideTemplateConfiguration>
-</file>
-
-<file path=customXml/item25.xml><?xml version="1.0" encoding="utf-8"?>
-<TemplafySlideTemplateConfiguration><![CDATA[{"slideVersion":1,"isValidatorEnabled":false,"isLocked":false,"elementsMetadata":[],"slideId":"637629098780931945","enableDocumentContentUpdater":true,"version":"2.0"}]]></TemplafySlideTemplateConfiguration>
-</file>
-
-<file path=customXml/item26.xml><?xml version="1.0" encoding="utf-8"?>
-<TemplafySlideFormConfiguration><![CDATA[{"formFields":[],"formDataEntries":[]}]]></TemplafySlideFormConfiguration>
-</file>
-
-<file path=customXml/item27.xml><?xml version="1.0" encoding="utf-8"?>
-<TemplafySlideFormConfiguration><![CDATA[{"formFields":[],"formDataEntries":[]}]]></TemplafySlideFormConfiguration>
-</file>
-
 <file path=customXml/item28.xml><?xml version="1.0" encoding="utf-8"?>
-<TemplafySlideFormConfiguration><![CDATA[{"formFields":[],"formDataEntries":[]}]]></TemplafySlideFormConfiguration>
+<TemplafySlideTemplateConfiguration><![CDATA[{"slideVersion":1,"isValidatorEnabled":false,"isLocked":false,"elementsMetadata":[],"slideId":"637629098780935963","enableDocumentContentUpdater":true,"version":"2.0"}]]></TemplafySlideTemplateConfiguration>
 </file>
 
 <file path=customXml/item29.xml><?xml version="1.0" encoding="utf-8"?>
@@ -36503,25 +36541,19 @@
 </file>
 
 <file path=customXml/item3.xml><?xml version="1.0" encoding="utf-8"?>
-<p:properties xmlns:p="http://schemas.microsoft.com/office/2006/metadata/properties" xmlns:xsi="http://www.w3.org/2001/XMLSchema-instance" xmlns:pc="http://schemas.microsoft.com/office/infopath/2007/PartnerControls">
-  <documentManagement>
-    <_ip_UnifiedCompliancePolicyUIAction xmlns="http://schemas.microsoft.com/sharepoint/v3" xsi:nil="true"/>
-    <_ip_UnifiedCompliancePolicyProperties xmlns="http://schemas.microsoft.com/sharepoint/v3" xsi:nil="true"/>
-    <MediaServiceKeyPoints xmlns="e4aa919a-b200-49cb-beca-4c7e0810321e" xsi:nil="true"/>
-  </documentManagement>
-</p:properties>
+<TemplafySlideTemplateConfiguration><![CDATA[{"slideVersion":1,"isValidatorEnabled":false,"isLocked":false,"elementsMetadata":[],"slideId":"637629098780863185","enableDocumentContentUpdater":true,"version":"2.0"}]]></TemplafySlideTemplateConfiguration>
 </file>
 
 <file path=customXml/item30.xml><?xml version="1.0" encoding="utf-8"?>
+<TemplafySlideTemplateConfiguration><![CDATA[{"slideVersion":1,"isValidatorEnabled":false,"isLocked":false,"elementsMetadata":[],"slideId":"637629098780818133","enableDocumentContentUpdater":true,"version":"2.0"}]]></TemplafySlideTemplateConfiguration>
+</file>
+
+<file path=customXml/item31.xml><?xml version="1.0" encoding="utf-8"?>
 <TemplafySlideFormConfiguration><![CDATA[{"formFields":[],"formDataEntries":[]}]]></TemplafySlideFormConfiguration>
 </file>
 
-<file path=customXml/item31.xml><?xml version="1.0" encoding="utf-8"?>
-<TemplafySlideTemplateConfiguration><![CDATA[{"slideVersion":1,"isValidatorEnabled":false,"isLocked":false,"elementsMetadata":[],"slideId":"637629098780874432","enableDocumentContentUpdater":true,"version":"2.0"}]]></TemplafySlideTemplateConfiguration>
-</file>
-
 <file path=customXml/item32.xml><?xml version="1.0" encoding="utf-8"?>
-<TemplafySlideTemplateConfiguration><![CDATA[{"slideVersion":1,"isValidatorEnabled":false,"isLocked":false,"elementsMetadata":[],"slideId":"637629098780863185","enableDocumentContentUpdater":true,"version":"2.0"}]]></TemplafySlideTemplateConfiguration>
+<TemplafySlideTemplateConfiguration><![CDATA[{"slideVersion":1,"isValidatorEnabled":false,"isLocked":false,"elementsMetadata":[],"slideId":"637629098780820470","enableDocumentContentUpdater":true,"version":"2.0"}]]></TemplafySlideTemplateConfiguration>
 </file>
 
 <file path=customXml/item33.xml><?xml version="1.0" encoding="utf-8"?>
@@ -36533,11 +36565,11 @@
 </file>
 
 <file path=customXml/item35.xml><?xml version="1.0" encoding="utf-8"?>
-<TemplafySlideTemplateConfiguration><![CDATA[{"slideVersion":1,"isValidatorEnabled":false,"isLocked":false,"elementsMetadata":[],"slideId":"637629098780861368","enableDocumentContentUpdater":true,"version":"2.0"}]]></TemplafySlideTemplateConfiguration>
+<TemplafySlideFormConfiguration><![CDATA[{"formFields":[],"formDataEntries":[]}]]></TemplafySlideFormConfiguration>
 </file>
 
 <file path=customXml/item36.xml><?xml version="1.0" encoding="utf-8"?>
-<TemplafySlideFormConfiguration><![CDATA[{"formFields":[],"formDataEntries":[]}]]></TemplafySlideFormConfiguration>
+<TemplafySlideTemplateConfiguration><![CDATA[{"slideVersion":1,"isValidatorEnabled":false,"isLocked":false,"elementsMetadata":[],"slideId":"637629098780929168","enableDocumentContentUpdater":true,"version":"2.0"}]]></TemplafySlideTemplateConfiguration>
 </file>
 
 <file path=customXml/item37.xml><?xml version="1.0" encoding="utf-8"?>
@@ -36545,23 +36577,23 @@
 </file>
 
 <file path=customXml/item38.xml><?xml version="1.0" encoding="utf-8"?>
-<TemplafySlideTemplateConfiguration><![CDATA[{"slideVersion":1,"isValidatorEnabled":false,"isLocked":false,"elementsMetadata":[],"slideId":"637629098780810453","enableDocumentContentUpdater":true,"version":"2.0"}]]></TemplafySlideTemplateConfiguration>
+<TemplafySlideFormConfiguration><![CDATA[{"formFields":[],"formDataEntries":[]}]]></TemplafySlideFormConfiguration>
 </file>
 
 <file path=customXml/item39.xml><?xml version="1.0" encoding="utf-8"?>
-<TemplafySlideTemplateConfiguration><![CDATA[{"slideVersion":1,"isValidatorEnabled":false,"isLocked":false,"elementsMetadata":[],"slideId":"637629098780802172","enableDocumentContentUpdater":true,"version":"2.0"}]]></TemplafySlideTemplateConfiguration>
+<TemplafySlideTemplateConfiguration><![CDATA[{"slideVersion":1,"isValidatorEnabled":false,"isLocked":false,"elementsMetadata":[],"slideId":"637629098780874432","enableDocumentContentUpdater":true,"version":"2.0"}]]></TemplafySlideTemplateConfiguration>
 </file>
 
 <file path=customXml/item4.xml><?xml version="1.0" encoding="utf-8"?>
-<TemplafySlideTemplateConfiguration><![CDATA[{"slideVersion":1,"isValidatorEnabled":false,"isLocked":false,"elementsMetadata":[],"slideId":"637629098780864969","enableDocumentContentUpdater":true,"version":"2.0"}]]></TemplafySlideTemplateConfiguration>
+<TemplafySlideFormConfiguration><![CDATA[{"formFields":[],"formDataEntries":[]}]]></TemplafySlideFormConfiguration>
 </file>
 
 <file path=customXml/item40.xml><?xml version="1.0" encoding="utf-8"?>
-<TemplafyFormConfiguration><![CDATA[{"formFields":[{"required":false,"placeholder":"Title | Date | Security Setting","lines":1,"shareValue":false,"type":"textBox","name":"Footer","label":"Enter footer description","fullyQualifiedName":"Footer"}],"formDataEntries":[]}]]></TemplafyFormConfiguration>
+<TemplafySlideTemplateConfiguration><![CDATA[{"slideVersion":1,"isValidatorEnabled":false,"isLocked":false,"elementsMetadata":[],"slideId":"637629098780819298","enableDocumentContentUpdater":true,"version":"2.0"}]]></TemplafySlideTemplateConfiguration>
 </file>
 
 <file path=customXml/item41.xml><?xml version="1.0" encoding="utf-8"?>
-<TemplafySlideTemplateConfiguration><![CDATA[{"slideVersion":1,"isValidatorEnabled":false,"isLocked":false,"elementsMetadata":[],"slideId":"637629098780935963","enableDocumentContentUpdater":true,"version":"2.0"}]]></TemplafySlideTemplateConfiguration>
+<TemplafySlideTemplateConfiguration><![CDATA[{"slideVersion":1,"isValidatorEnabled":false,"isLocked":false,"elementsMetadata":[],"slideId":"637629098780898812","enableDocumentContentUpdater":true,"version":"2.0"}]]></TemplafySlideTemplateConfiguration>
 </file>
 
 <file path=customXml/item42.xml><?xml version="1.0" encoding="utf-8"?>
@@ -36569,23 +36601,23 @@
 </file>
 
 <file path=customXml/item43.xml><?xml version="1.0" encoding="utf-8"?>
+<TemplafySlideTemplateConfiguration><![CDATA[{"slideVersion":1,"isValidatorEnabled":false,"isLocked":false,"elementsMetadata":[],"slideId":"637629098780864969","enableDocumentContentUpdater":true,"version":"2.0"}]]></TemplafySlideTemplateConfiguration>
+</file>
+
+<file path=customXml/item44.xml><?xml version="1.0" encoding="utf-8"?>
+<TemplafySlideTemplateConfiguration><![CDATA[{"slideVersion":1,"isValidatorEnabled":false,"isLocked":false,"elementsMetadata":[],"slideId":"637629098780858672","enableDocumentContentUpdater":true,"version":"2.0"}]]></TemplafySlideTemplateConfiguration>
+</file>
+
+<file path=customXml/item45.xml><?xml version="1.0" encoding="utf-8"?>
 <TemplafySlideFormConfiguration><![CDATA[{"formFields":[],"formDataEntries":[]}]]></TemplafySlideFormConfiguration>
 </file>
 
-<file path=customXml/item44.xml><?xml version="1.0" encoding="utf-8"?>
-<TemplafySlideTemplateConfiguration><![CDATA[{"slideVersion":1,"isValidatorEnabled":false,"isLocked":false,"elementsMetadata":[],"slideId":"637629098780819298","enableDocumentContentUpdater":true,"version":"2.0"}]]></TemplafySlideTemplateConfiguration>
-</file>
-
-<file path=customXml/item45.xml><?xml version="1.0" encoding="utf-8"?>
-<TemplafySlideTemplateConfiguration><![CDATA[{"slideVersion":1,"isValidatorEnabled":false,"isLocked":false,"elementsMetadata":[],"slideId":"637629098780940360","enableDocumentContentUpdater":true,"version":"2.0"}]]></TemplafySlideTemplateConfiguration>
-</file>
-
 <file path=customXml/item46.xml><?xml version="1.0" encoding="utf-8"?>
-<TemplafySlideTemplateConfiguration><![CDATA[{"slideVersion":1,"isValidatorEnabled":false,"isLocked":false,"elementsMetadata":[],"slideId":"637629098780812520","enableDocumentContentUpdater":true,"version":"2.0"}]]></TemplafySlideTemplateConfiguration>
+<TemplafyTemplateConfiguration><![CDATA[{"elementsMetadata":[],"transformationConfigurations":[{"colorTheme":"{{DataSources.ColorThemes[\"Corporate\"].ColorTheme}}","disableUpdates":false,"type":"colorTheme"}],"enableDocumentContentUpdater":true,"version":"2.0"}]]></TemplafyTemplateConfiguration>
 </file>
 
 <file path=customXml/item47.xml><?xml version="1.0" encoding="utf-8"?>
-<TemplafySlideFormConfiguration><![CDATA[{"formFields":[],"formDataEntries":[]}]]></TemplafySlideFormConfiguration>
+<TemplafySlideTemplateConfiguration><![CDATA[{"slideVersion":1,"isValidatorEnabled":false,"isLocked":false,"elementsMetadata":[],"slideId":"637629098780802172","enableDocumentContentUpdater":true,"version":"2.0"}]]></TemplafySlideTemplateConfiguration>
 </file>
 
 <file path=customXml/item48.xml><?xml version="1.0" encoding="utf-8"?>
@@ -36593,7 +36625,7 @@
 </file>
 
 <file path=customXml/item49.xml><?xml version="1.0" encoding="utf-8"?>
-<TemplafySlideTemplateConfiguration><![CDATA[{"slideVersion":1,"isValidatorEnabled":false,"isLocked":false,"elementsMetadata":[],"slideId":"637629098780929168","enableDocumentContentUpdater":true,"version":"2.0"}]]></TemplafySlideTemplateConfiguration>
+<TemplafySlideTemplateConfiguration><![CDATA[{"slideVersion":1,"isValidatorEnabled":false,"isLocked":false,"elementsMetadata":[],"slideId":"637629098780942318","enableDocumentContentUpdater":true,"version":"2.0"}]]></TemplafySlideTemplateConfiguration>
 </file>
 
 <file path=customXml/item5.xml><?xml version="1.0" encoding="utf-8"?>
@@ -36601,26 +36633,6 @@
 </file>
 
 <file path=customXml/item50.xml><?xml version="1.0" encoding="utf-8"?>
-<TemplafySlideTemplateConfiguration><![CDATA[{"slideVersion":1,"isValidatorEnabled":false,"isLocked":false,"elementsMetadata":[],"slideId":"637629098780942318","enableDocumentContentUpdater":true,"version":"2.0"}]]></TemplafySlideTemplateConfiguration>
-</file>
-
-<file path=customXml/item51.xml><?xml version="1.0" encoding="utf-8"?>
-<TemplafySlideFormConfiguration><![CDATA[{"formFields":[],"formDataEntries":[]}]]></TemplafySlideFormConfiguration>
-</file>
-
-<file path=customXml/item52.xml><?xml version="1.0" encoding="utf-8"?>
-<TemplafySlideTemplateConfiguration><![CDATA[{"slideVersion":1,"isValidatorEnabled":false,"isLocked":false,"elementsMetadata":[],"slideId":"637629098780898812","enableDocumentContentUpdater":true,"version":"2.0"}]]></TemplafySlideTemplateConfiguration>
-</file>
-
-<file path=customXml/item53.xml><?xml version="1.0" encoding="utf-8"?>
-<TemplafySlideFormConfiguration><![CDATA[{"formFields":[],"formDataEntries":[]}]]></TemplafySlideFormConfiguration>
-</file>
-
-<file path=customXml/item54.xml><?xml version="1.0" encoding="utf-8"?>
-<TemplafySlideFormConfiguration><![CDATA[{"formFields":[],"formDataEntries":[]}]]></TemplafySlideFormConfiguration>
-</file>
-
-<file path=customXml/item55.xml><?xml version="1.0" encoding="utf-8"?>
 <?mso-contentType ?>
 <FormTemplates xmlns="http://schemas.microsoft.com/sharepoint/v3/contenttype/forms">
   <Display>DocumentLibraryForm</Display>
@@ -36629,8 +36641,28 @@
 </FormTemplates>
 </file>
 
+<file path=customXml/item51.xml><?xml version="1.0" encoding="utf-8"?>
+<TemplafySlideFormConfiguration><![CDATA[{"formFields":[],"formDataEntries":[]}]]></TemplafySlideFormConfiguration>
+</file>
+
+<file path=customXml/item52.xml><?xml version="1.0" encoding="utf-8"?>
+<TemplafySlideTemplateConfiguration><![CDATA[{"slideVersion":1,"isValidatorEnabled":false,"isLocked":false,"elementsMetadata":[],"slideId":"637629098780933985","enableDocumentContentUpdater":true,"version":"2.0"}]]></TemplafySlideTemplateConfiguration>
+</file>
+
+<file path=customXml/item53.xml><?xml version="1.0" encoding="utf-8"?>
+<TemplafySlideFormConfiguration><![CDATA[{"formFields":[],"formDataEntries":[]}]]></TemplafySlideFormConfiguration>
+</file>
+
+<file path=customXml/item54.xml><?xml version="1.0" encoding="utf-8"?>
+<TemplafySlideTemplateConfiguration><![CDATA[{"slideVersion":1,"isValidatorEnabled":false,"isLocked":false,"elementsMetadata":[],"slideId":"637629098780805369","enableDocumentContentUpdater":true,"version":"2.0"}]]></TemplafySlideTemplateConfiguration>
+</file>
+
+<file path=customXml/item55.xml><?xml version="1.0" encoding="utf-8"?>
+<TemplafyFormConfiguration><![CDATA[{"formFields":[{"required":false,"placeholder":"Title | Date | Security Setting","lines":1,"shareValue":false,"type":"textBox","name":"Footer","label":"Enter footer description","fullyQualifiedName":"Footer"}],"formDataEntries":[]}]]></TemplafyFormConfiguration>
+</file>
+
 <file path=customXml/item56.xml><?xml version="1.0" encoding="utf-8"?>
-<TemplafySlideFormConfiguration><![CDATA[{"formFields":[],"formDataEntries":[]}]]></TemplafySlideFormConfiguration>
+<TemplafySlideTemplateConfiguration><![CDATA[{"slideVersion":1,"isValidatorEnabled":false,"isLocked":false,"elementsMetadata":[],"slideId":"637629098780940360","enableDocumentContentUpdater":true,"version":"2.0"}]]></TemplafySlideTemplateConfiguration>
 </file>
 
 <file path=customXml/item57.xml><?xml version="1.0" encoding="utf-8"?>
@@ -36642,7 +36674,7 @@
 </file>
 
 <file path=customXml/item59.xml><?xml version="1.0" encoding="utf-8"?>
-<TemplafySlideTemplateConfiguration><![CDATA[{"slideVersion":1,"isValidatorEnabled":false,"isLocked":false,"elementsMetadata":[],"slideId":"637629098780815282","enableDocumentContentUpdater":true,"version":"2.0"}]]></TemplafySlideTemplateConfiguration>
+<TemplafySlideTemplateConfiguration><![CDATA[{"slideVersion":1,"isValidatorEnabled":false,"isLocked":false,"elementsMetadata":[],"slideId":"637629098780855834","enableDocumentContentUpdater":true,"version":"2.0"}]]></TemplafySlideTemplateConfiguration>
 </file>
 
 <file path=customXml/item6.xml><?xml version="1.0" encoding="utf-8"?>
@@ -36662,86 +36694,140 @@
 </file>
 
 <file path=customXml/item8.xml><?xml version="1.0" encoding="utf-8"?>
-<TemplafySlideTemplateConfiguration><![CDATA[{"slideVersion":1,"isValidatorEnabled":false,"isLocked":false,"elementsMetadata":[],"slideId":"637629098780938070","enableDocumentContentUpdater":true,"version":"2.0"}]]></TemplafySlideTemplateConfiguration>
+<TemplafySlideTemplateConfiguration><![CDATA[{"slideVersion":1,"isValidatorEnabled":false,"isLocked":false,"elementsMetadata":[],"slideId":"637629098780944294","enableDocumentContentUpdater":true,"version":"2.0"}]]></TemplafySlideTemplateConfiguration>
 </file>
 
 <file path=customXml/item9.xml><?xml version="1.0" encoding="utf-8"?>
-<TemplafySlideTemplateConfiguration><![CDATA[{"slideVersion":1,"isValidatorEnabled":false,"isLocked":false,"elementsMetadata":[],"slideId":"637629098780858672","enableDocumentContentUpdater":true,"version":"2.0"}]]></TemplafySlideTemplateConfiguration>
+<TemplafySlideTemplateConfiguration><![CDATA[{"slideVersion":1,"isValidatorEnabled":false,"isLocked":false,"elementsMetadata":[],"slideId":"637629098780938389","enableDocumentContentUpdater":true,"version":"2.0"}]]></TemplafySlideTemplateConfiguration>
 </file>
 
 <file path=customXml/itemProps1.xml><?xml version="1.0" encoding="utf-8"?>
-<ds:datastoreItem xmlns:ds="http://schemas.openxmlformats.org/officeDocument/2006/customXml" ds:itemID="{6B831CAE-95E4-452E-B3C5-B76AAD78A52A}">
+<ds:datastoreItem xmlns:ds="http://schemas.openxmlformats.org/officeDocument/2006/customXml" ds:itemID="{7C5C44AF-FBA1-4FF3-8C07-71728D2581FD}">
   <ds:schemaRefs/>
 </ds:datastoreItem>
 </file>
 
 <file path=customXml/itemProps10.xml><?xml version="1.0" encoding="utf-8"?>
-<ds:datastoreItem xmlns:ds="http://schemas.openxmlformats.org/officeDocument/2006/customXml" ds:itemID="{9DF1E77E-93BB-43A3-BEC8-6478C2794FA6}">
+<ds:datastoreItem xmlns:ds="http://schemas.openxmlformats.org/officeDocument/2006/customXml" ds:itemID="{FC77B9F3-C094-489B-8C01-F272F0AF68C6}">
   <ds:schemaRefs/>
 </ds:datastoreItem>
 </file>
 
 <file path=customXml/itemProps11.xml><?xml version="1.0" encoding="utf-8"?>
+<ds:datastoreItem xmlns:ds="http://schemas.openxmlformats.org/officeDocument/2006/customXml" ds:itemID="{6A0018E2-8AA5-4CE6-A43B-7E69D37BB663}">
+  <ds:schemaRefs/>
+</ds:datastoreItem>
+</file>
+
+<file path=customXml/itemProps12.xml><?xml version="1.0" encoding="utf-8"?>
+<ds:datastoreItem xmlns:ds="http://schemas.openxmlformats.org/officeDocument/2006/customXml" ds:itemID="{682BF6E6-8993-4A0E-A615-E24230C37DAC}">
+  <ds:schemaRefs/>
+</ds:datastoreItem>
+</file>
+
+<file path=customXml/itemProps13.xml><?xml version="1.0" encoding="utf-8"?>
+<ds:datastoreItem xmlns:ds="http://schemas.openxmlformats.org/officeDocument/2006/customXml" ds:itemID="{921C0A0B-EE13-4908-9C41-3E7EDF526068}">
+  <ds:schemaRefs/>
+</ds:datastoreItem>
+</file>
+
+<file path=customXml/itemProps14.xml><?xml version="1.0" encoding="utf-8"?>
+<ds:datastoreItem xmlns:ds="http://schemas.openxmlformats.org/officeDocument/2006/customXml" ds:itemID="{C5DD1971-334A-45E9-9D2B-FB6BD8AAE58A}">
+  <ds:schemaRefs/>
+</ds:datastoreItem>
+</file>
+
+<file path=customXml/itemProps15.xml><?xml version="1.0" encoding="utf-8"?>
+<ds:datastoreItem xmlns:ds="http://schemas.openxmlformats.org/officeDocument/2006/customXml" ds:itemID="{162E1B2B-387B-423C-8FB0-129D0EE7DD83}">
+  <ds:schemaRefs/>
+</ds:datastoreItem>
+</file>
+
+<file path=customXml/itemProps16.xml><?xml version="1.0" encoding="utf-8"?>
+<ds:datastoreItem xmlns:ds="http://schemas.openxmlformats.org/officeDocument/2006/customXml" ds:itemID="{D5DFDA8F-B725-4CD6-A843-7349EA123794}">
+  <ds:schemaRefs/>
+</ds:datastoreItem>
+</file>
+
+<file path=customXml/itemProps17.xml><?xml version="1.0" encoding="utf-8"?>
+<ds:datastoreItem xmlns:ds="http://schemas.openxmlformats.org/officeDocument/2006/customXml" ds:itemID="{3915BD4A-04C4-49F2-B0B9-3E7D336EC799}">
+  <ds:schemaRefs/>
+</ds:datastoreItem>
+</file>
+
+<file path=customXml/itemProps18.xml><?xml version="1.0" encoding="utf-8"?>
+<ds:datastoreItem xmlns:ds="http://schemas.openxmlformats.org/officeDocument/2006/customXml" ds:itemID="{D4B66AC3-71C4-4908-9595-93E8B8D76E97}">
+  <ds:schemaRefs/>
+</ds:datastoreItem>
+</file>
+
+<file path=customXml/itemProps19.xml><?xml version="1.0" encoding="utf-8"?>
+<ds:datastoreItem xmlns:ds="http://schemas.openxmlformats.org/officeDocument/2006/customXml" ds:itemID="{F990F116-B58F-4255-B05B-DA3808E0E5C6}">
+  <ds:schemaRefs>
+    <ds:schemaRef ds:uri="http://schemas.openxmlformats.org/package/2006/metadata/core-properties"/>
+    <ds:schemaRef ds:uri="http://purl.org/dc/elements/1.1/"/>
+    <ds:schemaRef ds:uri="http://purl.org/dc/dcmitype/"/>
+    <ds:schemaRef ds:uri="http://www.w3.org/XML/1998/namespace"/>
+    <ds:schemaRef ds:uri="http://purl.org/dc/terms/"/>
+    <ds:schemaRef ds:uri="e4aa919a-b200-49cb-beca-4c7e0810321e"/>
+    <ds:schemaRef ds:uri="http://schemas.microsoft.com/office/2006/documentManagement/types"/>
+    <ds:schemaRef ds:uri="http://schemas.microsoft.com/office/2006/metadata/properties"/>
+    <ds:schemaRef ds:uri="http://schemas.microsoft.com/office/infopath/2007/PartnerControls"/>
+    <ds:schemaRef ds:uri="06670dda-0291-4061-b6e0-f6c0cb392c51"/>
+    <ds:schemaRef ds:uri="http://schemas.microsoft.com/sharepoint/v3"/>
+  </ds:schemaRefs>
+</ds:datastoreItem>
+</file>
+
+<file path=customXml/itemProps2.xml><?xml version="1.0" encoding="utf-8"?>
 <ds:datastoreItem xmlns:ds="http://schemas.openxmlformats.org/officeDocument/2006/customXml" ds:itemID="{1BCEDA00-0BCE-4F19-A380-8AED6A66E762}">
   <ds:schemaRefs/>
 </ds:datastoreItem>
 </file>
 
-<file path=customXml/itemProps12.xml><?xml version="1.0" encoding="utf-8"?>
+<file path=customXml/itemProps20.xml><?xml version="1.0" encoding="utf-8"?>
 <ds:datastoreItem xmlns:ds="http://schemas.openxmlformats.org/officeDocument/2006/customXml" ds:itemID="{AC107CF9-7144-4997-BE7D-1990BE189C9A}">
   <ds:schemaRefs/>
 </ds:datastoreItem>
 </file>
 
-<file path=customXml/itemProps13.xml><?xml version="1.0" encoding="utf-8"?>
-<ds:datastoreItem xmlns:ds="http://schemas.openxmlformats.org/officeDocument/2006/customXml" ds:itemID="{DDCC6A1B-7673-40E9-AC3E-C0D8F2784A83}">
-  <ds:schemaRefs/>
-</ds:datastoreItem>
-</file>
-
-<file path=customXml/itemProps14.xml><?xml version="1.0" encoding="utf-8"?>
-<ds:datastoreItem xmlns:ds="http://schemas.openxmlformats.org/officeDocument/2006/customXml" ds:itemID="{A20E27A4-6C3C-428D-ADE7-7DC089C0CD46}">
-  <ds:schemaRefs/>
-</ds:datastoreItem>
-</file>
-
-<file path=customXml/itemProps15.xml><?xml version="1.0" encoding="utf-8"?>
-<ds:datastoreItem xmlns:ds="http://schemas.openxmlformats.org/officeDocument/2006/customXml" ds:itemID="{00BD3ED4-8ED9-4359-B43B-2C197BC490D9}">
-  <ds:schemaRefs/>
-</ds:datastoreItem>
-</file>
-
-<file path=customXml/itemProps16.xml><?xml version="1.0" encoding="utf-8"?>
-<ds:datastoreItem xmlns:ds="http://schemas.openxmlformats.org/officeDocument/2006/customXml" ds:itemID="{7C5C44AF-FBA1-4FF3-8C07-71728D2581FD}">
-  <ds:schemaRefs/>
-</ds:datastoreItem>
-</file>
-
-<file path=customXml/itemProps17.xml><?xml version="1.0" encoding="utf-8"?>
+<file path=customXml/itemProps21.xml><?xml version="1.0" encoding="utf-8"?>
 <ds:datastoreItem xmlns:ds="http://schemas.openxmlformats.org/officeDocument/2006/customXml" ds:itemID="{5265E46D-0749-47B1-8243-3C63764C0EFC}">
   <ds:schemaRefs/>
 </ds:datastoreItem>
 </file>
 
-<file path=customXml/itemProps18.xml><?xml version="1.0" encoding="utf-8"?>
-<ds:datastoreItem xmlns:ds="http://schemas.openxmlformats.org/officeDocument/2006/customXml" ds:itemID="{6291F803-2EF0-4E47-96D6-4796950CE6BD}">
+<file path=customXml/itemProps22.xml><?xml version="1.0" encoding="utf-8"?>
+<ds:datastoreItem xmlns:ds="http://schemas.openxmlformats.org/officeDocument/2006/customXml" ds:itemID="{CAFED163-E143-4EEB-A735-81C1226AD9B4}">
   <ds:schemaRefs/>
 </ds:datastoreItem>
 </file>
 
-<file path=customXml/itemProps19.xml><?xml version="1.0" encoding="utf-8"?>
-<ds:datastoreItem xmlns:ds="http://schemas.openxmlformats.org/officeDocument/2006/customXml" ds:itemID="{1AB4A281-5EBA-4CA1-A536-6B29C98890B6}">
+<file path=customXml/itemProps23.xml><?xml version="1.0" encoding="utf-8"?>
+<ds:datastoreItem xmlns:ds="http://schemas.openxmlformats.org/officeDocument/2006/customXml" ds:itemID="{65B44A9F-1851-42AC-AD3C-FFC343A07D3A}">
   <ds:schemaRefs/>
 </ds:datastoreItem>
 </file>
 
-<file path=customXml/itemProps2.xml><?xml version="1.0" encoding="utf-8"?>
-<ds:datastoreItem xmlns:ds="http://schemas.openxmlformats.org/officeDocument/2006/customXml" ds:itemID="{364650BF-04B4-4ADF-AE61-286BFE5AF2AD}">
+<file path=customXml/itemProps24.xml><?xml version="1.0" encoding="utf-8"?>
+<ds:datastoreItem xmlns:ds="http://schemas.openxmlformats.org/officeDocument/2006/customXml" ds:itemID="{915452D2-9D6B-41D9-99FD-4D1CF211FA39}">
   <ds:schemaRefs/>
 </ds:datastoreItem>
 </file>
 
-<file path=customXml/itemProps20.xml><?xml version="1.0" encoding="utf-8"?>
+<file path=customXml/itemProps25.xml><?xml version="1.0" encoding="utf-8"?>
+<ds:datastoreItem xmlns:ds="http://schemas.openxmlformats.org/officeDocument/2006/customXml" ds:itemID="{EC53C6C7-14A0-4237-9C9A-FA78B37E53AB}">
+  <ds:schemaRefs/>
+</ds:datastoreItem>
+</file>
+
+<file path=customXml/itemProps26.xml><?xml version="1.0" encoding="utf-8"?>
+<ds:datastoreItem xmlns:ds="http://schemas.openxmlformats.org/officeDocument/2006/customXml" ds:itemID="{E4C8E36C-E4C3-4DF8-B9A8-546312449852}">
+  <ds:schemaRefs/>
+</ds:datastoreItem>
+</file>
+
+<file path=customXml/itemProps27.xml><?xml version="1.0" encoding="utf-8"?>
 <ds:datastoreItem xmlns:ds="http://schemas.openxmlformats.org/officeDocument/2006/customXml" ds:itemID="{0BB3C309-8520-4616-80FC-2CB10D5B83A0}">
   <ds:schemaRefs>
     <ds:schemaRef ds:uri="http://schemas.microsoft.com/office/2006/metadata/contentType"/>
@@ -36761,241 +36847,157 @@
 </ds:datastoreItem>
 </file>
 
-<file path=customXml/itemProps21.xml><?xml version="1.0" encoding="utf-8"?>
-<ds:datastoreItem xmlns:ds="http://schemas.openxmlformats.org/officeDocument/2006/customXml" ds:itemID="{1669606D-CDD4-43E6-985A-81776140D176}">
+<file path=customXml/itemProps28.xml><?xml version="1.0" encoding="utf-8"?>
+<ds:datastoreItem xmlns:ds="http://schemas.openxmlformats.org/officeDocument/2006/customXml" ds:itemID="{1D3A887C-FC1C-482E-BE66-F9B66B0A6227}">
   <ds:schemaRefs/>
 </ds:datastoreItem>
 </file>
 
-<file path=customXml/itemProps22.xml><?xml version="1.0" encoding="utf-8"?>
-<ds:datastoreItem xmlns:ds="http://schemas.openxmlformats.org/officeDocument/2006/customXml" ds:itemID="{FC77B9F3-C094-489B-8C01-F272F0AF68C6}">
+<file path=customXml/itemProps29.xml><?xml version="1.0" encoding="utf-8"?>
+<ds:datastoreItem xmlns:ds="http://schemas.openxmlformats.org/officeDocument/2006/customXml" ds:itemID="{00121D97-98F5-4946-8A5D-87D090F11338}">
   <ds:schemaRefs/>
 </ds:datastoreItem>
 </file>
 
-<file path=customXml/itemProps23.xml><?xml version="1.0" encoding="utf-8"?>
+<file path=customXml/itemProps3.xml><?xml version="1.0" encoding="utf-8"?>
+<ds:datastoreItem xmlns:ds="http://schemas.openxmlformats.org/officeDocument/2006/customXml" ds:itemID="{7FD631D3-3AB7-43F0-9FCE-6F65E4127A72}">
+  <ds:schemaRefs/>
+</ds:datastoreItem>
+</file>
+
+<file path=customXml/itemProps30.xml><?xml version="1.0" encoding="utf-8"?>
+<ds:datastoreItem xmlns:ds="http://schemas.openxmlformats.org/officeDocument/2006/customXml" ds:itemID="{6B831CAE-95E4-452E-B3C5-B76AAD78A52A}">
+  <ds:schemaRefs/>
+</ds:datastoreItem>
+</file>
+
+<file path=customXml/itemProps31.xml><?xml version="1.0" encoding="utf-8"?>
+<ds:datastoreItem xmlns:ds="http://schemas.openxmlformats.org/officeDocument/2006/customXml" ds:itemID="{C67D3CDE-4F82-4339-9EA4-1EEE33A61958}">
+  <ds:schemaRefs/>
+</ds:datastoreItem>
+</file>
+
+<file path=customXml/itemProps32.xml><?xml version="1.0" encoding="utf-8"?>
+<ds:datastoreItem xmlns:ds="http://schemas.openxmlformats.org/officeDocument/2006/customXml" ds:itemID="{00BD3ED4-8ED9-4359-B43B-2C197BC490D9}">
+  <ds:schemaRefs/>
+</ds:datastoreItem>
+</file>
+
+<file path=customXml/itemProps33.xml><?xml version="1.0" encoding="utf-8"?>
 <ds:datastoreItem xmlns:ds="http://schemas.openxmlformats.org/officeDocument/2006/customXml" ds:itemID="{CBB24767-B696-4303-95AD-C1F5811D028F}">
   <ds:schemaRefs/>
 </ds:datastoreItem>
 </file>
 
-<file path=customXml/itemProps24.xml><?xml version="1.0" encoding="utf-8"?>
-<ds:datastoreItem xmlns:ds="http://schemas.openxmlformats.org/officeDocument/2006/customXml" ds:itemID="{95AE8F77-448C-4B7C-8669-DC6D4241F9CE}">
-  <ds:schemaRefs/>
-</ds:datastoreItem>
-</file>
-
-<file path=customXml/itemProps25.xml><?xml version="1.0" encoding="utf-8"?>
-<ds:datastoreItem xmlns:ds="http://schemas.openxmlformats.org/officeDocument/2006/customXml" ds:itemID="{CAFED163-E143-4EEB-A735-81C1226AD9B4}">
-  <ds:schemaRefs/>
-</ds:datastoreItem>
-</file>
-
-<file path=customXml/itemProps26.xml><?xml version="1.0" encoding="utf-8"?>
-<ds:datastoreItem xmlns:ds="http://schemas.openxmlformats.org/officeDocument/2006/customXml" ds:itemID="{33C2836D-CD36-48F0-AE3F-D27BFE792AB7}">
-  <ds:schemaRefs/>
-</ds:datastoreItem>
-</file>
-
-<file path=customXml/itemProps27.xml><?xml version="1.0" encoding="utf-8"?>
-<ds:datastoreItem xmlns:ds="http://schemas.openxmlformats.org/officeDocument/2006/customXml" ds:itemID="{6A0018E2-8AA5-4CE6-A43B-7E69D37BB663}">
-  <ds:schemaRefs/>
-</ds:datastoreItem>
-</file>
-
-<file path=customXml/itemProps28.xml><?xml version="1.0" encoding="utf-8"?>
+<file path=customXml/itemProps34.xml><?xml version="1.0" encoding="utf-8"?>
 <ds:datastoreItem xmlns:ds="http://schemas.openxmlformats.org/officeDocument/2006/customXml" ds:itemID="{F82E9EAE-C942-4F71-8479-8192B35558E2}">
   <ds:schemaRefs/>
 </ds:datastoreItem>
 </file>
 
-<file path=customXml/itemProps29.xml><?xml version="1.0" encoding="utf-8"?>
-<ds:datastoreItem xmlns:ds="http://schemas.openxmlformats.org/officeDocument/2006/customXml" ds:itemID="{0A230136-8CEC-4C29-A55A-F5FA83CA887A}">
+<file path=customXml/itemProps35.xml><?xml version="1.0" encoding="utf-8"?>
+<ds:datastoreItem xmlns:ds="http://schemas.openxmlformats.org/officeDocument/2006/customXml" ds:itemID="{75BD4175-2A6A-457D-B03C-89D272FF4835}">
   <ds:schemaRefs/>
 </ds:datastoreItem>
 </file>
 
-<file path=customXml/itemProps3.xml><?xml version="1.0" encoding="utf-8"?>
-<ds:datastoreItem xmlns:ds="http://schemas.openxmlformats.org/officeDocument/2006/customXml" ds:itemID="{F990F116-B58F-4255-B05B-DA3808E0E5C6}">
-  <ds:schemaRefs>
-    <ds:schemaRef ds:uri="http://schemas.openxmlformats.org/package/2006/metadata/core-properties"/>
-    <ds:schemaRef ds:uri="http://purl.org/dc/elements/1.1/"/>
-    <ds:schemaRef ds:uri="http://purl.org/dc/dcmitype/"/>
-    <ds:schemaRef ds:uri="http://www.w3.org/XML/1998/namespace"/>
-    <ds:schemaRef ds:uri="http://purl.org/dc/terms/"/>
-    <ds:schemaRef ds:uri="e4aa919a-b200-49cb-beca-4c7e0810321e"/>
-    <ds:schemaRef ds:uri="http://schemas.microsoft.com/office/2006/documentManagement/types"/>
-    <ds:schemaRef ds:uri="http://schemas.microsoft.com/office/2006/metadata/properties"/>
-    <ds:schemaRef ds:uri="http://schemas.microsoft.com/office/infopath/2007/PartnerControls"/>
-    <ds:schemaRef ds:uri="06670dda-0291-4061-b6e0-f6c0cb392c51"/>
-    <ds:schemaRef ds:uri="http://schemas.microsoft.com/sharepoint/v3"/>
-  </ds:schemaRefs>
-</ds:datastoreItem>
-</file>
-
-<file path=customXml/itemProps30.xml><?xml version="1.0" encoding="utf-8"?>
-<ds:datastoreItem xmlns:ds="http://schemas.openxmlformats.org/officeDocument/2006/customXml" ds:itemID="{682BF6E6-8993-4A0E-A615-E24230C37DAC}">
+<file path=customXml/itemProps36.xml><?xml version="1.0" encoding="utf-8"?>
+<ds:datastoreItem xmlns:ds="http://schemas.openxmlformats.org/officeDocument/2006/customXml" ds:itemID="{0C0AD6D7-0AAB-4CF7-9869-E9E315BAF875}">
   <ds:schemaRefs/>
 </ds:datastoreItem>
 </file>
 
-<file path=customXml/itemProps31.xml><?xml version="1.0" encoding="utf-8"?>
+<file path=customXml/itemProps37.xml><?xml version="1.0" encoding="utf-8"?>
+<ds:datastoreItem xmlns:ds="http://schemas.openxmlformats.org/officeDocument/2006/customXml" ds:itemID="{08BA5A9A-BB8B-4F8E-93CD-455474EF7276}">
+  <ds:schemaRefs/>
+</ds:datastoreItem>
+</file>
+
+<file path=customXml/itemProps38.xml><?xml version="1.0" encoding="utf-8"?>
+<ds:datastoreItem xmlns:ds="http://schemas.openxmlformats.org/officeDocument/2006/customXml" ds:itemID="{9DF1E77E-93BB-43A3-BEC8-6478C2794FA6}">
+  <ds:schemaRefs/>
+</ds:datastoreItem>
+</file>
+
+<file path=customXml/itemProps39.xml><?xml version="1.0" encoding="utf-8"?>
 <ds:datastoreItem xmlns:ds="http://schemas.openxmlformats.org/officeDocument/2006/customXml" ds:itemID="{2BC0DC1D-8D15-4194-9A1A-EDACA544CFA6}">
   <ds:schemaRefs/>
 </ds:datastoreItem>
 </file>
 
-<file path=customXml/itemProps32.xml><?xml version="1.0" encoding="utf-8"?>
-<ds:datastoreItem xmlns:ds="http://schemas.openxmlformats.org/officeDocument/2006/customXml" ds:itemID="{7FD631D3-3AB7-43F0-9FCE-6F65E4127A72}">
+<file path=customXml/itemProps4.xml><?xml version="1.0" encoding="utf-8"?>
+<ds:datastoreItem xmlns:ds="http://schemas.openxmlformats.org/officeDocument/2006/customXml" ds:itemID="{8C320EF3-E45D-49A1-86A9-B0DA20C7CC04}">
   <ds:schemaRefs/>
 </ds:datastoreItem>
 </file>
 
-<file path=customXml/itemProps33.xml><?xml version="1.0" encoding="utf-8"?>
-<ds:datastoreItem xmlns:ds="http://schemas.openxmlformats.org/officeDocument/2006/customXml" ds:itemID="{65B44A9F-1851-42AC-AD3C-FFC343A07D3A}">
+<file path=customXml/itemProps40.xml><?xml version="1.0" encoding="utf-8"?>
+<ds:datastoreItem xmlns:ds="http://schemas.openxmlformats.org/officeDocument/2006/customXml" ds:itemID="{56B316EE-D9D1-44C3-8C00-AE433A63C836}">
   <ds:schemaRefs/>
 </ds:datastoreItem>
 </file>
 
-<file path=customXml/itemProps34.xml><?xml version="1.0" encoding="utf-8"?>
+<file path=customXml/itemProps41.xml><?xml version="1.0" encoding="utf-8"?>
+<ds:datastoreItem xmlns:ds="http://schemas.openxmlformats.org/officeDocument/2006/customXml" ds:itemID="{AD9376BE-3D3E-4586-9139-069C1651B477}">
+  <ds:schemaRefs/>
+</ds:datastoreItem>
+</file>
+
+<file path=customXml/itemProps42.xml><?xml version="1.0" encoding="utf-8"?>
+<ds:datastoreItem xmlns:ds="http://schemas.openxmlformats.org/officeDocument/2006/customXml" ds:itemID="{E3B787A2-A83F-4E87-A90A-111C61F62E24}">
+  <ds:schemaRefs/>
+</ds:datastoreItem>
+</file>
+
+<file path=customXml/itemProps43.xml><?xml version="1.0" encoding="utf-8"?>
+<ds:datastoreItem xmlns:ds="http://schemas.openxmlformats.org/officeDocument/2006/customXml" ds:itemID="{B7066F7B-EA61-4071-B961-E1FA19724DC0}">
+  <ds:schemaRefs/>
+</ds:datastoreItem>
+</file>
+
+<file path=customXml/itemProps44.xml><?xml version="1.0" encoding="utf-8"?>
+<ds:datastoreItem xmlns:ds="http://schemas.openxmlformats.org/officeDocument/2006/customXml" ds:itemID="{C89A946A-C258-4267-A263-69DA8374B547}">
+  <ds:schemaRefs/>
+</ds:datastoreItem>
+</file>
+
+<file path=customXml/itemProps45.xml><?xml version="1.0" encoding="utf-8"?>
+<ds:datastoreItem xmlns:ds="http://schemas.openxmlformats.org/officeDocument/2006/customXml" ds:itemID="{DDCC6A1B-7673-40E9-AC3E-C0D8F2784A83}">
+  <ds:schemaRefs/>
+</ds:datastoreItem>
+</file>
+
+<file path=customXml/itemProps46.xml><?xml version="1.0" encoding="utf-8"?>
+<ds:datastoreItem xmlns:ds="http://schemas.openxmlformats.org/officeDocument/2006/customXml" ds:itemID="{6291F803-2EF0-4E47-96D6-4796950CE6BD}">
+  <ds:schemaRefs/>
+</ds:datastoreItem>
+</file>
+
+<file path=customXml/itemProps47.xml><?xml version="1.0" encoding="utf-8"?>
+<ds:datastoreItem xmlns:ds="http://schemas.openxmlformats.org/officeDocument/2006/customXml" ds:itemID="{BE3BB7DD-0C86-4747-A387-5C5D191BB970}">
+  <ds:schemaRefs/>
+</ds:datastoreItem>
+</file>
+
+<file path=customXml/itemProps48.xml><?xml version="1.0" encoding="utf-8"?>
 <ds:datastoreItem xmlns:ds="http://schemas.openxmlformats.org/officeDocument/2006/customXml" ds:itemID="{3D719615-E8C3-42D3-B19D-076A1FC4620D}">
   <ds:schemaRefs/>
 </ds:datastoreItem>
 </file>
 
-<file path=customXml/itemProps35.xml><?xml version="1.0" encoding="utf-8"?>
-<ds:datastoreItem xmlns:ds="http://schemas.openxmlformats.org/officeDocument/2006/customXml" ds:itemID="{921C0A0B-EE13-4908-9C41-3E7EDF526068}">
-  <ds:schemaRefs/>
-</ds:datastoreItem>
-</file>
-
-<file path=customXml/itemProps36.xml><?xml version="1.0" encoding="utf-8"?>
-<ds:datastoreItem xmlns:ds="http://schemas.openxmlformats.org/officeDocument/2006/customXml" ds:itemID="{75BD4175-2A6A-457D-B03C-89D272FF4835}">
-  <ds:schemaRefs/>
-</ds:datastoreItem>
-</file>
-
-<file path=customXml/itemProps37.xml><?xml version="1.0" encoding="utf-8"?>
-<ds:datastoreItem xmlns:ds="http://schemas.openxmlformats.org/officeDocument/2006/customXml" ds:itemID="{8C320EF3-E45D-49A1-86A9-B0DA20C7CC04}">
-  <ds:schemaRefs/>
-</ds:datastoreItem>
-</file>
-
-<file path=customXml/itemProps38.xml><?xml version="1.0" encoding="utf-8"?>
-<ds:datastoreItem xmlns:ds="http://schemas.openxmlformats.org/officeDocument/2006/customXml" ds:itemID="{915452D2-9D6B-41D9-99FD-4D1CF211FA39}">
-  <ds:schemaRefs/>
-</ds:datastoreItem>
-</file>
-
-<file path=customXml/itemProps39.xml><?xml version="1.0" encoding="utf-8"?>
-<ds:datastoreItem xmlns:ds="http://schemas.openxmlformats.org/officeDocument/2006/customXml" ds:itemID="{BE3BB7DD-0C86-4747-A387-5C5D191BB970}">
-  <ds:schemaRefs/>
-</ds:datastoreItem>
-</file>
-
-<file path=customXml/itemProps4.xml><?xml version="1.0" encoding="utf-8"?>
-<ds:datastoreItem xmlns:ds="http://schemas.openxmlformats.org/officeDocument/2006/customXml" ds:itemID="{B7066F7B-EA61-4071-B961-E1FA19724DC0}">
-  <ds:schemaRefs/>
-</ds:datastoreItem>
-</file>
-
-<file path=customXml/itemProps40.xml><?xml version="1.0" encoding="utf-8"?>
-<ds:datastoreItem xmlns:ds="http://schemas.openxmlformats.org/officeDocument/2006/customXml" ds:itemID="{43BC5722-1D5B-4915-8247-E6D5F513E549}">
-  <ds:schemaRefs/>
-</ds:datastoreItem>
-</file>
-
-<file path=customXml/itemProps41.xml><?xml version="1.0" encoding="utf-8"?>
-<ds:datastoreItem xmlns:ds="http://schemas.openxmlformats.org/officeDocument/2006/customXml" ds:itemID="{1D3A887C-FC1C-482E-BE66-F9B66B0A6227}">
-  <ds:schemaRefs/>
-</ds:datastoreItem>
-</file>
-
-<file path=customXml/itemProps42.xml><?xml version="1.0" encoding="utf-8"?>
-<ds:datastoreItem xmlns:ds="http://schemas.openxmlformats.org/officeDocument/2006/customXml" ds:itemID="{25EDB0A7-1862-4F58-81F8-88FFEB27A481}">
-  <ds:schemaRefs/>
-</ds:datastoreItem>
-</file>
-
-<file path=customXml/itemProps43.xml><?xml version="1.0" encoding="utf-8"?>
-<ds:datastoreItem xmlns:ds="http://schemas.openxmlformats.org/officeDocument/2006/customXml" ds:itemID="{C5DD1971-334A-45E9-9D2B-FB6BD8AAE58A}">
-  <ds:schemaRefs/>
-</ds:datastoreItem>
-</file>
-
-<file path=customXml/itemProps44.xml><?xml version="1.0" encoding="utf-8"?>
-<ds:datastoreItem xmlns:ds="http://schemas.openxmlformats.org/officeDocument/2006/customXml" ds:itemID="{56B316EE-D9D1-44C3-8C00-AE433A63C836}">
-  <ds:schemaRefs/>
-</ds:datastoreItem>
-</file>
-
-<file path=customXml/itemProps45.xml><?xml version="1.0" encoding="utf-8"?>
-<ds:datastoreItem xmlns:ds="http://schemas.openxmlformats.org/officeDocument/2006/customXml" ds:itemID="{56A99A3E-A648-468D-B568-4C0AD8B35441}">
-  <ds:schemaRefs/>
-</ds:datastoreItem>
-</file>
-
-<file path=customXml/itemProps46.xml><?xml version="1.0" encoding="utf-8"?>
-<ds:datastoreItem xmlns:ds="http://schemas.openxmlformats.org/officeDocument/2006/customXml" ds:itemID="{EC53C6C7-14A0-4237-9C9A-FA78B37E53AB}">
-  <ds:schemaRefs/>
-</ds:datastoreItem>
-</file>
-
-<file path=customXml/itemProps47.xml><?xml version="1.0" encoding="utf-8"?>
-<ds:datastoreItem xmlns:ds="http://schemas.openxmlformats.org/officeDocument/2006/customXml" ds:itemID="{2EF89111-4289-441B-97BD-A2D8E126532F}">
-  <ds:schemaRefs/>
-</ds:datastoreItem>
-</file>
-
-<file path=customXml/itemProps48.xml><?xml version="1.0" encoding="utf-8"?>
-<ds:datastoreItem xmlns:ds="http://schemas.openxmlformats.org/officeDocument/2006/customXml" ds:itemID="{162E1B2B-387B-423C-8FB0-129D0EE7DD83}">
-  <ds:schemaRefs/>
-</ds:datastoreItem>
-</file>
-
 <file path=customXml/itemProps49.xml><?xml version="1.0" encoding="utf-8"?>
-<ds:datastoreItem xmlns:ds="http://schemas.openxmlformats.org/officeDocument/2006/customXml" ds:itemID="{0C0AD6D7-0AAB-4CF7-9869-E9E315BAF875}">
+<ds:datastoreItem xmlns:ds="http://schemas.openxmlformats.org/officeDocument/2006/customXml" ds:itemID="{30338C60-725E-4230-8732-6C1737FFCF6F}">
   <ds:schemaRefs/>
 </ds:datastoreItem>
 </file>
 
 <file path=customXml/itemProps5.xml><?xml version="1.0" encoding="utf-8"?>
-<ds:datastoreItem xmlns:ds="http://schemas.openxmlformats.org/officeDocument/2006/customXml" ds:itemID="{2A1B10AF-5356-4D21-9E16-9423E20937FC}">
+<ds:datastoreItem xmlns:ds="http://schemas.openxmlformats.org/officeDocument/2006/customXml" ds:itemID="{988BE19C-289C-4D51-AC33-2691C170DBEA}">
   <ds:schemaRefs/>
 </ds:datastoreItem>
 </file>
 
 <file path=customXml/itemProps50.xml><?xml version="1.0" encoding="utf-8"?>
-<ds:datastoreItem xmlns:ds="http://schemas.openxmlformats.org/officeDocument/2006/customXml" ds:itemID="{30338C60-725E-4230-8732-6C1737FFCF6F}">
-  <ds:schemaRefs/>
-</ds:datastoreItem>
-</file>
-
-<file path=customXml/itemProps51.xml><?xml version="1.0" encoding="utf-8"?>
-<ds:datastoreItem xmlns:ds="http://schemas.openxmlformats.org/officeDocument/2006/customXml" ds:itemID="{D4B66AC3-71C4-4908-9595-93E8B8D76E97}">
-  <ds:schemaRefs/>
-</ds:datastoreItem>
-</file>
-
-<file path=customXml/itemProps52.xml><?xml version="1.0" encoding="utf-8"?>
-<ds:datastoreItem xmlns:ds="http://schemas.openxmlformats.org/officeDocument/2006/customXml" ds:itemID="{AD9376BE-3D3E-4586-9139-069C1651B477}">
-  <ds:schemaRefs/>
-</ds:datastoreItem>
-</file>
-
-<file path=customXml/itemProps53.xml><?xml version="1.0" encoding="utf-8"?>
-<ds:datastoreItem xmlns:ds="http://schemas.openxmlformats.org/officeDocument/2006/customXml" ds:itemID="{988BE19C-289C-4D51-AC33-2691C170DBEA}">
-  <ds:schemaRefs/>
-</ds:datastoreItem>
-</file>
-
-<file path=customXml/itemProps54.xml><?xml version="1.0" encoding="utf-8"?>
-<ds:datastoreItem xmlns:ds="http://schemas.openxmlformats.org/officeDocument/2006/customXml" ds:itemID="{00121D97-98F5-4946-8A5D-87D090F11338}">
-  <ds:schemaRefs/>
-</ds:datastoreItem>
-</file>
-
-<file path=customXml/itemProps55.xml><?xml version="1.0" encoding="utf-8"?>
 <ds:datastoreItem xmlns:ds="http://schemas.openxmlformats.org/officeDocument/2006/customXml" ds:itemID="{758FDAC0-319D-4A54-8D8E-1D42CB1F8004}">
   <ds:schemaRefs>
     <ds:schemaRef ds:uri="http://schemas.microsoft.com/sharepoint/v3/contenttype/forms"/>
@@ -37003,62 +37005,92 @@
 </ds:datastoreItem>
 </file>
 
+<file path=customXml/itemProps51.xml><?xml version="1.0" encoding="utf-8"?>
+<ds:datastoreItem xmlns:ds="http://schemas.openxmlformats.org/officeDocument/2006/customXml" ds:itemID="{7BAA13C3-64B7-4D7A-BA49-B0CCD43E2049}">
+  <ds:schemaRefs/>
+</ds:datastoreItem>
+</file>
+
+<file path=customXml/itemProps52.xml><?xml version="1.0" encoding="utf-8"?>
+<ds:datastoreItem xmlns:ds="http://schemas.openxmlformats.org/officeDocument/2006/customXml" ds:itemID="{364650BF-04B4-4ADF-AE61-286BFE5AF2AD}">
+  <ds:schemaRefs/>
+</ds:datastoreItem>
+</file>
+
+<file path=customXml/itemProps53.xml><?xml version="1.0" encoding="utf-8"?>
+<ds:datastoreItem xmlns:ds="http://schemas.openxmlformats.org/officeDocument/2006/customXml" ds:itemID="{0A230136-8CEC-4C29-A55A-F5FA83CA887A}">
+  <ds:schemaRefs/>
+</ds:datastoreItem>
+</file>
+
+<file path=customXml/itemProps54.xml><?xml version="1.0" encoding="utf-8"?>
+<ds:datastoreItem xmlns:ds="http://schemas.openxmlformats.org/officeDocument/2006/customXml" ds:itemID="{95AE8F77-448C-4B7C-8669-DC6D4241F9CE}">
+  <ds:schemaRefs/>
+</ds:datastoreItem>
+</file>
+
+<file path=customXml/itemProps55.xml><?xml version="1.0" encoding="utf-8"?>
+<ds:datastoreItem xmlns:ds="http://schemas.openxmlformats.org/officeDocument/2006/customXml" ds:itemID="{43BC5722-1D5B-4915-8247-E6D5F513E549}">
+  <ds:schemaRefs/>
+</ds:datastoreItem>
+</file>
+
 <file path=customXml/itemProps56.xml><?xml version="1.0" encoding="utf-8"?>
-<ds:datastoreItem xmlns:ds="http://schemas.openxmlformats.org/officeDocument/2006/customXml" ds:itemID="{D5DFDA8F-B725-4CD6-A843-7349EA123794}">
+<ds:datastoreItem xmlns:ds="http://schemas.openxmlformats.org/officeDocument/2006/customXml" ds:itemID="{56A99A3E-A648-468D-B568-4C0AD8B35441}">
   <ds:schemaRefs/>
 </ds:datastoreItem>
 </file>
 
 <file path=customXml/itemProps57.xml><?xml version="1.0" encoding="utf-8"?>
-<ds:datastoreItem xmlns:ds="http://schemas.openxmlformats.org/officeDocument/2006/customXml" ds:itemID="{08BA5A9A-BB8B-4F8E-93CD-455474EF7276}">
+<ds:datastoreItem xmlns:ds="http://schemas.openxmlformats.org/officeDocument/2006/customXml" ds:itemID="{AE04A922-1222-46EA-85D1-620CD08A927B}">
   <ds:schemaRefs/>
 </ds:datastoreItem>
 </file>
 
 <file path=customXml/itemProps58.xml><?xml version="1.0" encoding="utf-8"?>
+<ds:datastoreItem xmlns:ds="http://schemas.openxmlformats.org/officeDocument/2006/customXml" ds:itemID="{33C2836D-CD36-48F0-AE3F-D27BFE792AB7}">
+  <ds:schemaRefs/>
+</ds:datastoreItem>
+</file>
+
+<file path=customXml/itemProps59.xml><?xml version="1.0" encoding="utf-8"?>
+<ds:datastoreItem xmlns:ds="http://schemas.openxmlformats.org/officeDocument/2006/customXml" ds:itemID="{1669606D-CDD4-43E6-985A-81776140D176}">
+  <ds:schemaRefs/>
+</ds:datastoreItem>
+</file>
+
+<file path=customXml/itemProps6.xml><?xml version="1.0" encoding="utf-8"?>
 <ds:datastoreItem xmlns:ds="http://schemas.openxmlformats.org/officeDocument/2006/customXml" ds:itemID="{647B6612-4C79-45CE-9A32-14C2D37B46F1}">
   <ds:schemaRefs/>
 </ds:datastoreItem>
 </file>
 
-<file path=customXml/itemProps59.xml><?xml version="1.0" encoding="utf-8"?>
-<ds:datastoreItem xmlns:ds="http://schemas.openxmlformats.org/officeDocument/2006/customXml" ds:itemID="{E4C8E36C-E4C3-4DF8-B9A8-546312449852}">
-  <ds:schemaRefs/>
-</ds:datastoreItem>
-</file>
-
-<file path=customXml/itemProps6.xml><?xml version="1.0" encoding="utf-8"?>
-<ds:datastoreItem xmlns:ds="http://schemas.openxmlformats.org/officeDocument/2006/customXml" ds:itemID="{C67D3CDE-4F82-4339-9EA4-1EEE33A61958}">
-  <ds:schemaRefs/>
-</ds:datastoreItem>
-</file>
-
 <file path=customXml/itemProps60.xml><?xml version="1.0" encoding="utf-8"?>
-<ds:datastoreItem xmlns:ds="http://schemas.openxmlformats.org/officeDocument/2006/customXml" ds:itemID="{E3B787A2-A83F-4E87-A90A-111C61F62E24}">
+<ds:datastoreItem xmlns:ds="http://schemas.openxmlformats.org/officeDocument/2006/customXml" ds:itemID="{25EDB0A7-1862-4F58-81F8-88FFEB27A481}">
   <ds:schemaRefs/>
 </ds:datastoreItem>
 </file>
 
 <file path=customXml/itemProps61.xml><?xml version="1.0" encoding="utf-8"?>
-<ds:datastoreItem xmlns:ds="http://schemas.openxmlformats.org/officeDocument/2006/customXml" ds:itemID="{AE04A922-1222-46EA-85D1-620CD08A927B}">
+<ds:datastoreItem xmlns:ds="http://schemas.openxmlformats.org/officeDocument/2006/customXml" ds:itemID="{2EF89111-4289-441B-97BD-A2D8E126532F}">
   <ds:schemaRefs/>
 </ds:datastoreItem>
 </file>
 
 <file path=customXml/itemProps7.xml><?xml version="1.0" encoding="utf-8"?>
-<ds:datastoreItem xmlns:ds="http://schemas.openxmlformats.org/officeDocument/2006/customXml" ds:itemID="{7BAA13C3-64B7-4D7A-BA49-B0CCD43E2049}">
+<ds:datastoreItem xmlns:ds="http://schemas.openxmlformats.org/officeDocument/2006/customXml" ds:itemID="{2A1B10AF-5356-4D21-9E16-9423E20937FC}">
   <ds:schemaRefs/>
 </ds:datastoreItem>
 </file>
 
 <file path=customXml/itemProps8.xml><?xml version="1.0" encoding="utf-8"?>
-<ds:datastoreItem xmlns:ds="http://schemas.openxmlformats.org/officeDocument/2006/customXml" ds:itemID="{3915BD4A-04C4-49F2-B0B9-3E7D336EC799}">
+<ds:datastoreItem xmlns:ds="http://schemas.openxmlformats.org/officeDocument/2006/customXml" ds:itemID="{1AB4A281-5EBA-4CA1-A536-6B29C98890B6}">
   <ds:schemaRefs/>
 </ds:datastoreItem>
 </file>
 
 <file path=customXml/itemProps9.xml><?xml version="1.0" encoding="utf-8"?>
-<ds:datastoreItem xmlns:ds="http://schemas.openxmlformats.org/officeDocument/2006/customXml" ds:itemID="{C89A946A-C258-4267-A263-69DA8374B547}">
+<ds:datastoreItem xmlns:ds="http://schemas.openxmlformats.org/officeDocument/2006/customXml" ds:itemID="{A20E27A4-6C3C-428D-ADE7-7DC089C0CD46}">
   <ds:schemaRefs/>
 </ds:datastoreItem>
 </file>

</xml_diff>

<commit_message>
Sudoku notebook improvements: warmup, mid-run generalist check, logging, cleanup
Builds on the existing Sudoku GRPO workshop notebook rather than
introducing a separate track: adds a pre-generate warmup cell, a
generalist sanity-check between the initial training run and the
resume-from-checkpoint run, JSONL logging of every scored completion
during training, side-by-side strategy/board printing to save console
space, and removes duplicated code (shared reward_funcs/resume config,
a single ask() helper, merged trivial display cells).
</commit_message>
<xml_diff>
--- a/docs/AMD-Unsloth-GRPO-Fine-tuning1.pptx
+++ b/docs/AMD-Unsloth-GRPO-Fine-tuning1.pptx
@@ -337,7 +337,7 @@
             <a:fld id="{076B0810-FC62-EE4E-BF04-55F4B7654175}" type="datetime8">
               <a:rPr lang="en-US" smtClean="0"/>
               <a:pPr/>
-              <a:t>9/28/2026 12:50 PM</a:t>
+              <a:t>10/2/2026 10:09 AM</a:t>
             </a:fld>
             <a:endParaRPr lang="en-US" dirty="0"/>
           </a:p>
@@ -577,7 +577,7 @@
             <a:fld id="{076B0810-FC62-EE4E-BF04-55F4B7654175}" type="datetime8">
               <a:rPr lang="en-US" smtClean="0"/>
               <a:pPr/>
-              <a:t>9/28/2026 12:50 PM</a:t>
+              <a:t>10/2/2026 10:07 AM</a:t>
             </a:fld>
             <a:endParaRPr lang="en-US" dirty="0"/>
           </a:p>
@@ -2254,7 +2254,7 @@
         <p:fade/>
       </p:transition>
     </mc:Choice>
-    <mc:Fallback xmlns:p15="http://schemas.microsoft.com/office/powerpoint/2012/main" xmlns:a14="http://schemas.microsoft.com/office/drawing/2010/main" xmlns:a16="http://schemas.microsoft.com/office/drawing/2014/main" xmlns="">
+    <mc:Fallback xmlns="" xmlns:a16="http://schemas.microsoft.com/office/drawing/2014/main" xmlns:a14="http://schemas.microsoft.com/office/drawing/2010/main" xmlns:p15="http://schemas.microsoft.com/office/powerpoint/2012/main">
       <p:transition spd="med">
         <p:fade/>
       </p:transition>
@@ -10451,7 +10451,7 @@
         <p:fade/>
       </p:transition>
     </mc:Choice>
-    <mc:Fallback xmlns="" xmlns:p15="http://schemas.microsoft.com/office/powerpoint/2012/main" xmlns:a14="http://schemas.microsoft.com/office/drawing/2010/main" xmlns:a16="http://schemas.microsoft.com/office/drawing/2014/main">
+    <mc:Fallback xmlns:a16="http://schemas.microsoft.com/office/drawing/2014/main" xmlns:a14="http://schemas.microsoft.com/office/drawing/2010/main" xmlns:p15="http://schemas.microsoft.com/office/powerpoint/2012/main" xmlns="">
       <p:transition spd="med">
         <p:fade/>
       </p:transition>
@@ -14577,7 +14577,7 @@
         <p:fade/>
       </p:transition>
     </mc:Choice>
-    <mc:Fallback xmlns:p15="http://schemas.microsoft.com/office/powerpoint/2012/main" xmlns:a14="http://schemas.microsoft.com/office/drawing/2010/main" xmlns:a16="http://schemas.microsoft.com/office/drawing/2014/main" xmlns="">
+    <mc:Fallback xmlns="" xmlns:a16="http://schemas.microsoft.com/office/drawing/2014/main" xmlns:a14="http://schemas.microsoft.com/office/drawing/2010/main" xmlns:p15="http://schemas.microsoft.com/office/powerpoint/2012/main">
       <p:transition spd="med">
         <p:fade/>
       </p:transition>
@@ -19503,13 +19503,31 @@
           <a:lstStyle/>
           <a:p>
             <a:r>
-              <a:rPr sz="4000" b="0">
+              <a:rPr sz="4000" b="0" dirty="0">
                 <a:solidFill>
                   <a:srgbClr val="FFFFFF"/>
                 </a:solidFill>
                 <a:latin typeface="Klavika Bold"/>
               </a:rPr>
-              <a:t>AMD Unsloth GRPO Fine-tuning</a:t>
+              <a:t>AMD </a:t>
+            </a:r>
+            <a:r>
+              <a:rPr sz="4000" b="0" dirty="0" err="1">
+                <a:solidFill>
+                  <a:srgbClr val="FFFFFF"/>
+                </a:solidFill>
+                <a:latin typeface="Klavika Bold"/>
+              </a:rPr>
+              <a:t>Unsloth</a:t>
+            </a:r>
+            <a:r>
+              <a:rPr sz="4000" b="0" dirty="0">
+                <a:solidFill>
+                  <a:srgbClr val="FFFFFF"/>
+                </a:solidFill>
+                <a:latin typeface="Klavika Bold"/>
+              </a:rPr>
+              <a:t> GRPO Fine-tuning</a:t>
             </a:r>
           </a:p>
         </p:txBody>
@@ -22347,7 +22365,7 @@
         <p:spPr>
           <a:xfrm>
             <a:off x="585216" y="1243584"/>
-            <a:ext cx="11018520" cy="320040"/>
+            <a:ext cx="11018520" cy="230832"/>
           </a:xfrm>
           <a:prstGeom prst="rect">
             <a:avLst/>
@@ -22369,13 +22387,31 @@
               </a:spcAft>
             </a:pPr>
             <a:r>
-              <a:rPr sz="1500" b="0">
+              <a:rPr sz="1500" b="0" dirty="0">
                 <a:solidFill>
                   <a:srgbClr val="D8DADE"/>
                 </a:solidFill>
                 <a:latin typeface="Klavika Regular"/>
               </a:rPr>
-              <a:t>Open a terminal inside Jupyter and confirm the GPU is really there before you train.</a:t>
+              <a:t>Open a terminal inside Jupyter and confirm the GPU is </a:t>
+            </a:r>
+            <a:r>
+              <a:rPr lang="en-US" sz="1500" b="0" dirty="0">
+                <a:solidFill>
+                  <a:srgbClr val="D8DADE"/>
+                </a:solidFill>
+                <a:latin typeface="Klavika Regular"/>
+              </a:rPr>
+              <a:t>available </a:t>
+            </a:r>
+            <a:r>
+              <a:rPr sz="1500" b="0" dirty="0">
+                <a:solidFill>
+                  <a:srgbClr val="D8DADE"/>
+                </a:solidFill>
+                <a:latin typeface="Klavika Regular"/>
+              </a:rPr>
+              <a:t>before you train.</a:t>
             </a:r>
           </a:p>
         </p:txBody>
@@ -22638,14 +22674,29 @@
               </a:spcAft>
             </a:pPr>
             <a:r>
-              <a:rPr sz="1400" b="0">
+              <a:rPr sz="1400" b="0" dirty="0">
                 <a:solidFill>
                   <a:srgbClr val="00A8CC"/>
                 </a:solidFill>
                 <a:latin typeface="Consolas"/>
               </a:rPr>
-              <a:t>$ rocm-smi</a:t>
-            </a:r>
+              <a:t>$ </a:t>
+            </a:r>
+            <a:r>
+              <a:rPr sz="1400" b="0" dirty="0" err="1">
+                <a:solidFill>
+                  <a:srgbClr val="00A8CC"/>
+                </a:solidFill>
+                <a:latin typeface="Consolas"/>
+              </a:rPr>
+              <a:t>rocm-smi</a:t>
+            </a:r>
+            <a:endParaRPr sz="1400" b="0" dirty="0">
+              <a:solidFill>
+                <a:srgbClr val="00A8CC"/>
+              </a:solidFill>
+              <a:latin typeface="Consolas"/>
+            </a:endParaRPr>
           </a:p>
           <a:p>
             <a:pPr algn="l">
@@ -22660,14 +22711,29 @@
               </a:spcAft>
             </a:pPr>
             <a:r>
-              <a:rPr sz="1400" b="0">
+              <a:rPr sz="1400" b="0" dirty="0">
                 <a:solidFill>
                   <a:srgbClr val="00A8CC"/>
                 </a:solidFill>
                 <a:latin typeface="Consolas"/>
               </a:rPr>
-              <a:t>$ rocminfo</a:t>
-            </a:r>
+              <a:t>$ </a:t>
+            </a:r>
+            <a:r>
+              <a:rPr sz="1400" b="0" dirty="0" err="1">
+                <a:solidFill>
+                  <a:srgbClr val="00A8CC"/>
+                </a:solidFill>
+                <a:latin typeface="Consolas"/>
+              </a:rPr>
+              <a:t>rocminfo</a:t>
+            </a:r>
+            <a:endParaRPr sz="1400" b="0" dirty="0">
+              <a:solidFill>
+                <a:srgbClr val="00A8CC"/>
+              </a:solidFill>
+              <a:latin typeface="Consolas"/>
+            </a:endParaRPr>
           </a:p>
         </p:txBody>
       </p:sp>
@@ -22838,7 +22904,7 @@
               </a:spcAft>
             </a:pPr>
             <a:r>
-              <a:rPr sz="1150" b="0">
+              <a:rPr sz="1150" b="0" dirty="0">
                 <a:solidFill>
                   <a:srgbClr val="D8DADE"/>
                 </a:solidFill>
@@ -27537,25 +27603,58 @@
           <a:lstStyle/>
           <a:p>
             <a:r>
-              <a:rPr sz="2000" b="0">
+              <a:rPr sz="2000" b="0" dirty="0">
                 <a:solidFill>
                   <a:srgbClr val="C6C8CC"/>
                 </a:solidFill>
                 <a:latin typeface="Klavika Light"/>
               </a:rPr>
-              <a:t>notebooks.amd.com/ind-dev</a:t>
-            </a:r>
-          </a:p>
-          <a:p>
-            <a:r>
-              <a:rPr sz="2400" b="1">
+              <a:t>notebooks.amd.com/</a:t>
+            </a:r>
+            <a:r>
+              <a:rPr sz="2000" b="0" dirty="0" err="1">
+                <a:solidFill>
+                  <a:srgbClr val="C6C8CC"/>
+                </a:solidFill>
+                <a:latin typeface="Klavika Light"/>
+              </a:rPr>
+              <a:t>ind</a:t>
+            </a:r>
+            <a:r>
+              <a:rPr sz="2000" b="0" dirty="0">
+                <a:solidFill>
+                  <a:srgbClr val="C6C8CC"/>
+                </a:solidFill>
+                <a:latin typeface="Klavika Light"/>
+              </a:rPr>
+              <a:t>-dev</a:t>
+            </a:r>
+          </a:p>
+          <a:p>
+            <a:r>
+              <a:rPr sz="2400" b="1" dirty="0">
                 <a:solidFill>
                   <a:srgbClr val="FFFFFF"/>
                 </a:solidFill>
                 <a:latin typeface="Klavika Bold"/>
               </a:rPr>
-              <a:t>Password:  RadeonUnslothTuning</a:t>
-            </a:r>
+              <a:t>Password:  </a:t>
+            </a:r>
+            <a:r>
+              <a:rPr sz="2400" b="1" dirty="0" err="1">
+                <a:solidFill>
+                  <a:srgbClr val="FFFFFF"/>
+                </a:solidFill>
+                <a:latin typeface="Klavika Bold"/>
+              </a:rPr>
+              <a:t>RadeonUnslothTuning</a:t>
+            </a:r>
+            <a:endParaRPr sz="2400" b="1" dirty="0">
+              <a:solidFill>
+                <a:srgbClr val="FFFFFF"/>
+              </a:solidFill>
+              <a:latin typeface="Klavika Bold"/>
+            </a:endParaRPr>
           </a:p>
         </p:txBody>
       </p:sp>
@@ -28395,7 +28494,7 @@
               </a:spcAft>
             </a:pPr>
             <a:r>
-              <a:rPr sz="1800" b="0">
+              <a:rPr sz="1800" b="0" dirty="0">
                 <a:solidFill>
                   <a:srgbClr val="F26522"/>
                 </a:solidFill>
@@ -28437,7 +28536,7 @@
               </a:spcAft>
             </a:pPr>
             <a:r>
-              <a:rPr sz="1500" b="0">
+              <a:rPr sz="1500" b="0" dirty="0">
                 <a:solidFill>
                   <a:srgbClr val="FFFFFF"/>
                 </a:solidFill>
@@ -29086,7 +29185,7 @@
         <p:spPr>
           <a:xfrm>
             <a:off x="585216" y="1298448"/>
-            <a:ext cx="6766560" cy="1371600"/>
+            <a:ext cx="6766560" cy="1099019"/>
           </a:xfrm>
           <a:prstGeom prst="rect">
             <a:avLst/>
@@ -29151,31 +29250,40 @@
               </a:spcAft>
             </a:pPr>
             <a:r>
-              <a:rPr sz="1500" b="0" dirty="0">
+              <a:rPr lang="en-US" sz="1500" b="0" dirty="0">
                 <a:solidFill>
                   <a:srgbClr val="C6C8CC"/>
                 </a:solidFill>
                 <a:latin typeface="Klavika Regular"/>
               </a:rPr>
-              <a:t>That one simple skill, done at enormous scale, is enough to chat, </a:t>
-            </a:r>
-            <a:r>
-              <a:rPr sz="1500" b="0" dirty="0" err="1">
+              <a:t>This ability enables models to </a:t>
+            </a:r>
+            <a:r>
+              <a:rPr sz="1500" b="0" dirty="0">
                 <a:solidFill>
                   <a:srgbClr val="C6C8CC"/>
                 </a:solidFill>
                 <a:latin typeface="Klavika Regular"/>
               </a:rPr>
-              <a:t>summarise</a:t>
-            </a:r>
-            <a:r>
-              <a:rPr sz="1500" b="0" dirty="0">
+              <a:t>chat, summari</a:t>
+            </a:r>
+            <a:r>
+              <a:rPr lang="en-US" sz="1500" b="0" dirty="0">
                 <a:solidFill>
                   <a:srgbClr val="C6C8CC"/>
                 </a:solidFill>
                 <a:latin typeface="Klavika Regular"/>
               </a:rPr>
-              <a:t>, write code and reason.</a:t>
+              <a:t>z</a:t>
+            </a:r>
+            <a:r>
+              <a:rPr sz="1500" b="0" dirty="0">
+                <a:solidFill>
+                  <a:srgbClr val="C6C8CC"/>
+                </a:solidFill>
+                <a:latin typeface="Klavika Regular"/>
+              </a:rPr>
+              <a:t>e, write code and reason.</a:t>
             </a:r>
           </a:p>
         </p:txBody>
@@ -29438,7 +29546,7 @@
               </a:spcAft>
             </a:pPr>
             <a:r>
-              <a:rPr sz="1100" b="0">
+              <a:rPr sz="1100" b="0" dirty="0">
                 <a:solidFill>
                   <a:srgbClr val="C6C8CC"/>
                 </a:solidFill>
@@ -29459,7 +29567,7 @@
                 <a:spcPts val="300"/>
               </a:spcAft>
             </a:pPr>
-            <a:endParaRPr sz="1100" b="0">
+            <a:endParaRPr sz="1100" b="0" dirty="0">
               <a:solidFill>
                 <a:srgbClr val="C6C8CC"/>
               </a:solidFill>
@@ -29479,7 +29587,7 @@
               </a:spcAft>
             </a:pPr>
             <a:r>
-              <a:rPr sz="1100" b="0">
+              <a:rPr sz="1100" b="0" dirty="0">
                 <a:solidFill>
                   <a:srgbClr val="00A8CC"/>
                 </a:solidFill>
@@ -29501,7 +29609,7 @@
               </a:spcAft>
             </a:pPr>
             <a:r>
-              <a:rPr sz="1100" b="0">
+              <a:rPr sz="1100" b="0" dirty="0">
                 <a:solidFill>
                   <a:srgbClr val="C6C8CC"/>
                 </a:solidFill>
@@ -29523,7 +29631,7 @@
               </a:spcAft>
             </a:pPr>
             <a:r>
-              <a:rPr sz="1100" b="0">
+              <a:rPr sz="1100" b="0" dirty="0">
                 <a:solidFill>
                   <a:srgbClr val="C6C8CC"/>
                 </a:solidFill>
@@ -36217,11 +36325,11 @@
 </file>
 
 <file path=customXml/item1.xml><?xml version="1.0" encoding="utf-8"?>
-<TemplafySlideFormConfiguration><![CDATA[{"formFields":[],"formDataEntries":[]}]]></TemplafySlideFormConfiguration>
+<TemplafySlideTemplateConfiguration><![CDATA[{"slideVersion":1,"isValidatorEnabled":false,"isLocked":false,"elementsMetadata":[],"slideId":"637629098780820470","enableDocumentContentUpdater":true,"version":"2.0"}]]></TemplafySlideTemplateConfiguration>
 </file>
 
 <file path=customXml/item10.xml><?xml version="1.0" encoding="utf-8"?>
-<TemplafySlideTemplateConfiguration><![CDATA[{"slideVersion":1,"isValidatorEnabled":false,"isLocked":false,"elementsMetadata":[],"slideId":"637629098780891892","enableDocumentContentUpdater":true,"version":"2.0"}]]></TemplafySlideTemplateConfiguration>
+<TemplafySlideTemplateConfiguration><![CDATA[{"slideVersion":1,"isValidatorEnabled":false,"isLocked":false,"elementsMetadata":[],"slideId":"637629098780818133","enableDocumentContentUpdater":true,"version":"2.0"}]]></TemplafySlideTemplateConfiguration>
 </file>
 
 <file path=customXml/item11.xml><?xml version="1.0" encoding="utf-8"?>
@@ -36229,19 +36337,19 @@
 </file>
 
 <file path=customXml/item12.xml><?xml version="1.0" encoding="utf-8"?>
+<TemplafySlideTemplateConfiguration><![CDATA[{"slideVersion":1,"isValidatorEnabled":false,"isLocked":false,"elementsMetadata":[],"slideId":"637629098780864969","enableDocumentContentUpdater":true,"version":"2.0"}]]></TemplafySlideTemplateConfiguration>
+</file>
+
+<file path=customXml/item13.xml><?xml version="1.0" encoding="utf-8"?>
 <TemplafySlideFormConfiguration><![CDATA[{"formFields":[],"formDataEntries":[]}]]></TemplafySlideFormConfiguration>
 </file>
 
-<file path=customXml/item13.xml><?xml version="1.0" encoding="utf-8"?>
-<TemplafySlideTemplateConfiguration><![CDATA[{"slideVersion":1,"isValidatorEnabled":false,"isLocked":false,"elementsMetadata":[],"slideId":"637629098780861368","enableDocumentContentUpdater":true,"version":"2.0"}]]></TemplafySlideTemplateConfiguration>
-</file>
-
 <file path=customXml/item14.xml><?xml version="1.0" encoding="utf-8"?>
-<TemplafySlideFormConfiguration><![CDATA[{"formFields":[],"formDataEntries":[]}]]></TemplafySlideFormConfiguration>
+<TemplafySlideTemplateConfiguration><![CDATA[{"slideVersion":1,"isValidatorEnabled":false,"isLocked":false,"elementsMetadata":[],"slideId":"637629098780940360","enableDocumentContentUpdater":true,"version":"2.0"}]]></TemplafySlideTemplateConfiguration>
 </file>
 
 <file path=customXml/item15.xml><?xml version="1.0" encoding="utf-8"?>
-<TemplafySlideFormConfiguration><![CDATA[{"formFields":[],"formDataEntries":[]}]]></TemplafySlideFormConfiguration>
+<TemplafySlideTemplateConfiguration><![CDATA[{"slideVersion":1,"isValidatorEnabled":false,"isLocked":false,"elementsMetadata":[],"slideId":"637629098780944294","enableDocumentContentUpdater":true,"version":"2.0"}]]></TemplafySlideTemplateConfiguration>
 </file>
 
 <file path=customXml/item16.xml><?xml version="1.0" encoding="utf-8"?>
@@ -36249,7 +36357,7 @@
 </file>
 
 <file path=customXml/item17.xml><?xml version="1.0" encoding="utf-8"?>
-<TemplafySlideTemplateConfiguration><![CDATA[{"slideVersion":1,"isValidatorEnabled":false,"isLocked":false,"elementsMetadata":[],"slideId":"637629098780938070","enableDocumentContentUpdater":true,"version":"2.0"}]]></TemplafySlideTemplateConfiguration>
+<TemplafySlideTemplateConfiguration><![CDATA[{"slideVersion":1,"isValidatorEnabled":false,"isLocked":false,"elementsMetadata":[],"slideId":"637629098780863185","enableDocumentContentUpdater":true,"version":"2.0"}]]></TemplafySlideTemplateConfiguration>
 </file>
 
 <file path=customXml/item18.xml><?xml version="1.0" encoding="utf-8"?>
@@ -36257,6 +36365,191 @@
 </file>
 
 <file path=customXml/item19.xml><?xml version="1.0" encoding="utf-8"?>
+<TemplafySlideTemplateConfiguration><![CDATA[{"slideVersion":1,"isValidatorEnabled":false,"isLocked":false,"elementsMetadata":[],"slideId":"637629098780938070","enableDocumentContentUpdater":true,"version":"2.0"}]]></TemplafySlideTemplateConfiguration>
+</file>
+
+<file path=customXml/item2.xml><?xml version="1.0" encoding="utf-8"?>
+<TemplafySlideFormConfiguration><![CDATA[{"formFields":[],"formDataEntries":[]}]]></TemplafySlideFormConfiguration>
+</file>
+
+<file path=customXml/item20.xml><?xml version="1.0" encoding="utf-8"?>
+<TemplafySlideTemplateConfiguration><![CDATA[{"slideVersion":1,"isValidatorEnabled":false,"isLocked":false,"elementsMetadata":[],"slideId":"637629098780812520","enableDocumentContentUpdater":true,"version":"2.0"}]]></TemplafySlideTemplateConfiguration>
+</file>
+
+<file path=customXml/item21.xml><?xml version="1.0" encoding="utf-8"?>
+<TemplafySlideFormConfiguration><![CDATA[{"formFields":[],"formDataEntries":[]}]]></TemplafySlideFormConfiguration>
+</file>
+
+<file path=customXml/item22.xml><?xml version="1.0" encoding="utf-8"?>
+<TemplafySlideFormConfiguration><![CDATA[{"formFields":[],"formDataEntries":[]}]]></TemplafySlideFormConfiguration>
+</file>
+
+<file path=customXml/item23.xml><?xml version="1.0" encoding="utf-8"?>
+<TemplafyTemplateConfiguration><![CDATA[{"elementsMetadata":[],"transformationConfigurations":[{"colorTheme":"{{DataSources.ColorThemes[\"Corporate\"].ColorTheme}}","disableUpdates":false,"type":"colorTheme"}],"enableDocumentContentUpdater":true,"version":"2.0"}]]></TemplafyTemplateConfiguration>
+</file>
+
+<file path=customXml/item24.xml><?xml version="1.0" encoding="utf-8"?>
+<TemplafySlideTemplateConfiguration><![CDATA[{"slideVersion":1,"isValidatorEnabled":false,"isLocked":false,"elementsMetadata":[],"slideId":"637629098780855834","enableDocumentContentUpdater":true,"version":"2.0"}]]></TemplafySlideTemplateConfiguration>
+</file>
+
+<file path=customXml/item25.xml><?xml version="1.0" encoding="utf-8"?>
+<TemplafySlideTemplateConfiguration><![CDATA[{"slideVersion":1,"isValidatorEnabled":false,"isLocked":false,"elementsMetadata":[],"slideId":"637629098780868991","enableDocumentContentUpdater":true,"version":"2.0"}]]></TemplafySlideTemplateConfiguration>
+</file>
+
+<file path=customXml/item26.xml><?xml version="1.0" encoding="utf-8"?>
+<TemplafySlideTemplateConfiguration><![CDATA[{"slideVersion":1,"isValidatorEnabled":false,"isLocked":false,"elementsMetadata":[],"slideId":"637629098780898812","enableDocumentContentUpdater":true,"version":"2.0"}]]></TemplafySlideTemplateConfiguration>
+</file>
+
+<file path=customXml/item27.xml><?xml version="1.0" encoding="utf-8"?>
+<TemplafySlideTemplateConfiguration><![CDATA[{"slideVersion":1,"isValidatorEnabled":false,"isLocked":false,"elementsMetadata":[],"slideId":"637629098780805369","enableDocumentContentUpdater":true,"version":"2.0"}]]></TemplafySlideTemplateConfiguration>
+</file>
+
+<file path=customXml/item28.xml><?xml version="1.0" encoding="utf-8"?>
+<TemplafySlideFormConfiguration><![CDATA[{"formFields":[],"formDataEntries":[]}]]></TemplafySlideFormConfiguration>
+</file>
+
+<file path=customXml/item29.xml><?xml version="1.0" encoding="utf-8"?>
+<TemplafySlideFormConfiguration><![CDATA[{"formFields":[],"formDataEntries":[]}]]></TemplafySlideFormConfiguration>
+</file>
+
+<file path=customXml/item3.xml><?xml version="1.0" encoding="utf-8"?>
+<TemplafySlideFormConfiguration><![CDATA[{"formFields":[],"formDataEntries":[]}]]></TemplafySlideFormConfiguration>
+</file>
+
+<file path=customXml/item30.xml><?xml version="1.0" encoding="utf-8"?>
+<TemplafySlideFormConfiguration><![CDATA[{"formFields":[],"formDataEntries":[]}]]></TemplafySlideFormConfiguration>
+</file>
+
+<file path=customXml/item31.xml><?xml version="1.0" encoding="utf-8"?>
+<TemplafySlideFormConfiguration><![CDATA[{"formFields":[],"formDataEntries":[]}]]></TemplafySlideFormConfiguration>
+</file>
+
+<file path=customXml/item32.xml><?xml version="1.0" encoding="utf-8"?>
+<TemplafySlideTemplateConfiguration><![CDATA[{"slideVersion":1,"isValidatorEnabled":false,"isLocked":false,"elementsMetadata":[],"slideId":"637629098780935963","enableDocumentContentUpdater":true,"version":"2.0"}]]></TemplafySlideTemplateConfiguration>
+</file>
+
+<file path=customXml/item33.xml><?xml version="1.0" encoding="utf-8"?>
+<TemplafySlideTemplateConfiguration><![CDATA[{"slideVersion":1,"isValidatorEnabled":false,"isLocked":false,"elementsMetadata":[],"slideId":"637629098780929168","enableDocumentContentUpdater":true,"version":"2.0"}]]></TemplafySlideTemplateConfiguration>
+</file>
+
+<file path=customXml/item34.xml><?xml version="1.0" encoding="utf-8"?>
+<TemplafySlideTemplateConfiguration><![CDATA[{"slideVersion":1,"isValidatorEnabled":false,"isLocked":false,"elementsMetadata":[],"slideId":"637629098780942318","enableDocumentContentUpdater":true,"version":"2.0"}]]></TemplafySlideTemplateConfiguration>
+</file>
+
+<file path=customXml/item35.xml><?xml version="1.0" encoding="utf-8"?>
+<TemplafySlideFormConfiguration><![CDATA[{"formFields":[],"formDataEntries":[]}]]></TemplafySlideFormConfiguration>
+</file>
+
+<file path=customXml/item36.xml><?xml version="1.0" encoding="utf-8"?>
+<TemplafySlideTemplateConfiguration><![CDATA[{"slideVersion":1,"isValidatorEnabled":false,"isLocked":false,"elementsMetadata":[],"slideId":"637629098780891892","enableDocumentContentUpdater":true,"version":"2.0"}]]></TemplafySlideTemplateConfiguration>
+</file>
+
+<file path=customXml/item37.xml><?xml version="1.0" encoding="utf-8"?>
+<TemplafySlideFormConfiguration><![CDATA[{"formFields":[],"formDataEntries":[]}]]></TemplafySlideFormConfiguration>
+</file>
+
+<file path=customXml/item38.xml><?xml version="1.0" encoding="utf-8"?>
+<TemplafySlideTemplateConfiguration><![CDATA[{"slideVersion":1,"isValidatorEnabled":false,"isLocked":false,"elementsMetadata":[],"slideId":"637629098780858672","enableDocumentContentUpdater":true,"version":"2.0"}]]></TemplafySlideTemplateConfiguration>
+</file>
+
+<file path=customXml/item39.xml><?xml version="1.0" encoding="utf-8"?>
+<TemplafySlideTemplateConfiguration><![CDATA[{"slideVersion":1,"isValidatorEnabled":false,"isLocked":false,"elementsMetadata":[],"slideId":"637629098780933985","enableDocumentContentUpdater":true,"version":"2.0"}]]></TemplafySlideTemplateConfiguration>
+</file>
+
+<file path=customXml/item4.xml><?xml version="1.0" encoding="utf-8"?>
+<TemplafySlideFormConfiguration><![CDATA[{"formFields":[],"formDataEntries":[]}]]></TemplafySlideFormConfiguration>
+</file>
+
+<file path=customXml/item40.xml><?xml version="1.0" encoding="utf-8"?>
+<TemplafySlideFormConfiguration><![CDATA[{"formFields":[],"formDataEntries":[]}]]></TemplafySlideFormConfiguration>
+</file>
+
+<file path=customXml/item41.xml><?xml version="1.0" encoding="utf-8"?>
+<TemplafySlideFormConfiguration><![CDATA[{"formFields":[],"formDataEntries":[]}]]></TemplafySlideFormConfiguration>
+</file>
+
+<file path=customXml/item42.xml><?xml version="1.0" encoding="utf-8"?>
+<TemplafySlideTemplateConfiguration><![CDATA[{"slideVersion":1,"isValidatorEnabled":false,"isLocked":false,"elementsMetadata":[],"slideId":"637629098780938389","enableDocumentContentUpdater":true,"version":"2.0"}]]></TemplafySlideTemplateConfiguration>
+</file>
+
+<file path=customXml/item43.xml><?xml version="1.0" encoding="utf-8"?>
+<TemplafySlideTemplateConfiguration><![CDATA[{"slideVersion":1,"isValidatorEnabled":false,"isLocked":false,"elementsMetadata":[],"slideId":"637629098780861368","enableDocumentContentUpdater":true,"version":"2.0"}]]></TemplafySlideTemplateConfiguration>
+</file>
+
+<file path=customXml/item44.xml><?xml version="1.0" encoding="utf-8"?>
+<TemplafySlideFormConfiguration><![CDATA[{"formFields":[],"formDataEntries":[]}]]></TemplafySlideFormConfiguration>
+</file>
+
+<file path=customXml/item45.xml><?xml version="1.0" encoding="utf-8"?>
+<TemplafySlideTemplateConfiguration><![CDATA[{"slideVersion":1,"isValidatorEnabled":false,"isLocked":false,"elementsMetadata":[],"slideId":"637629098780874432","enableDocumentContentUpdater":true,"version":"2.0"}]]></TemplafySlideTemplateConfiguration>
+</file>
+
+<file path=customXml/item46.xml><?xml version="1.0" encoding="utf-8"?>
+<TemplafySlideFormConfiguration><![CDATA[{"formFields":[],"formDataEntries":[]}]]></TemplafySlideFormConfiguration>
+</file>
+
+<file path=customXml/item47.xml><?xml version="1.0" encoding="utf-8"?>
+<?mso-contentType ?>
+<FormTemplates xmlns="http://schemas.microsoft.com/sharepoint/v3/contenttype/forms">
+  <Display>DocumentLibraryForm</Display>
+  <Edit>DocumentLibraryForm</Edit>
+  <New>DocumentLibraryForm</New>
+</FormTemplates>
+</file>
+
+<file path=customXml/item48.xml><?xml version="1.0" encoding="utf-8"?>
+<TemplafyFormConfiguration><![CDATA[{"formFields":[{"required":false,"placeholder":"Title | Date | Security Setting","lines":1,"shareValue":false,"type":"textBox","name":"Footer","label":"Enter footer description","fullyQualifiedName":"Footer"}],"formDataEntries":[]}]]></TemplafyFormConfiguration>
+</file>
+
+<file path=customXml/item49.xml><?xml version="1.0" encoding="utf-8"?>
+<TemplafySlideFormConfiguration><![CDATA[{"formFields":[],"formDataEntries":[]}]]></TemplafySlideFormConfiguration>
+</file>
+
+<file path=customXml/item5.xml><?xml version="1.0" encoding="utf-8"?>
+<TemplafySlideFormConfiguration><![CDATA[{"formFields":[],"formDataEntries":[]}]]></TemplafySlideFormConfiguration>
+</file>
+
+<file path=customXml/item50.xml><?xml version="1.0" encoding="utf-8"?>
+<TemplafySlideTemplateConfiguration><![CDATA[{"slideVersion":1,"isValidatorEnabled":false,"isLocked":false,"elementsMetadata":[],"slideId":"637629098780808397","enableDocumentContentUpdater":true,"version":"2.0"}]]></TemplafySlideTemplateConfiguration>
+</file>
+
+<file path=customXml/item51.xml><?xml version="1.0" encoding="utf-8"?>
+<TemplafySlideFormConfiguration><![CDATA[{"formFields":[],"formDataEntries":[]}]]></TemplafySlideFormConfiguration>
+</file>
+
+<file path=customXml/item52.xml><?xml version="1.0" encoding="utf-8"?>
+<TemplafySlideTemplateConfiguration><![CDATA[{"slideVersion":1,"isValidatorEnabled":false,"isLocked":false,"elementsMetadata":[],"slideId":"637629098780810453","enableDocumentContentUpdater":true,"version":"2.0"}]]></TemplafySlideTemplateConfiguration>
+</file>
+
+<file path=customXml/item53.xml><?xml version="1.0" encoding="utf-8"?>
+<TemplafySlideTemplateConfiguration><![CDATA[{"slideVersion":1,"isValidatorEnabled":false,"isLocked":false,"elementsMetadata":[],"slideId":"637629098780819298","enableDocumentContentUpdater":true,"version":"2.0"}]]></TemplafySlideTemplateConfiguration>
+</file>
+
+<file path=customXml/item54.xml><?xml version="1.0" encoding="utf-8"?>
+<TemplafySlideFormConfiguration><![CDATA[{"formFields":[],"formDataEntries":[]}]]></TemplafySlideFormConfiguration>
+</file>
+
+<file path=customXml/item55.xml><?xml version="1.0" encoding="utf-8"?>
+<TemplafySlideFormConfiguration><![CDATA[{"formFields":[],"formDataEntries":[]}]]></TemplafySlideFormConfiguration>
+</file>
+
+<file path=customXml/item56.xml><?xml version="1.0" encoding="utf-8"?>
+<TemplafySlideTemplateConfiguration><![CDATA[{"slideVersion":1,"isValidatorEnabled":false,"isLocked":false,"elementsMetadata":[],"slideId":"637629098780815282","enableDocumentContentUpdater":true,"version":"2.0"}]]></TemplafySlideTemplateConfiguration>
+</file>
+
+<file path=customXml/item57.xml><?xml version="1.0" encoding="utf-8"?>
+<TemplafySlideTemplateConfiguration><![CDATA[{"slideVersion":1,"isValidatorEnabled":false,"isLocked":false,"elementsMetadata":[],"slideId":"637629098780882757","enableDocumentContentUpdater":true,"version":"2.0"}]]></TemplafySlideTemplateConfiguration>
+</file>
+
+<file path=customXml/item58.xml><?xml version="1.0" encoding="utf-8"?>
+<TemplafySlideFormConfiguration><![CDATA[{"formFields":[],"formDataEntries":[]}]]></TemplafySlideFormConfiguration>
+</file>
+
+<file path=customXml/item59.xml><?xml version="1.0" encoding="utf-8"?>
+<TemplafySlideTemplateConfiguration><![CDATA[{"slideVersion":1,"isValidatorEnabled":false,"isLocked":false,"elementsMetadata":[],"slideId":"637629098780802172","enableDocumentContentUpdater":true,"version":"2.0"}]]></TemplafySlideTemplateConfiguration>
+</file>
+
+<file path=customXml/item6.xml><?xml version="1.0" encoding="utf-8"?>
 <p:properties xmlns:p="http://schemas.microsoft.com/office/2006/metadata/properties" xmlns:xsi="http://www.w3.org/2001/XMLSchema-instance" xmlns:pc="http://schemas.microsoft.com/office/infopath/2007/PartnerControls">
   <documentManagement>
     <_ip_UnifiedCompliancePolicyUIAction xmlns="http://schemas.microsoft.com/sharepoint/v3" xsi:nil="true"/>
@@ -36266,39 +36559,23 @@
 </p:properties>
 </file>
 
-<file path=customXml/item2.xml><?xml version="1.0" encoding="utf-8"?>
-<TemplafySlideTemplateConfiguration><![CDATA[{"slideVersion":1,"isValidatorEnabled":false,"isLocked":false,"elementsMetadata":[],"slideId":"637629098780808397","enableDocumentContentUpdater":true,"version":"2.0"}]]></TemplafySlideTemplateConfiguration>
+<file path=customXml/item60.xml><?xml version="1.0" encoding="utf-8"?>
+<TemplafySlideFormConfiguration><![CDATA[{"formFields":[],"formDataEntries":[]}]]></TemplafySlideFormConfiguration>
 </file>
 
-<file path=customXml/item20.xml><?xml version="1.0" encoding="utf-8"?>
-<TemplafySlideTemplateConfiguration><![CDATA[{"slideVersion":1,"isValidatorEnabled":false,"isLocked":false,"elementsMetadata":[],"slideId":"637629098780868991","enableDocumentContentUpdater":true,"version":"2.0"}]]></TemplafySlideTemplateConfiguration>
+<file path=customXml/item61.xml><?xml version="1.0" encoding="utf-8"?>
+<TemplafySlideFormConfiguration><![CDATA[{"formFields":[],"formDataEntries":[]}]]></TemplafySlideFormConfiguration>
 </file>
 
-<file path=customXml/item21.xml><?xml version="1.0" encoding="utf-8"?>
-<TemplafySlideTemplateConfiguration><![CDATA[{"slideVersion":1,"isValidatorEnabled":false,"isLocked":false,"elementsMetadata":[],"slideId":"637629098780882757","enableDocumentContentUpdater":true,"version":"2.0"}]]></TemplafySlideTemplateConfiguration>
+<file path=customXml/item7.xml><?xml version="1.0" encoding="utf-8"?>
+<TemplafySlideFormConfiguration><![CDATA[{"formFields":[],"formDataEntries":[]}]]></TemplafySlideFormConfiguration>
 </file>
 
-<file path=customXml/item22.xml><?xml version="1.0" encoding="utf-8"?>
+<file path=customXml/item8.xml><?xml version="1.0" encoding="utf-8"?>
 <TemplafySlideTemplateConfiguration><![CDATA[{"slideVersion":1,"isValidatorEnabled":false,"isLocked":false,"elementsMetadata":[],"slideId":"637629098780931945","enableDocumentContentUpdater":true,"version":"2.0"}]]></TemplafySlideTemplateConfiguration>
 </file>
 
-<file path=customXml/item23.xml><?xml version="1.0" encoding="utf-8"?>
-<TemplafySlideFormConfiguration><![CDATA[{"formFields":[],"formDataEntries":[]}]]></TemplafySlideFormConfiguration>
-</file>
-
-<file path=customXml/item24.xml><?xml version="1.0" encoding="utf-8"?>
-<TemplafySlideTemplateConfiguration><![CDATA[{"slideVersion":1,"isValidatorEnabled":false,"isLocked":false,"elementsMetadata":[],"slideId":"637629098780810453","enableDocumentContentUpdater":true,"version":"2.0"}]]></TemplafySlideTemplateConfiguration>
-</file>
-
-<file path=customXml/item25.xml><?xml version="1.0" encoding="utf-8"?>
-<TemplafySlideTemplateConfiguration><![CDATA[{"slideVersion":1,"isValidatorEnabled":false,"isLocked":false,"elementsMetadata":[],"slideId":"637629098780812520","enableDocumentContentUpdater":true,"version":"2.0"}]]></TemplafySlideTemplateConfiguration>
-</file>
-
-<file path=customXml/item26.xml><?xml version="1.0" encoding="utf-8"?>
-<TemplafySlideTemplateConfiguration><![CDATA[{"slideVersion":1,"isValidatorEnabled":false,"isLocked":false,"elementsMetadata":[],"slideId":"637629098780815282","enableDocumentContentUpdater":true,"version":"2.0"}]]></TemplafySlideTemplateConfiguration>
-</file>
-
-<file path=customXml/item27.xml><?xml version="1.0" encoding="utf-8"?>
+<file path=customXml/item9.xml><?xml version="1.0" encoding="utf-8"?>
 <ct:contentTypeSchema xmlns:ct="http://schemas.microsoft.com/office/2006/metadata/contentType" xmlns:ma="http://schemas.microsoft.com/office/2006/metadata/properties/metaAttributes" ct:_="" ma:_="" ma:contentTypeName="Document" ma:contentTypeID="0x010100778A2EBC6E34694C80F43E94FCA993B5" ma:contentTypeVersion="14" ma:contentTypeDescription="Create a new document." ma:contentTypeScope="" ma:versionID="1a7ced39ac191f9ec8deffde533b0c1c">
   <xsd:schema xmlns:xsd="http://www.w3.org/2001/XMLSchema" xmlns:xs="http://www.w3.org/2001/XMLSchema" xmlns:p="http://schemas.microsoft.com/office/2006/metadata/properties" xmlns:ns1="http://schemas.microsoft.com/sharepoint/v3" xmlns:ns2="e4aa919a-b200-49cb-beca-4c7e0810321e" xmlns:ns3="06670dda-0291-4061-b6e0-f6c0cb392c51" targetNamespace="http://schemas.microsoft.com/office/2006/metadata/properties" ma:root="true" ma:fieldsID="bedea8c8816a4e5934c808becd103583" ns1:_="" ns2:_="" ns3:_="">
     <xsd:import namespace="http://schemas.microsoft.com/sharepoint/v3"/>
@@ -36532,236 +36809,339 @@
 </ct:contentTypeSchema>
 </file>
 
-<file path=customXml/item28.xml><?xml version="1.0" encoding="utf-8"?>
-<TemplafySlideTemplateConfiguration><![CDATA[{"slideVersion":1,"isValidatorEnabled":false,"isLocked":false,"elementsMetadata":[],"slideId":"637629098780935963","enableDocumentContentUpdater":true,"version":"2.0"}]]></TemplafySlideTemplateConfiguration>
+<file path=customXml/itemProps1.xml><?xml version="1.0" encoding="utf-8"?>
+<ds:datastoreItem xmlns:ds="http://schemas.openxmlformats.org/officeDocument/2006/customXml" ds:itemID="{00BD3ED4-8ED9-4359-B43B-2C197BC490D9}">
+  <ds:schemaRefs/>
+</ds:datastoreItem>
 </file>
 
-<file path=customXml/item29.xml><?xml version="1.0" encoding="utf-8"?>
-<TemplafySlideFormConfiguration><![CDATA[{"formFields":[],"formDataEntries":[]}]]></TemplafySlideFormConfiguration>
+<file path=customXml/itemProps10.xml><?xml version="1.0" encoding="utf-8"?>
+<ds:datastoreItem xmlns:ds="http://schemas.openxmlformats.org/officeDocument/2006/customXml" ds:itemID="{6B831CAE-95E4-452E-B3C5-B76AAD78A52A}">
+  <ds:schemaRefs/>
+</ds:datastoreItem>
 </file>
 
-<file path=customXml/item3.xml><?xml version="1.0" encoding="utf-8"?>
-<TemplafySlideTemplateConfiguration><![CDATA[{"slideVersion":1,"isValidatorEnabled":false,"isLocked":false,"elementsMetadata":[],"slideId":"637629098780863185","enableDocumentContentUpdater":true,"version":"2.0"}]]></TemplafySlideTemplateConfiguration>
+<file path=customXml/itemProps11.xml><?xml version="1.0" encoding="utf-8"?>
+<ds:datastoreItem xmlns:ds="http://schemas.openxmlformats.org/officeDocument/2006/customXml" ds:itemID="{75BD4175-2A6A-457D-B03C-89D272FF4835}">
+  <ds:schemaRefs/>
+</ds:datastoreItem>
 </file>
 
-<file path=customXml/item30.xml><?xml version="1.0" encoding="utf-8"?>
-<TemplafySlideTemplateConfiguration><![CDATA[{"slideVersion":1,"isValidatorEnabled":false,"isLocked":false,"elementsMetadata":[],"slideId":"637629098780818133","enableDocumentContentUpdater":true,"version":"2.0"}]]></TemplafySlideTemplateConfiguration>
+<file path=customXml/itemProps12.xml><?xml version="1.0" encoding="utf-8"?>
+<ds:datastoreItem xmlns:ds="http://schemas.openxmlformats.org/officeDocument/2006/customXml" ds:itemID="{B7066F7B-EA61-4071-B961-E1FA19724DC0}">
+  <ds:schemaRefs/>
+</ds:datastoreItem>
 </file>
 
-<file path=customXml/item31.xml><?xml version="1.0" encoding="utf-8"?>
-<TemplafySlideFormConfiguration><![CDATA[{"formFields":[],"formDataEntries":[]}]]></TemplafySlideFormConfiguration>
+<file path=customXml/itemProps13.xml><?xml version="1.0" encoding="utf-8"?>
+<ds:datastoreItem xmlns:ds="http://schemas.openxmlformats.org/officeDocument/2006/customXml" ds:itemID="{3D719615-E8C3-42D3-B19D-076A1FC4620D}">
+  <ds:schemaRefs/>
+</ds:datastoreItem>
 </file>
 
-<file path=customXml/item32.xml><?xml version="1.0" encoding="utf-8"?>
-<TemplafySlideTemplateConfiguration><![CDATA[{"slideVersion":1,"isValidatorEnabled":false,"isLocked":false,"elementsMetadata":[],"slideId":"637629098780820470","enableDocumentContentUpdater":true,"version":"2.0"}]]></TemplafySlideTemplateConfiguration>
+<file path=customXml/itemProps14.xml><?xml version="1.0" encoding="utf-8"?>
+<ds:datastoreItem xmlns:ds="http://schemas.openxmlformats.org/officeDocument/2006/customXml" ds:itemID="{56A99A3E-A648-468D-B568-4C0AD8B35441}">
+  <ds:schemaRefs/>
+</ds:datastoreItem>
 </file>
 
-<file path=customXml/item33.xml><?xml version="1.0" encoding="utf-8"?>
-<TemplafySlideFormConfiguration><![CDATA[{"formFields":[],"formDataEntries":[]}]]></TemplafySlideFormConfiguration>
+<file path=customXml/itemProps15.xml><?xml version="1.0" encoding="utf-8"?>
+<ds:datastoreItem xmlns:ds="http://schemas.openxmlformats.org/officeDocument/2006/customXml" ds:itemID="{1AB4A281-5EBA-4CA1-A536-6B29C98890B6}">
+  <ds:schemaRefs/>
+</ds:datastoreItem>
 </file>
 
-<file path=customXml/item34.xml><?xml version="1.0" encoding="utf-8"?>
-<TemplafySlideFormConfiguration><![CDATA[{"formFields":[],"formDataEntries":[]}]]></TemplafySlideFormConfiguration>
+<file path=customXml/itemProps16.xml><?xml version="1.0" encoding="utf-8"?>
+<ds:datastoreItem xmlns:ds="http://schemas.openxmlformats.org/officeDocument/2006/customXml" ds:itemID="{7BAA13C3-64B7-4D7A-BA49-B0CCD43E2049}">
+  <ds:schemaRefs/>
+</ds:datastoreItem>
 </file>
 
-<file path=customXml/item35.xml><?xml version="1.0" encoding="utf-8"?>
-<TemplafySlideFormConfiguration><![CDATA[{"formFields":[],"formDataEntries":[]}]]></TemplafySlideFormConfiguration>
+<file path=customXml/itemProps17.xml><?xml version="1.0" encoding="utf-8"?>
+<ds:datastoreItem xmlns:ds="http://schemas.openxmlformats.org/officeDocument/2006/customXml" ds:itemID="{7FD631D3-3AB7-43F0-9FCE-6F65E4127A72}">
+  <ds:schemaRefs/>
+</ds:datastoreItem>
 </file>
 
-<file path=customXml/item36.xml><?xml version="1.0" encoding="utf-8"?>
-<TemplafySlideTemplateConfiguration><![CDATA[{"slideVersion":1,"isValidatorEnabled":false,"isLocked":false,"elementsMetadata":[],"slideId":"637629098780929168","enableDocumentContentUpdater":true,"version":"2.0"}]]></TemplafySlideTemplateConfiguration>
+<file path=customXml/itemProps18.xml><?xml version="1.0" encoding="utf-8"?>
+<ds:datastoreItem xmlns:ds="http://schemas.openxmlformats.org/officeDocument/2006/customXml" ds:itemID="{682BF6E6-8993-4A0E-A615-E24230C37DAC}">
+  <ds:schemaRefs/>
+</ds:datastoreItem>
 </file>
 
-<file path=customXml/item37.xml><?xml version="1.0" encoding="utf-8"?>
-<TemplafySlideFormConfiguration><![CDATA[{"formFields":[],"formDataEntries":[]}]]></TemplafySlideFormConfiguration>
+<file path=customXml/itemProps19.xml><?xml version="1.0" encoding="utf-8"?>
+<ds:datastoreItem xmlns:ds="http://schemas.openxmlformats.org/officeDocument/2006/customXml" ds:itemID="{3915BD4A-04C4-49F2-B0B9-3E7D336EC799}">
+  <ds:schemaRefs/>
+</ds:datastoreItem>
 </file>
 
-<file path=customXml/item38.xml><?xml version="1.0" encoding="utf-8"?>
-<TemplafySlideFormConfiguration><![CDATA[{"formFields":[],"formDataEntries":[]}]]></TemplafySlideFormConfiguration>
+<file path=customXml/itemProps2.xml><?xml version="1.0" encoding="utf-8"?>
+<ds:datastoreItem xmlns:ds="http://schemas.openxmlformats.org/officeDocument/2006/customXml" ds:itemID="{08BA5A9A-BB8B-4F8E-93CD-455474EF7276}">
+  <ds:schemaRefs/>
+</ds:datastoreItem>
 </file>
 
-<file path=customXml/item39.xml><?xml version="1.0" encoding="utf-8"?>
-<TemplafySlideTemplateConfiguration><![CDATA[{"slideVersion":1,"isValidatorEnabled":false,"isLocked":false,"elementsMetadata":[],"slideId":"637629098780874432","enableDocumentContentUpdater":true,"version":"2.0"}]]></TemplafySlideTemplateConfiguration>
+<file path=customXml/itemProps20.xml><?xml version="1.0" encoding="utf-8"?>
+<ds:datastoreItem xmlns:ds="http://schemas.openxmlformats.org/officeDocument/2006/customXml" ds:itemID="{EC53C6C7-14A0-4237-9C9A-FA78B37E53AB}">
+  <ds:schemaRefs/>
+</ds:datastoreItem>
 </file>
 
-<file path=customXml/item4.xml><?xml version="1.0" encoding="utf-8"?>
-<TemplafySlideFormConfiguration><![CDATA[{"formFields":[],"formDataEntries":[]}]]></TemplafySlideFormConfiguration>
+<file path=customXml/itemProps21.xml><?xml version="1.0" encoding="utf-8"?>
+<ds:datastoreItem xmlns:ds="http://schemas.openxmlformats.org/officeDocument/2006/customXml" ds:itemID="{CBB24767-B696-4303-95AD-C1F5811D028F}">
+  <ds:schemaRefs/>
+</ds:datastoreItem>
 </file>
 
-<file path=customXml/item40.xml><?xml version="1.0" encoding="utf-8"?>
-<TemplafySlideTemplateConfiguration><![CDATA[{"slideVersion":1,"isValidatorEnabled":false,"isLocked":false,"elementsMetadata":[],"slideId":"637629098780819298","enableDocumentContentUpdater":true,"version":"2.0"}]]></TemplafySlideTemplateConfiguration>
+<file path=customXml/itemProps22.xml><?xml version="1.0" encoding="utf-8"?>
+<ds:datastoreItem xmlns:ds="http://schemas.openxmlformats.org/officeDocument/2006/customXml" ds:itemID="{9DF1E77E-93BB-43A3-BEC8-6478C2794FA6}">
+  <ds:schemaRefs/>
+</ds:datastoreItem>
 </file>
 
-<file path=customXml/item41.xml><?xml version="1.0" encoding="utf-8"?>
-<TemplafySlideTemplateConfiguration><![CDATA[{"slideVersion":1,"isValidatorEnabled":false,"isLocked":false,"elementsMetadata":[],"slideId":"637629098780898812","enableDocumentContentUpdater":true,"version":"2.0"}]]></TemplafySlideTemplateConfiguration>
+<file path=customXml/itemProps23.xml><?xml version="1.0" encoding="utf-8"?>
+<ds:datastoreItem xmlns:ds="http://schemas.openxmlformats.org/officeDocument/2006/customXml" ds:itemID="{6291F803-2EF0-4E47-96D6-4796950CE6BD}">
+  <ds:schemaRefs/>
+</ds:datastoreItem>
 </file>
 
-<file path=customXml/item42.xml><?xml version="1.0" encoding="utf-8"?>
-<TemplafySlideFormConfiguration><![CDATA[{"formFields":[],"formDataEntries":[]}]]></TemplafySlideFormConfiguration>
+<file path=customXml/itemProps24.xml><?xml version="1.0" encoding="utf-8"?>
+<ds:datastoreItem xmlns:ds="http://schemas.openxmlformats.org/officeDocument/2006/customXml" ds:itemID="{1669606D-CDD4-43E6-985A-81776140D176}">
+  <ds:schemaRefs/>
+</ds:datastoreItem>
 </file>
 
-<file path=customXml/item43.xml><?xml version="1.0" encoding="utf-8"?>
-<TemplafySlideTemplateConfiguration><![CDATA[{"slideVersion":1,"isValidatorEnabled":false,"isLocked":false,"elementsMetadata":[],"slideId":"637629098780864969","enableDocumentContentUpdater":true,"version":"2.0"}]]></TemplafySlideTemplateConfiguration>
+<file path=customXml/itemProps25.xml><?xml version="1.0" encoding="utf-8"?>
+<ds:datastoreItem xmlns:ds="http://schemas.openxmlformats.org/officeDocument/2006/customXml" ds:itemID="{AC107CF9-7144-4997-BE7D-1990BE189C9A}">
+  <ds:schemaRefs/>
+</ds:datastoreItem>
 </file>
 
-<file path=customXml/item44.xml><?xml version="1.0" encoding="utf-8"?>
-<TemplafySlideTemplateConfiguration><![CDATA[{"slideVersion":1,"isValidatorEnabled":false,"isLocked":false,"elementsMetadata":[],"slideId":"637629098780858672","enableDocumentContentUpdater":true,"version":"2.0"}]]></TemplafySlideTemplateConfiguration>
+<file path=customXml/itemProps26.xml><?xml version="1.0" encoding="utf-8"?>
+<ds:datastoreItem xmlns:ds="http://schemas.openxmlformats.org/officeDocument/2006/customXml" ds:itemID="{AD9376BE-3D3E-4586-9139-069C1651B477}">
+  <ds:schemaRefs/>
+</ds:datastoreItem>
 </file>
 
-<file path=customXml/item45.xml><?xml version="1.0" encoding="utf-8"?>
-<TemplafySlideFormConfiguration><![CDATA[{"formFields":[],"formDataEntries":[]}]]></TemplafySlideFormConfiguration>
+<file path=customXml/itemProps27.xml><?xml version="1.0" encoding="utf-8"?>
+<ds:datastoreItem xmlns:ds="http://schemas.openxmlformats.org/officeDocument/2006/customXml" ds:itemID="{95AE8F77-448C-4B7C-8669-DC6D4241F9CE}">
+  <ds:schemaRefs/>
+</ds:datastoreItem>
 </file>
 
-<file path=customXml/item46.xml><?xml version="1.0" encoding="utf-8"?>
-<TemplafyTemplateConfiguration><![CDATA[{"elementsMetadata":[],"transformationConfigurations":[{"colorTheme":"{{DataSources.ColorThemes[\"Corporate\"].ColorTheme}}","disableUpdates":false,"type":"colorTheme"}],"enableDocumentContentUpdater":true,"version":"2.0"}]]></TemplafyTemplateConfiguration>
-</file>
-
-<file path=customXml/item47.xml><?xml version="1.0" encoding="utf-8"?>
-<TemplafySlideTemplateConfiguration><![CDATA[{"slideVersion":1,"isValidatorEnabled":false,"isLocked":false,"elementsMetadata":[],"slideId":"637629098780802172","enableDocumentContentUpdater":true,"version":"2.0"}]]></TemplafySlideTemplateConfiguration>
-</file>
-
-<file path=customXml/item48.xml><?xml version="1.0" encoding="utf-8"?>
-<TemplafySlideFormConfiguration><![CDATA[{"formFields":[],"formDataEntries":[]}]]></TemplafySlideFormConfiguration>
-</file>
-
-<file path=customXml/item49.xml><?xml version="1.0" encoding="utf-8"?>
-<TemplafySlideTemplateConfiguration><![CDATA[{"slideVersion":1,"isValidatorEnabled":false,"isLocked":false,"elementsMetadata":[],"slideId":"637629098780942318","enableDocumentContentUpdater":true,"version":"2.0"}]]></TemplafySlideTemplateConfiguration>
-</file>
-
-<file path=customXml/item5.xml><?xml version="1.0" encoding="utf-8"?>
-<TemplafySlideFormConfiguration><![CDATA[{"formFields":[],"formDataEntries":[]}]]></TemplafySlideFormConfiguration>
-</file>
-
-<file path=customXml/item50.xml><?xml version="1.0" encoding="utf-8"?>
-<?mso-contentType ?>
-<FormTemplates xmlns="http://schemas.microsoft.com/sharepoint/v3/contenttype/forms">
-  <Display>DocumentLibraryForm</Display>
-  <Edit>DocumentLibraryForm</Edit>
-  <New>DocumentLibraryForm</New>
-</FormTemplates>
-</file>
-
-<file path=customXml/item51.xml><?xml version="1.0" encoding="utf-8"?>
-<TemplafySlideFormConfiguration><![CDATA[{"formFields":[],"formDataEntries":[]}]]></TemplafySlideFormConfiguration>
-</file>
-
-<file path=customXml/item52.xml><?xml version="1.0" encoding="utf-8"?>
-<TemplafySlideTemplateConfiguration><![CDATA[{"slideVersion":1,"isValidatorEnabled":false,"isLocked":false,"elementsMetadata":[],"slideId":"637629098780933985","enableDocumentContentUpdater":true,"version":"2.0"}]]></TemplafySlideTemplateConfiguration>
-</file>
-
-<file path=customXml/item53.xml><?xml version="1.0" encoding="utf-8"?>
-<TemplafySlideFormConfiguration><![CDATA[{"formFields":[],"formDataEntries":[]}]]></TemplafySlideFormConfiguration>
-</file>
-
-<file path=customXml/item54.xml><?xml version="1.0" encoding="utf-8"?>
-<TemplafySlideTemplateConfiguration><![CDATA[{"slideVersion":1,"isValidatorEnabled":false,"isLocked":false,"elementsMetadata":[],"slideId":"637629098780805369","enableDocumentContentUpdater":true,"version":"2.0"}]]></TemplafySlideTemplateConfiguration>
-</file>
-
-<file path=customXml/item55.xml><?xml version="1.0" encoding="utf-8"?>
-<TemplafyFormConfiguration><![CDATA[{"formFields":[{"required":false,"placeholder":"Title | Date | Security Setting","lines":1,"shareValue":false,"type":"textBox","name":"Footer","label":"Enter footer description","fullyQualifiedName":"Footer"}],"formDataEntries":[]}]]></TemplafyFormConfiguration>
-</file>
-
-<file path=customXml/item56.xml><?xml version="1.0" encoding="utf-8"?>
-<TemplafySlideTemplateConfiguration><![CDATA[{"slideVersion":1,"isValidatorEnabled":false,"isLocked":false,"elementsMetadata":[],"slideId":"637629098780940360","enableDocumentContentUpdater":true,"version":"2.0"}]]></TemplafySlideTemplateConfiguration>
-</file>
-
-<file path=customXml/item57.xml><?xml version="1.0" encoding="utf-8"?>
-<TemplafySlideFormConfiguration><![CDATA[{"formFields":[],"formDataEntries":[]}]]></TemplafySlideFormConfiguration>
-</file>
-
-<file path=customXml/item58.xml><?xml version="1.0" encoding="utf-8"?>
-<TemplafySlideFormConfiguration><![CDATA[{"formFields":[],"formDataEntries":[]}]]></TemplafySlideFormConfiguration>
-</file>
-
-<file path=customXml/item59.xml><?xml version="1.0" encoding="utf-8"?>
-<TemplafySlideTemplateConfiguration><![CDATA[{"slideVersion":1,"isValidatorEnabled":false,"isLocked":false,"elementsMetadata":[],"slideId":"637629098780855834","enableDocumentContentUpdater":true,"version":"2.0"}]]></TemplafySlideTemplateConfiguration>
-</file>
-
-<file path=customXml/item6.xml><?xml version="1.0" encoding="utf-8"?>
-<TemplafySlideFormConfiguration><![CDATA[{"formFields":[],"formDataEntries":[]}]]></TemplafySlideFormConfiguration>
-</file>
-
-<file path=customXml/item60.xml><?xml version="1.0" encoding="utf-8"?>
-<TemplafySlideFormConfiguration><![CDATA[{"formFields":[],"formDataEntries":[]}]]></TemplafySlideFormConfiguration>
-</file>
-
-<file path=customXml/item61.xml><?xml version="1.0" encoding="utf-8"?>
-<TemplafySlideFormConfiguration><![CDATA[{"formFields":[],"formDataEntries":[]}]]></TemplafySlideFormConfiguration>
-</file>
-
-<file path=customXml/item7.xml><?xml version="1.0" encoding="utf-8"?>
-<TemplafySlideFormConfiguration><![CDATA[{"formFields":[],"formDataEntries":[]}]]></TemplafySlideFormConfiguration>
-</file>
-
-<file path=customXml/item8.xml><?xml version="1.0" encoding="utf-8"?>
-<TemplafySlideTemplateConfiguration><![CDATA[{"slideVersion":1,"isValidatorEnabled":false,"isLocked":false,"elementsMetadata":[],"slideId":"637629098780944294","enableDocumentContentUpdater":true,"version":"2.0"}]]></TemplafySlideTemplateConfiguration>
-</file>
-
-<file path=customXml/item9.xml><?xml version="1.0" encoding="utf-8"?>
-<TemplafySlideTemplateConfiguration><![CDATA[{"slideVersion":1,"isValidatorEnabled":false,"isLocked":false,"elementsMetadata":[],"slideId":"637629098780938389","enableDocumentContentUpdater":true,"version":"2.0"}]]></TemplafySlideTemplateConfiguration>
-</file>
-
-<file path=customXml/itemProps1.xml><?xml version="1.0" encoding="utf-8"?>
+<file path=customXml/itemProps28.xml><?xml version="1.0" encoding="utf-8"?>
 <ds:datastoreItem xmlns:ds="http://schemas.openxmlformats.org/officeDocument/2006/customXml" ds:itemID="{7C5C44AF-FBA1-4FF3-8C07-71728D2581FD}">
   <ds:schemaRefs/>
 </ds:datastoreItem>
 </file>
 
-<file path=customXml/itemProps10.xml><?xml version="1.0" encoding="utf-8"?>
+<file path=customXml/itemProps29.xml><?xml version="1.0" encoding="utf-8"?>
+<ds:datastoreItem xmlns:ds="http://schemas.openxmlformats.org/officeDocument/2006/customXml" ds:itemID="{647B6612-4C79-45CE-9A32-14C2D37B46F1}">
+  <ds:schemaRefs/>
+</ds:datastoreItem>
+</file>
+
+<file path=customXml/itemProps3.xml><?xml version="1.0" encoding="utf-8"?>
+<ds:datastoreItem xmlns:ds="http://schemas.openxmlformats.org/officeDocument/2006/customXml" ds:itemID="{0A230136-8CEC-4C29-A55A-F5FA83CA887A}">
+  <ds:schemaRefs/>
+</ds:datastoreItem>
+</file>
+
+<file path=customXml/itemProps30.xml><?xml version="1.0" encoding="utf-8"?>
+<ds:datastoreItem xmlns:ds="http://schemas.openxmlformats.org/officeDocument/2006/customXml" ds:itemID="{162E1B2B-387B-423C-8FB0-129D0EE7DD83}">
+  <ds:schemaRefs/>
+</ds:datastoreItem>
+</file>
+
+<file path=customXml/itemProps31.xml><?xml version="1.0" encoding="utf-8"?>
+<ds:datastoreItem xmlns:ds="http://schemas.openxmlformats.org/officeDocument/2006/customXml" ds:itemID="{65B44A9F-1851-42AC-AD3C-FFC343A07D3A}">
+  <ds:schemaRefs/>
+</ds:datastoreItem>
+</file>
+
+<file path=customXml/itemProps32.xml><?xml version="1.0" encoding="utf-8"?>
+<ds:datastoreItem xmlns:ds="http://schemas.openxmlformats.org/officeDocument/2006/customXml" ds:itemID="{1D3A887C-FC1C-482E-BE66-F9B66B0A6227}">
+  <ds:schemaRefs/>
+</ds:datastoreItem>
+</file>
+
+<file path=customXml/itemProps33.xml><?xml version="1.0" encoding="utf-8"?>
+<ds:datastoreItem xmlns:ds="http://schemas.openxmlformats.org/officeDocument/2006/customXml" ds:itemID="{0C0AD6D7-0AAB-4CF7-9869-E9E315BAF875}">
+  <ds:schemaRefs/>
+</ds:datastoreItem>
+</file>
+
+<file path=customXml/itemProps34.xml><?xml version="1.0" encoding="utf-8"?>
+<ds:datastoreItem xmlns:ds="http://schemas.openxmlformats.org/officeDocument/2006/customXml" ds:itemID="{30338C60-725E-4230-8732-6C1737FFCF6F}">
+  <ds:schemaRefs/>
+</ds:datastoreItem>
+</file>
+
+<file path=customXml/itemProps35.xml><?xml version="1.0" encoding="utf-8"?>
+<ds:datastoreItem xmlns:ds="http://schemas.openxmlformats.org/officeDocument/2006/customXml" ds:itemID="{AE04A922-1222-46EA-85D1-620CD08A927B}">
+  <ds:schemaRefs/>
+</ds:datastoreItem>
+</file>
+
+<file path=customXml/itemProps36.xml><?xml version="1.0" encoding="utf-8"?>
 <ds:datastoreItem xmlns:ds="http://schemas.openxmlformats.org/officeDocument/2006/customXml" ds:itemID="{FC77B9F3-C094-489B-8C01-F272F0AF68C6}">
   <ds:schemaRefs/>
 </ds:datastoreItem>
 </file>
 
-<file path=customXml/itemProps11.xml><?xml version="1.0" encoding="utf-8"?>
-<ds:datastoreItem xmlns:ds="http://schemas.openxmlformats.org/officeDocument/2006/customXml" ds:itemID="{6A0018E2-8AA5-4CE6-A43B-7E69D37BB663}">
+<file path=customXml/itemProps37.xml><?xml version="1.0" encoding="utf-8"?>
+<ds:datastoreItem xmlns:ds="http://schemas.openxmlformats.org/officeDocument/2006/customXml" ds:itemID="{C67D3CDE-4F82-4339-9EA4-1EEE33A61958}">
   <ds:schemaRefs/>
 </ds:datastoreItem>
 </file>
 
-<file path=customXml/itemProps12.xml><?xml version="1.0" encoding="utf-8"?>
-<ds:datastoreItem xmlns:ds="http://schemas.openxmlformats.org/officeDocument/2006/customXml" ds:itemID="{682BF6E6-8993-4A0E-A615-E24230C37DAC}">
+<file path=customXml/itemProps38.xml><?xml version="1.0" encoding="utf-8"?>
+<ds:datastoreItem xmlns:ds="http://schemas.openxmlformats.org/officeDocument/2006/customXml" ds:itemID="{C89A946A-C258-4267-A263-69DA8374B547}">
   <ds:schemaRefs/>
 </ds:datastoreItem>
 </file>
 
-<file path=customXml/itemProps13.xml><?xml version="1.0" encoding="utf-8"?>
+<file path=customXml/itemProps39.xml><?xml version="1.0" encoding="utf-8"?>
+<ds:datastoreItem xmlns:ds="http://schemas.openxmlformats.org/officeDocument/2006/customXml" ds:itemID="{364650BF-04B4-4ADF-AE61-286BFE5AF2AD}">
+  <ds:schemaRefs/>
+</ds:datastoreItem>
+</file>
+
+<file path=customXml/itemProps4.xml><?xml version="1.0" encoding="utf-8"?>
+<ds:datastoreItem xmlns:ds="http://schemas.openxmlformats.org/officeDocument/2006/customXml" ds:itemID="{33C2836D-CD36-48F0-AE3F-D27BFE792AB7}">
+  <ds:schemaRefs/>
+</ds:datastoreItem>
+</file>
+
+<file path=customXml/itemProps40.xml><?xml version="1.0" encoding="utf-8"?>
+<ds:datastoreItem xmlns:ds="http://schemas.openxmlformats.org/officeDocument/2006/customXml" ds:itemID="{25EDB0A7-1862-4F58-81F8-88FFEB27A481}">
+  <ds:schemaRefs/>
+</ds:datastoreItem>
+</file>
+
+<file path=customXml/itemProps41.xml><?xml version="1.0" encoding="utf-8"?>
+<ds:datastoreItem xmlns:ds="http://schemas.openxmlformats.org/officeDocument/2006/customXml" ds:itemID="{8C320EF3-E45D-49A1-86A9-B0DA20C7CC04}">
+  <ds:schemaRefs/>
+</ds:datastoreItem>
+</file>
+
+<file path=customXml/itemProps42.xml><?xml version="1.0" encoding="utf-8"?>
+<ds:datastoreItem xmlns:ds="http://schemas.openxmlformats.org/officeDocument/2006/customXml" ds:itemID="{A20E27A4-6C3C-428D-ADE7-7DC089C0CD46}">
+  <ds:schemaRefs/>
+</ds:datastoreItem>
+</file>
+
+<file path=customXml/itemProps43.xml><?xml version="1.0" encoding="utf-8"?>
 <ds:datastoreItem xmlns:ds="http://schemas.openxmlformats.org/officeDocument/2006/customXml" ds:itemID="{921C0A0B-EE13-4908-9C41-3E7EDF526068}">
   <ds:schemaRefs/>
 </ds:datastoreItem>
 </file>
 
-<file path=customXml/itemProps14.xml><?xml version="1.0" encoding="utf-8"?>
-<ds:datastoreItem xmlns:ds="http://schemas.openxmlformats.org/officeDocument/2006/customXml" ds:itemID="{C5DD1971-334A-45E9-9D2B-FB6BD8AAE58A}">
-  <ds:schemaRefs/>
-</ds:datastoreItem>
-</file>
-
-<file path=customXml/itemProps15.xml><?xml version="1.0" encoding="utf-8"?>
-<ds:datastoreItem xmlns:ds="http://schemas.openxmlformats.org/officeDocument/2006/customXml" ds:itemID="{162E1B2B-387B-423C-8FB0-129D0EE7DD83}">
-  <ds:schemaRefs/>
-</ds:datastoreItem>
-</file>
-
-<file path=customXml/itemProps16.xml><?xml version="1.0" encoding="utf-8"?>
-<ds:datastoreItem xmlns:ds="http://schemas.openxmlformats.org/officeDocument/2006/customXml" ds:itemID="{D5DFDA8F-B725-4CD6-A843-7349EA123794}">
-  <ds:schemaRefs/>
-</ds:datastoreItem>
-</file>
-
-<file path=customXml/itemProps17.xml><?xml version="1.0" encoding="utf-8"?>
-<ds:datastoreItem xmlns:ds="http://schemas.openxmlformats.org/officeDocument/2006/customXml" ds:itemID="{3915BD4A-04C4-49F2-B0B9-3E7D336EC799}">
-  <ds:schemaRefs/>
-</ds:datastoreItem>
-</file>
-
-<file path=customXml/itemProps18.xml><?xml version="1.0" encoding="utf-8"?>
+<file path=customXml/itemProps44.xml><?xml version="1.0" encoding="utf-8"?>
 <ds:datastoreItem xmlns:ds="http://schemas.openxmlformats.org/officeDocument/2006/customXml" ds:itemID="{D4B66AC3-71C4-4908-9595-93E8B8D76E97}">
   <ds:schemaRefs/>
 </ds:datastoreItem>
 </file>
 
-<file path=customXml/itemProps19.xml><?xml version="1.0" encoding="utf-8"?>
+<file path=customXml/itemProps45.xml><?xml version="1.0" encoding="utf-8"?>
+<ds:datastoreItem xmlns:ds="http://schemas.openxmlformats.org/officeDocument/2006/customXml" ds:itemID="{2BC0DC1D-8D15-4194-9A1A-EDACA544CFA6}">
+  <ds:schemaRefs/>
+</ds:datastoreItem>
+</file>
+
+<file path=customXml/itemProps46.xml><?xml version="1.0" encoding="utf-8"?>
+<ds:datastoreItem xmlns:ds="http://schemas.openxmlformats.org/officeDocument/2006/customXml" ds:itemID="{F82E9EAE-C942-4F71-8479-8192B35558E2}">
+  <ds:schemaRefs/>
+</ds:datastoreItem>
+</file>
+
+<file path=customXml/itemProps47.xml><?xml version="1.0" encoding="utf-8"?>
+<ds:datastoreItem xmlns:ds="http://schemas.openxmlformats.org/officeDocument/2006/customXml" ds:itemID="{758FDAC0-319D-4A54-8D8E-1D42CB1F8004}">
+  <ds:schemaRefs>
+    <ds:schemaRef ds:uri="http://schemas.microsoft.com/sharepoint/v3/contenttype/forms"/>
+  </ds:schemaRefs>
+</ds:datastoreItem>
+</file>
+
+<file path=customXml/itemProps48.xml><?xml version="1.0" encoding="utf-8"?>
+<ds:datastoreItem xmlns:ds="http://schemas.openxmlformats.org/officeDocument/2006/customXml" ds:itemID="{43BC5722-1D5B-4915-8247-E6D5F513E549}">
+  <ds:schemaRefs/>
+</ds:datastoreItem>
+</file>
+
+<file path=customXml/itemProps49.xml><?xml version="1.0" encoding="utf-8"?>
+<ds:datastoreItem xmlns:ds="http://schemas.openxmlformats.org/officeDocument/2006/customXml" ds:itemID="{2A1B10AF-5356-4D21-9E16-9423E20937FC}">
+  <ds:schemaRefs/>
+</ds:datastoreItem>
+</file>
+
+<file path=customXml/itemProps5.xml><?xml version="1.0" encoding="utf-8"?>
+<ds:datastoreItem xmlns:ds="http://schemas.openxmlformats.org/officeDocument/2006/customXml" ds:itemID="{988BE19C-289C-4D51-AC33-2691C170DBEA}">
+  <ds:schemaRefs/>
+</ds:datastoreItem>
+</file>
+
+<file path=customXml/itemProps50.xml><?xml version="1.0" encoding="utf-8"?>
+<ds:datastoreItem xmlns:ds="http://schemas.openxmlformats.org/officeDocument/2006/customXml" ds:itemID="{1BCEDA00-0BCE-4F19-A380-8AED6A66E762}">
+  <ds:schemaRefs/>
+</ds:datastoreItem>
+</file>
+
+<file path=customXml/itemProps51.xml><?xml version="1.0" encoding="utf-8"?>
+<ds:datastoreItem xmlns:ds="http://schemas.openxmlformats.org/officeDocument/2006/customXml" ds:itemID="{00121D97-98F5-4946-8A5D-87D090F11338}">
+  <ds:schemaRefs/>
+</ds:datastoreItem>
+</file>
+
+<file path=customXml/itemProps52.xml><?xml version="1.0" encoding="utf-8"?>
+<ds:datastoreItem xmlns:ds="http://schemas.openxmlformats.org/officeDocument/2006/customXml" ds:itemID="{915452D2-9D6B-41D9-99FD-4D1CF211FA39}">
+  <ds:schemaRefs/>
+</ds:datastoreItem>
+</file>
+
+<file path=customXml/itemProps53.xml><?xml version="1.0" encoding="utf-8"?>
+<ds:datastoreItem xmlns:ds="http://schemas.openxmlformats.org/officeDocument/2006/customXml" ds:itemID="{56B316EE-D9D1-44C3-8C00-AE433A63C836}">
+  <ds:schemaRefs/>
+</ds:datastoreItem>
+</file>
+
+<file path=customXml/itemProps54.xml><?xml version="1.0" encoding="utf-8"?>
+<ds:datastoreItem xmlns:ds="http://schemas.openxmlformats.org/officeDocument/2006/customXml" ds:itemID="{DDCC6A1B-7673-40E9-AC3E-C0D8F2784A83}">
+  <ds:schemaRefs/>
+</ds:datastoreItem>
+</file>
+
+<file path=customXml/itemProps55.xml><?xml version="1.0" encoding="utf-8"?>
+<ds:datastoreItem xmlns:ds="http://schemas.openxmlformats.org/officeDocument/2006/customXml" ds:itemID="{2EF89111-4289-441B-97BD-A2D8E126532F}">
+  <ds:schemaRefs/>
+</ds:datastoreItem>
+</file>
+
+<file path=customXml/itemProps56.xml><?xml version="1.0" encoding="utf-8"?>
+<ds:datastoreItem xmlns:ds="http://schemas.openxmlformats.org/officeDocument/2006/customXml" ds:itemID="{E4C8E36C-E4C3-4DF8-B9A8-546312449852}">
+  <ds:schemaRefs/>
+</ds:datastoreItem>
+</file>
+
+<file path=customXml/itemProps57.xml><?xml version="1.0" encoding="utf-8"?>
+<ds:datastoreItem xmlns:ds="http://schemas.openxmlformats.org/officeDocument/2006/customXml" ds:itemID="{5265E46D-0749-47B1-8243-3C63764C0EFC}">
+  <ds:schemaRefs/>
+</ds:datastoreItem>
+</file>
+
+<file path=customXml/itemProps58.xml><?xml version="1.0" encoding="utf-8"?>
+<ds:datastoreItem xmlns:ds="http://schemas.openxmlformats.org/officeDocument/2006/customXml" ds:itemID="{E3B787A2-A83F-4E87-A90A-111C61F62E24}">
+  <ds:schemaRefs/>
+</ds:datastoreItem>
+</file>
+
+<file path=customXml/itemProps59.xml><?xml version="1.0" encoding="utf-8"?>
+<ds:datastoreItem xmlns:ds="http://schemas.openxmlformats.org/officeDocument/2006/customXml" ds:itemID="{BE3BB7DD-0C86-4747-A387-5C5D191BB970}">
+  <ds:schemaRefs/>
+</ds:datastoreItem>
+</file>
+
+<file path=customXml/itemProps6.xml><?xml version="1.0" encoding="utf-8"?>
 <ds:datastoreItem xmlns:ds="http://schemas.openxmlformats.org/officeDocument/2006/customXml" ds:itemID="{F990F116-B58F-4255-B05B-DA3808E0E5C6}">
   <ds:schemaRefs>
     <ds:schemaRef ds:uri="http://schemas.openxmlformats.org/package/2006/metadata/core-properties"/>
@@ -36779,55 +37159,31 @@
 </ds:datastoreItem>
 </file>
 
-<file path=customXml/itemProps2.xml><?xml version="1.0" encoding="utf-8"?>
-<ds:datastoreItem xmlns:ds="http://schemas.openxmlformats.org/officeDocument/2006/customXml" ds:itemID="{1BCEDA00-0BCE-4F19-A380-8AED6A66E762}">
+<file path=customXml/itemProps60.xml><?xml version="1.0" encoding="utf-8"?>
+<ds:datastoreItem xmlns:ds="http://schemas.openxmlformats.org/officeDocument/2006/customXml" ds:itemID="{D5DFDA8F-B725-4CD6-A843-7349EA123794}">
   <ds:schemaRefs/>
 </ds:datastoreItem>
 </file>
 
-<file path=customXml/itemProps20.xml><?xml version="1.0" encoding="utf-8"?>
-<ds:datastoreItem xmlns:ds="http://schemas.openxmlformats.org/officeDocument/2006/customXml" ds:itemID="{AC107CF9-7144-4997-BE7D-1990BE189C9A}">
+<file path=customXml/itemProps61.xml><?xml version="1.0" encoding="utf-8"?>
+<ds:datastoreItem xmlns:ds="http://schemas.openxmlformats.org/officeDocument/2006/customXml" ds:itemID="{6A0018E2-8AA5-4CE6-A43B-7E69D37BB663}">
   <ds:schemaRefs/>
 </ds:datastoreItem>
 </file>
 
-<file path=customXml/itemProps21.xml><?xml version="1.0" encoding="utf-8"?>
-<ds:datastoreItem xmlns:ds="http://schemas.openxmlformats.org/officeDocument/2006/customXml" ds:itemID="{5265E46D-0749-47B1-8243-3C63764C0EFC}">
+<file path=customXml/itemProps7.xml><?xml version="1.0" encoding="utf-8"?>
+<ds:datastoreItem xmlns:ds="http://schemas.openxmlformats.org/officeDocument/2006/customXml" ds:itemID="{C5DD1971-334A-45E9-9D2B-FB6BD8AAE58A}">
   <ds:schemaRefs/>
 </ds:datastoreItem>
 </file>
 
-<file path=customXml/itemProps22.xml><?xml version="1.0" encoding="utf-8"?>
+<file path=customXml/itemProps8.xml><?xml version="1.0" encoding="utf-8"?>
 <ds:datastoreItem xmlns:ds="http://schemas.openxmlformats.org/officeDocument/2006/customXml" ds:itemID="{CAFED163-E143-4EEB-A735-81C1226AD9B4}">
   <ds:schemaRefs/>
 </ds:datastoreItem>
 </file>
 
-<file path=customXml/itemProps23.xml><?xml version="1.0" encoding="utf-8"?>
-<ds:datastoreItem xmlns:ds="http://schemas.openxmlformats.org/officeDocument/2006/customXml" ds:itemID="{65B44A9F-1851-42AC-AD3C-FFC343A07D3A}">
-  <ds:schemaRefs/>
-</ds:datastoreItem>
-</file>
-
-<file path=customXml/itemProps24.xml><?xml version="1.0" encoding="utf-8"?>
-<ds:datastoreItem xmlns:ds="http://schemas.openxmlformats.org/officeDocument/2006/customXml" ds:itemID="{915452D2-9D6B-41D9-99FD-4D1CF211FA39}">
-  <ds:schemaRefs/>
-</ds:datastoreItem>
-</file>
-
-<file path=customXml/itemProps25.xml><?xml version="1.0" encoding="utf-8"?>
-<ds:datastoreItem xmlns:ds="http://schemas.openxmlformats.org/officeDocument/2006/customXml" ds:itemID="{EC53C6C7-14A0-4237-9C9A-FA78B37E53AB}">
-  <ds:schemaRefs/>
-</ds:datastoreItem>
-</file>
-
-<file path=customXml/itemProps26.xml><?xml version="1.0" encoding="utf-8"?>
-<ds:datastoreItem xmlns:ds="http://schemas.openxmlformats.org/officeDocument/2006/customXml" ds:itemID="{E4C8E36C-E4C3-4DF8-B9A8-546312449852}">
-  <ds:schemaRefs/>
-</ds:datastoreItem>
-</file>
-
-<file path=customXml/itemProps27.xml><?xml version="1.0" encoding="utf-8"?>
+<file path=customXml/itemProps9.xml><?xml version="1.0" encoding="utf-8"?>
 <ds:datastoreItem xmlns:ds="http://schemas.openxmlformats.org/officeDocument/2006/customXml" ds:itemID="{0BB3C309-8520-4616-80FC-2CB10D5B83A0}">
   <ds:schemaRefs>
     <ds:schemaRef ds:uri="http://schemas.microsoft.com/office/2006/metadata/contentType"/>
@@ -36847,254 +37203,6 @@
 </ds:datastoreItem>
 </file>
 
-<file path=customXml/itemProps28.xml><?xml version="1.0" encoding="utf-8"?>
-<ds:datastoreItem xmlns:ds="http://schemas.openxmlformats.org/officeDocument/2006/customXml" ds:itemID="{1D3A887C-FC1C-482E-BE66-F9B66B0A6227}">
-  <ds:schemaRefs/>
-</ds:datastoreItem>
-</file>
-
-<file path=customXml/itemProps29.xml><?xml version="1.0" encoding="utf-8"?>
-<ds:datastoreItem xmlns:ds="http://schemas.openxmlformats.org/officeDocument/2006/customXml" ds:itemID="{00121D97-98F5-4946-8A5D-87D090F11338}">
-  <ds:schemaRefs/>
-</ds:datastoreItem>
-</file>
-
-<file path=customXml/itemProps3.xml><?xml version="1.0" encoding="utf-8"?>
-<ds:datastoreItem xmlns:ds="http://schemas.openxmlformats.org/officeDocument/2006/customXml" ds:itemID="{7FD631D3-3AB7-43F0-9FCE-6F65E4127A72}">
-  <ds:schemaRefs/>
-</ds:datastoreItem>
-</file>
-
-<file path=customXml/itemProps30.xml><?xml version="1.0" encoding="utf-8"?>
-<ds:datastoreItem xmlns:ds="http://schemas.openxmlformats.org/officeDocument/2006/customXml" ds:itemID="{6B831CAE-95E4-452E-B3C5-B76AAD78A52A}">
-  <ds:schemaRefs/>
-</ds:datastoreItem>
-</file>
-
-<file path=customXml/itemProps31.xml><?xml version="1.0" encoding="utf-8"?>
-<ds:datastoreItem xmlns:ds="http://schemas.openxmlformats.org/officeDocument/2006/customXml" ds:itemID="{C67D3CDE-4F82-4339-9EA4-1EEE33A61958}">
-  <ds:schemaRefs/>
-</ds:datastoreItem>
-</file>
-
-<file path=customXml/itemProps32.xml><?xml version="1.0" encoding="utf-8"?>
-<ds:datastoreItem xmlns:ds="http://schemas.openxmlformats.org/officeDocument/2006/customXml" ds:itemID="{00BD3ED4-8ED9-4359-B43B-2C197BC490D9}">
-  <ds:schemaRefs/>
-</ds:datastoreItem>
-</file>
-
-<file path=customXml/itemProps33.xml><?xml version="1.0" encoding="utf-8"?>
-<ds:datastoreItem xmlns:ds="http://schemas.openxmlformats.org/officeDocument/2006/customXml" ds:itemID="{CBB24767-B696-4303-95AD-C1F5811D028F}">
-  <ds:schemaRefs/>
-</ds:datastoreItem>
-</file>
-
-<file path=customXml/itemProps34.xml><?xml version="1.0" encoding="utf-8"?>
-<ds:datastoreItem xmlns:ds="http://schemas.openxmlformats.org/officeDocument/2006/customXml" ds:itemID="{F82E9EAE-C942-4F71-8479-8192B35558E2}">
-  <ds:schemaRefs/>
-</ds:datastoreItem>
-</file>
-
-<file path=customXml/itemProps35.xml><?xml version="1.0" encoding="utf-8"?>
-<ds:datastoreItem xmlns:ds="http://schemas.openxmlformats.org/officeDocument/2006/customXml" ds:itemID="{75BD4175-2A6A-457D-B03C-89D272FF4835}">
-  <ds:schemaRefs/>
-</ds:datastoreItem>
-</file>
-
-<file path=customXml/itemProps36.xml><?xml version="1.0" encoding="utf-8"?>
-<ds:datastoreItem xmlns:ds="http://schemas.openxmlformats.org/officeDocument/2006/customXml" ds:itemID="{0C0AD6D7-0AAB-4CF7-9869-E9E315BAF875}">
-  <ds:schemaRefs/>
-</ds:datastoreItem>
-</file>
-
-<file path=customXml/itemProps37.xml><?xml version="1.0" encoding="utf-8"?>
-<ds:datastoreItem xmlns:ds="http://schemas.openxmlformats.org/officeDocument/2006/customXml" ds:itemID="{08BA5A9A-BB8B-4F8E-93CD-455474EF7276}">
-  <ds:schemaRefs/>
-</ds:datastoreItem>
-</file>
-
-<file path=customXml/itemProps38.xml><?xml version="1.0" encoding="utf-8"?>
-<ds:datastoreItem xmlns:ds="http://schemas.openxmlformats.org/officeDocument/2006/customXml" ds:itemID="{9DF1E77E-93BB-43A3-BEC8-6478C2794FA6}">
-  <ds:schemaRefs/>
-</ds:datastoreItem>
-</file>
-
-<file path=customXml/itemProps39.xml><?xml version="1.0" encoding="utf-8"?>
-<ds:datastoreItem xmlns:ds="http://schemas.openxmlformats.org/officeDocument/2006/customXml" ds:itemID="{2BC0DC1D-8D15-4194-9A1A-EDACA544CFA6}">
-  <ds:schemaRefs/>
-</ds:datastoreItem>
-</file>
-
-<file path=customXml/itemProps4.xml><?xml version="1.0" encoding="utf-8"?>
-<ds:datastoreItem xmlns:ds="http://schemas.openxmlformats.org/officeDocument/2006/customXml" ds:itemID="{8C320EF3-E45D-49A1-86A9-B0DA20C7CC04}">
-  <ds:schemaRefs/>
-</ds:datastoreItem>
-</file>
-
-<file path=customXml/itemProps40.xml><?xml version="1.0" encoding="utf-8"?>
-<ds:datastoreItem xmlns:ds="http://schemas.openxmlformats.org/officeDocument/2006/customXml" ds:itemID="{56B316EE-D9D1-44C3-8C00-AE433A63C836}">
-  <ds:schemaRefs/>
-</ds:datastoreItem>
-</file>
-
-<file path=customXml/itemProps41.xml><?xml version="1.0" encoding="utf-8"?>
-<ds:datastoreItem xmlns:ds="http://schemas.openxmlformats.org/officeDocument/2006/customXml" ds:itemID="{AD9376BE-3D3E-4586-9139-069C1651B477}">
-  <ds:schemaRefs/>
-</ds:datastoreItem>
-</file>
-
-<file path=customXml/itemProps42.xml><?xml version="1.0" encoding="utf-8"?>
-<ds:datastoreItem xmlns:ds="http://schemas.openxmlformats.org/officeDocument/2006/customXml" ds:itemID="{E3B787A2-A83F-4E87-A90A-111C61F62E24}">
-  <ds:schemaRefs/>
-</ds:datastoreItem>
-</file>
-
-<file path=customXml/itemProps43.xml><?xml version="1.0" encoding="utf-8"?>
-<ds:datastoreItem xmlns:ds="http://schemas.openxmlformats.org/officeDocument/2006/customXml" ds:itemID="{B7066F7B-EA61-4071-B961-E1FA19724DC0}">
-  <ds:schemaRefs/>
-</ds:datastoreItem>
-</file>
-
-<file path=customXml/itemProps44.xml><?xml version="1.0" encoding="utf-8"?>
-<ds:datastoreItem xmlns:ds="http://schemas.openxmlformats.org/officeDocument/2006/customXml" ds:itemID="{C89A946A-C258-4267-A263-69DA8374B547}">
-  <ds:schemaRefs/>
-</ds:datastoreItem>
-</file>
-
-<file path=customXml/itemProps45.xml><?xml version="1.0" encoding="utf-8"?>
-<ds:datastoreItem xmlns:ds="http://schemas.openxmlformats.org/officeDocument/2006/customXml" ds:itemID="{DDCC6A1B-7673-40E9-AC3E-C0D8F2784A83}">
-  <ds:schemaRefs/>
-</ds:datastoreItem>
-</file>
-
-<file path=customXml/itemProps46.xml><?xml version="1.0" encoding="utf-8"?>
-<ds:datastoreItem xmlns:ds="http://schemas.openxmlformats.org/officeDocument/2006/customXml" ds:itemID="{6291F803-2EF0-4E47-96D6-4796950CE6BD}">
-  <ds:schemaRefs/>
-</ds:datastoreItem>
-</file>
-
-<file path=customXml/itemProps47.xml><?xml version="1.0" encoding="utf-8"?>
-<ds:datastoreItem xmlns:ds="http://schemas.openxmlformats.org/officeDocument/2006/customXml" ds:itemID="{BE3BB7DD-0C86-4747-A387-5C5D191BB970}">
-  <ds:schemaRefs/>
-</ds:datastoreItem>
-</file>
-
-<file path=customXml/itemProps48.xml><?xml version="1.0" encoding="utf-8"?>
-<ds:datastoreItem xmlns:ds="http://schemas.openxmlformats.org/officeDocument/2006/customXml" ds:itemID="{3D719615-E8C3-42D3-B19D-076A1FC4620D}">
-  <ds:schemaRefs/>
-</ds:datastoreItem>
-</file>
-
-<file path=customXml/itemProps49.xml><?xml version="1.0" encoding="utf-8"?>
-<ds:datastoreItem xmlns:ds="http://schemas.openxmlformats.org/officeDocument/2006/customXml" ds:itemID="{30338C60-725E-4230-8732-6C1737FFCF6F}">
-  <ds:schemaRefs/>
-</ds:datastoreItem>
-</file>
-
-<file path=customXml/itemProps5.xml><?xml version="1.0" encoding="utf-8"?>
-<ds:datastoreItem xmlns:ds="http://schemas.openxmlformats.org/officeDocument/2006/customXml" ds:itemID="{988BE19C-289C-4D51-AC33-2691C170DBEA}">
-  <ds:schemaRefs/>
-</ds:datastoreItem>
-</file>
-
-<file path=customXml/itemProps50.xml><?xml version="1.0" encoding="utf-8"?>
-<ds:datastoreItem xmlns:ds="http://schemas.openxmlformats.org/officeDocument/2006/customXml" ds:itemID="{758FDAC0-319D-4A54-8D8E-1D42CB1F8004}">
-  <ds:schemaRefs>
-    <ds:schemaRef ds:uri="http://schemas.microsoft.com/sharepoint/v3/contenttype/forms"/>
-  </ds:schemaRefs>
-</ds:datastoreItem>
-</file>
-
-<file path=customXml/itemProps51.xml><?xml version="1.0" encoding="utf-8"?>
-<ds:datastoreItem xmlns:ds="http://schemas.openxmlformats.org/officeDocument/2006/customXml" ds:itemID="{7BAA13C3-64B7-4D7A-BA49-B0CCD43E2049}">
-  <ds:schemaRefs/>
-</ds:datastoreItem>
-</file>
-
-<file path=customXml/itemProps52.xml><?xml version="1.0" encoding="utf-8"?>
-<ds:datastoreItem xmlns:ds="http://schemas.openxmlformats.org/officeDocument/2006/customXml" ds:itemID="{364650BF-04B4-4ADF-AE61-286BFE5AF2AD}">
-  <ds:schemaRefs/>
-</ds:datastoreItem>
-</file>
-
-<file path=customXml/itemProps53.xml><?xml version="1.0" encoding="utf-8"?>
-<ds:datastoreItem xmlns:ds="http://schemas.openxmlformats.org/officeDocument/2006/customXml" ds:itemID="{0A230136-8CEC-4C29-A55A-F5FA83CA887A}">
-  <ds:schemaRefs/>
-</ds:datastoreItem>
-</file>
-
-<file path=customXml/itemProps54.xml><?xml version="1.0" encoding="utf-8"?>
-<ds:datastoreItem xmlns:ds="http://schemas.openxmlformats.org/officeDocument/2006/customXml" ds:itemID="{95AE8F77-448C-4B7C-8669-DC6D4241F9CE}">
-  <ds:schemaRefs/>
-</ds:datastoreItem>
-</file>
-
-<file path=customXml/itemProps55.xml><?xml version="1.0" encoding="utf-8"?>
-<ds:datastoreItem xmlns:ds="http://schemas.openxmlformats.org/officeDocument/2006/customXml" ds:itemID="{43BC5722-1D5B-4915-8247-E6D5F513E549}">
-  <ds:schemaRefs/>
-</ds:datastoreItem>
-</file>
-
-<file path=customXml/itemProps56.xml><?xml version="1.0" encoding="utf-8"?>
-<ds:datastoreItem xmlns:ds="http://schemas.openxmlformats.org/officeDocument/2006/customXml" ds:itemID="{56A99A3E-A648-468D-B568-4C0AD8B35441}">
-  <ds:schemaRefs/>
-</ds:datastoreItem>
-</file>
-
-<file path=customXml/itemProps57.xml><?xml version="1.0" encoding="utf-8"?>
-<ds:datastoreItem xmlns:ds="http://schemas.openxmlformats.org/officeDocument/2006/customXml" ds:itemID="{AE04A922-1222-46EA-85D1-620CD08A927B}">
-  <ds:schemaRefs/>
-</ds:datastoreItem>
-</file>
-
-<file path=customXml/itemProps58.xml><?xml version="1.0" encoding="utf-8"?>
-<ds:datastoreItem xmlns:ds="http://schemas.openxmlformats.org/officeDocument/2006/customXml" ds:itemID="{33C2836D-CD36-48F0-AE3F-D27BFE792AB7}">
-  <ds:schemaRefs/>
-</ds:datastoreItem>
-</file>
-
-<file path=customXml/itemProps59.xml><?xml version="1.0" encoding="utf-8"?>
-<ds:datastoreItem xmlns:ds="http://schemas.openxmlformats.org/officeDocument/2006/customXml" ds:itemID="{1669606D-CDD4-43E6-985A-81776140D176}">
-  <ds:schemaRefs/>
-</ds:datastoreItem>
-</file>
-
-<file path=customXml/itemProps6.xml><?xml version="1.0" encoding="utf-8"?>
-<ds:datastoreItem xmlns:ds="http://schemas.openxmlformats.org/officeDocument/2006/customXml" ds:itemID="{647B6612-4C79-45CE-9A32-14C2D37B46F1}">
-  <ds:schemaRefs/>
-</ds:datastoreItem>
-</file>
-
-<file path=customXml/itemProps60.xml><?xml version="1.0" encoding="utf-8"?>
-<ds:datastoreItem xmlns:ds="http://schemas.openxmlformats.org/officeDocument/2006/customXml" ds:itemID="{25EDB0A7-1862-4F58-81F8-88FFEB27A481}">
-  <ds:schemaRefs/>
-</ds:datastoreItem>
-</file>
-
-<file path=customXml/itemProps61.xml><?xml version="1.0" encoding="utf-8"?>
-<ds:datastoreItem xmlns:ds="http://schemas.openxmlformats.org/officeDocument/2006/customXml" ds:itemID="{2EF89111-4289-441B-97BD-A2D8E126532F}">
-  <ds:schemaRefs/>
-</ds:datastoreItem>
-</file>
-
-<file path=customXml/itemProps7.xml><?xml version="1.0" encoding="utf-8"?>
-<ds:datastoreItem xmlns:ds="http://schemas.openxmlformats.org/officeDocument/2006/customXml" ds:itemID="{2A1B10AF-5356-4D21-9E16-9423E20937FC}">
-  <ds:schemaRefs/>
-</ds:datastoreItem>
-</file>
-
-<file path=customXml/itemProps8.xml><?xml version="1.0" encoding="utf-8"?>
-<ds:datastoreItem xmlns:ds="http://schemas.openxmlformats.org/officeDocument/2006/customXml" ds:itemID="{1AB4A281-5EBA-4CA1-A536-6B29C98890B6}">
-  <ds:schemaRefs/>
-</ds:datastoreItem>
-</file>
-
-<file path=customXml/itemProps9.xml><?xml version="1.0" encoding="utf-8"?>
-<ds:datastoreItem xmlns:ds="http://schemas.openxmlformats.org/officeDocument/2006/customXml" ds:itemID="{A20E27A4-6C3C-428D-ADE7-7DC089C0CD46}">
-  <ds:schemaRefs/>
-</ds:datastoreItem>
-</file>
-
 <file path=docMetadata/LabelInfo.xml><?xml version="1.0" encoding="utf-8"?>
 <clbl:labelList xmlns:clbl="http://schemas.microsoft.com/office/2020/mipLabelMetadata">
   <clbl:label id="{2d0b1989-8fc8-4a69-bcac-d46889461ba5}" enabled="1" method="Privileged" siteId="{3dd8961f-e488-4e60-8e11-a82d994e183d}" contentBits="1" removed="0"/>

</xml_diff>

<commit_message>
Fold Sudoku notebook explainer cells into code comments; update deck
</commit_message>
<xml_diff>
--- a/docs/AMD-Unsloth-GRPO-Fine-tuning1.pptx
+++ b/docs/AMD-Unsloth-GRPO-Fine-tuning1.pptx
@@ -19673,7 +19673,7 @@
                 </a:solidFill>
                 <a:latin typeface="Klavika Regular"/>
               </a:rPr>
-              <a:t>An open-source, no-code framework and UI for training, running and exporting LLMs </a:t>
+              <a:t>An open-source library for training, running and exporting LLMs </a:t>
             </a:r>
             <a:r>
               <a:rPr sz="1600" b="1">
@@ -19691,7 +19691,7 @@
                 </a:solidFill>
                 <a:latin typeface="Klavika Regular"/>
               </a:rPr>
-              <a:t>, tuned for speed, memory efficiency and accessibility.</a:t>
+              <a:t>, with less memory and in less time.</a:t>
             </a:r>
           </a:p>
           <a:p>
@@ -19713,7 +19713,7 @@
                 </a:solidFill>
                 <a:latin typeface="Klavika Regular"/>
               </a:rPr>
-              <a:t>It sits as an optimized layer on top of Hugging Face Transformers, so your existing workflow still applies.</a:t>
+              <a:t>It builds on Hugging Face Transformers and TRL, so code you already have still works.</a:t>
             </a:r>
           </a:p>
         </p:txBody>
@@ -20625,7 +20625,7 @@
                 </a:solidFill>
                 <a:latin typeface="Klavika Regular"/>
               </a:rPr>
-              <a:t> is what makes a GRPO run finish inside a session slot instead of overnight.</a:t>
+              <a:t> fits fifteen GRPO steps into about 12½ minutes on one Radeon PRO W7900D.</a:t>
             </a:r>
           </a:p>
         </p:txBody>
@@ -20715,7 +20715,7 @@
                 </a:solidFill>
                 <a:latin typeface="Klavika Light"/>
               </a:rPr>
-              <a:t>A game of Sudoku, an AMD Radeon GPU, and a notebook you drive yourself</a:t>
+              <a:t>A game of Sudoku, a Radeon PRO W7900D, and a notebook you drive yourself</a:t>
             </a:r>
           </a:p>
         </p:txBody>
@@ -21035,7 +21035,7 @@
                 </a:solidFill>
                 <a:latin typeface="Klavika Regular"/>
               </a:rPr>
-              <a:t>A board is right or wrong. No human judge needed.</a:t>
+              <a:t>A move is legal or it isn't. No human judge needed.</a:t>
             </a:r>
           </a:p>
         </p:txBody>
@@ -21168,7 +21168,7 @@
                 </a:solidFill>
                 <a:latin typeface="Klavika Bold"/>
               </a:rPr>
-              <a:t>Reward-friendly</a:t>
+              <a:t>Partial credit</a:t>
             </a:r>
           </a:p>
         </p:txBody>
@@ -21210,7 +21210,7 @@
                 </a:solidFill>
                 <a:latin typeface="Klavika Regular"/>
               </a:rPr>
-              <a:t>Score partial credit per correct cell, row and box.</a:t>
+              <a:t>Points for code that runs, for each legal move, and most for a solve.</a:t>
             </a:r>
           </a:p>
         </p:txBody>
@@ -21343,7 +21343,7 @@
                 </a:solidFill>
                 <a:latin typeface="Klavika Bold"/>
               </a:rPr>
-              <a:t>Genuinely hard</a:t>
+              <a:t>Hard to cheat</a:t>
             </a:r>
           </a:p>
         </p:txBody>
@@ -21385,7 +21385,7 @@
                 </a:solidFill>
                 <a:latin typeface="Klavika Regular"/>
               </a:rPr>
-              <a:t>A general model gets it wrong. Improvement is visible.</a:t>
+              <a:t>Imports are blocked and every run has a time limit.</a:t>
             </a:r>
           </a:p>
         </p:txBody>
@@ -21444,7 +21444,7 @@
           <p:nvPr/>
         </p:nvPicPr>
         <p:blipFill>
-          <a:blip r:embed="rId4"/>
+          <a:blip r:embed="rId5"/>
           <a:stretch>
             <a:fillRect/>
           </a:stretch>
@@ -21496,7 +21496,7 @@
                 </a:solidFill>
                 <a:latin typeface="Klavika Regular"/>
               </a:rPr>
-              <a:t>Our training task: an easy grid, scored cell by cell</a:t>
+              <a:t>The model writes a strategy function. The notebook plays it and scores it.</a:t>
             </a:r>
           </a:p>
         </p:txBody>
@@ -22219,7 +22219,7 @@
                 </a:solidFill>
                 <a:latin typeface="Klavika Regular"/>
               </a:rPr>
-              <a:t>Lands you on an AMD Radeon GPU</a:t>
+              <a:t>Lands you on a Radeon PRO W7900D with 48 GB</a:t>
             </a:r>
           </a:p>
         </p:txBody>
@@ -22278,7 +22278,7 @@
           <p:nvPr/>
         </p:nvPicPr>
         <p:blipFill>
-          <a:blip r:embed="rId4"/>
+          <a:blip r:embed="rId5"/>
           <a:stretch>
             <a:fillRect/>
           </a:stretch>
@@ -22293,6 +22293,66 @@
           </a:prstGeom>
         </p:spPr>
       </p:pic>
+      <p:sp>
+        <p:nvSpPr>
+          <p:cNvPr id="24" name="TextBox password"/>
+          <p:cNvSpPr txBox="1"/>
+          <p:nvPr/>
+        </p:nvSpPr>
+        <p:spPr>
+          <a:xfrm>
+            <a:off x="1426464" y="3136392"/>
+            <a:ext cx="3931920" cy="307777"/>
+          </a:xfrm>
+          <a:prstGeom prst="rect">
+            <a:avLst/>
+          </a:prstGeom>
+          <a:noFill/>
+        </p:spPr>
+        <p:txBody>
+          <a:bodyPr wrap="square" lIns="0" tIns="0" rIns="0" bIns="0">
+            <a:spAutoFit/>
+          </a:bodyPr>
+          <a:lstStyle/>
+          <a:p>
+            <a:pPr algn="l">
+              <a:spcBef>
+                <a:spcPts val="0"/>
+              </a:spcBef>
+              <a:spcAft>
+                <a:spcPts val="600"/>
+              </a:spcAft>
+            </a:pPr>
+            <a:r>
+              <a:rPr sz="2000" b="1" dirty="0">
+                <a:solidFill>
+                  <a:srgbClr val="00A8CC"/>
+                </a:solidFill>
+                <a:latin typeface="Consolas"/>
+              </a:rPr>
+              <a:t>RadeonUnslothTuning</a:t>
+            </a:r>
+            <a:r>
+              <a:rPr sz="2000" b="1" dirty="0" err="1">
+                <a:solidFill>
+                  <a:srgbClr val="00A8CC"/>
+                </a:solidFill>
+                <a:latin typeface="Consolas"/>
+              </a:rPr>
+              <a:t/>
+            </a:r>
+            <a:r>
+              <a:rPr sz="2000" b="1" dirty="0">
+                <a:solidFill>
+                  <a:srgbClr val="00A8CC"/>
+                </a:solidFill>
+                <a:latin typeface="Consolas"/>
+              </a:rPr>
+              <a:t/>
+            </a:r>
+          </a:p>
+        </p:txBody>
+      </p:sp>
     </p:spTree>
   </p:cSld>
   <p:clrMapOvr>
@@ -22393,7 +22453,7 @@
                 </a:solidFill>
                 <a:latin typeface="Klavika Regular"/>
               </a:rPr>
-              <a:t>Open a terminal inside Jupyter and confirm the GPU is </a:t>
+              <a:t>Before you train, open a terminal in Jupyter and check that the GPU is </a:t>
             </a:r>
             <a:r>
               <a:rPr lang="en-US" sz="1500" b="0" dirty="0">
@@ -22402,7 +22462,7 @@
                 </a:solidFill>
                 <a:latin typeface="Klavika Regular"/>
               </a:rPr>
-              <a:t>available </a:t>
+              <a:t>visible</a:t>
             </a:r>
             <a:r>
               <a:rPr sz="1500" b="0" dirty="0">
@@ -22411,7 +22471,7 @@
                 </a:solidFill>
                 <a:latin typeface="Klavika Regular"/>
               </a:rPr>
-              <a:t>before you train.</a:t>
+              <a:t>.</a:t>
             </a:r>
           </a:p>
         </p:txBody>
@@ -23224,7 +23284,7 @@
                 </a:solidFill>
                 <a:latin typeface="Klavika Regular"/>
               </a:rPr>
-              <a:t>GPU busy at 0% while a cell runs? It is not training.</a:t>
+              <a:t>GPU% stuck at 0 while a cell runs? It is not training.</a:t>
             </a:r>
           </a:p>
         </p:txBody>
@@ -23283,7 +23343,7 @@
           <p:nvPr/>
         </p:nvPicPr>
         <p:blipFill>
-          <a:blip r:embed="rId4"/>
+          <a:blip r:embed="rId6"/>
           <a:stretch>
             <a:fillRect/>
           </a:stretch>
@@ -23352,7 +23412,7 @@
           <p:nvPr/>
         </p:nvPicPr>
         <p:blipFill>
-          <a:blip r:embed="rId5"/>
+          <a:blip r:embed="rId7"/>
           <a:stretch>
             <a:fillRect/>
           </a:stretch>
@@ -23407,7 +23467,7 @@
                 </a:solidFill>
                 <a:latin typeface="Klavika Regular"/>
               </a:rPr>
-              <a:t>rocminfo confirms the ROCm runtime version and every agent the host exposes, GPU and CPU alike.</a:t>
+              <a:t>rocminfo lists the CPU as an agent too. The Radeon PRO W7900D is the agent named gfx1100.</a:t>
             </a:r>
           </a:p>
         </p:txBody>
@@ -23512,7 +23572,7 @@
                 </a:solidFill>
                 <a:latin typeface="Klavika Regular"/>
               </a:rPr>
-              <a:t>Run cells top to bottom. The first model load is the slow one.</a:t>
+              <a:t>Run cells top to bottom. Loading the model and the first generation are the slow parts.</a:t>
             </a:r>
           </a:p>
         </p:txBody>
@@ -24260,7 +24320,7 @@
                 </a:solidFill>
                 <a:latin typeface="Klavika Regular"/>
               </a:rPr>
-              <a:t>First load pulls weights. Retry a timed-out chat, the warm model is fast</a:t>
+              <a:t>The warmup cell takes the first-generation cost before training starts.</a:t>
             </a:r>
           </a:p>
         </p:txBody>
@@ -24319,7 +24379,7 @@
           <p:nvPr/>
         </p:nvPicPr>
         <p:blipFill>
-          <a:blip r:embed="rId4"/>
+          <a:blip r:embed="rId5"/>
           <a:stretch>
             <a:fillRect/>
           </a:stretch>
@@ -24434,7 +24494,7 @@
                 </a:solidFill>
                 <a:latin typeface="Klavika Regular"/>
               </a:rPr>
-              <a:t>Fifteen GRPO steps on a Radeon GPU, and the reward curve moves.</a:t>
+              <a:t>Fifteen GRPO steps on the portal's Radeon PRO W7900D took about 12½ minutes.</a:t>
             </a:r>
           </a:p>
         </p:txBody>
@@ -24546,7 +24606,7 @@
           <p:nvPr/>
         </p:nvPicPr>
         <p:blipFill>
-          <a:blip r:embed="rId4"/>
+          <a:blip r:embed="rId6"/>
           <a:stretch>
             <a:fillRect/>
           </a:stretch>
@@ -24598,7 +24658,7 @@
                 </a:solidFill>
                 <a:latin typeface="Klavika Regular"/>
               </a:rPr>
-              <a:t>Per-step training loss and reward, straight from the notebook</a:t>
+              <a:t>Legal moves, out of 40, for each strategy the model wrote (two per step)</a:t>
             </a:r>
           </a:p>
         </p:txBody>
@@ -24657,7 +24717,7 @@
           <p:nvPr/>
         </p:nvPicPr>
         <p:blipFill>
-          <a:blip r:embed="rId5"/>
+          <a:blip r:embed="rId7"/>
           <a:stretch>
             <a:fillRect/>
           </a:stretch>
@@ -24709,7 +24769,7 @@
                 </a:solidFill>
                 <a:latin typeface="Klavika Regular"/>
               </a:rPr>
-              <a:t>Final board produced by the tuned model</a:t>
+              <a:t>The step 13 strategy replayed on a new puzzle</a:t>
             </a:r>
           </a:p>
         </p:txBody>
@@ -24893,7 +24953,7 @@
                 </a:solidFill>
                 <a:latin typeface="Klavika Regular"/>
               </a:rPr>
-              <a:t>Reward trending up, not the absolute value</a:t>
+              <a:t>Most strategies make 27 to 36 legal moves, then guess wrong</a:t>
             </a:r>
           </a:p>
           <a:p>
@@ -24921,7 +24981,7 @@
                 </a:solidFill>
                 <a:latin typeface="Klavika Regular"/>
               </a:rPr>
-              <a:t>A structurally valid board, no repeated digits</a:t>
+              <a:t>It never backtracks, so a solve is partly luck. Longer runs do better</a:t>
             </a:r>
           </a:p>
         </p:txBody>
@@ -25201,7 +25261,7 @@
                 </a:solidFill>
                 <a:latin typeface="Klavika Bold"/>
               </a:rPr>
-              <a:t>First chat response times out</a:t>
+              <a:t>First generation is slow</a:t>
             </a:r>
           </a:p>
         </p:txBody>
@@ -25243,7 +25303,7 @@
                 </a:solidFill>
                 <a:latin typeface="Klavika Regular"/>
               </a:rPr>
-              <a:t>Cold model load. Retry, the warm model answers fast.</a:t>
+              <a:t>Kernels compile on first use. Run the warmup cell; later calls are faster.</a:t>
             </a:r>
           </a:p>
         </p:txBody>
@@ -25376,7 +25436,7 @@
                 </a:solidFill>
                 <a:latin typeface="Klavika Bold"/>
               </a:rPr>
-              <a:t>Training data format issues</a:t>
+              <a:t>Reward stays negative</a:t>
             </a:r>
           </a:p>
         </p:txBody>
@@ -25418,7 +25478,7 @@
                 </a:solidFill>
                 <a:latin typeface="Klavika Regular"/>
               </a:rPr>
-              <a:t>Check the Alpaca fields: instruction, input, output.</a:t>
+              <a:t>The model isn't returning a Python code block. Re-run the prompt cell unchanged.</a:t>
             </a:r>
           </a:p>
         </p:txBody>
@@ -25593,7 +25653,7 @@
                 </a:solidFill>
                 <a:latin typeface="Klavika Regular"/>
               </a:rPr>
-              <a:t>Smaller model, enable QLoRA 4-bit, lower batch size or sequence length.</a:t>
+              <a:t>Lower max_seq_length or lora_rank. num_generations is already at its minimum of 2.</a:t>
             </a:r>
           </a:p>
         </p:txBody>
@@ -25726,7 +25786,7 @@
                 </a:solidFill>
                 <a:latin typeface="Klavika Bold"/>
               </a:rPr>
-              <a:t>Loss not decreasing</a:t>
+              <a:t>Training loss stays near 0</a:t>
             </a:r>
           </a:p>
         </p:txBody>
@@ -25768,7 +25828,7 @@
                 </a:solidFill>
                 <a:latin typeface="Klavika Regular"/>
               </a:rPr>
-              <a:t>Raise the learning rate a little, train more steps, re-check the dataset format.</a:t>
+              <a:t>Normal for GRPO. Watch the reward column instead.</a:t>
             </a:r>
           </a:p>
         </p:txBody>
@@ -25943,7 +26003,7 @@
                 </a:solidFill>
                 <a:latin typeface="Klavika Regular"/>
               </a:rPr>
-              <a:t>Run rocm-smi. GPU use drops to zero when training is actually finished.</a:t>
+              <a:t>Run rocm-smi. If GPU% stays at 0, restart the kernel and run from the top.</a:t>
             </a:r>
           </a:p>
         </p:txBody>
@@ -26076,7 +26136,7 @@
                 </a:solidFill>
                 <a:latin typeface="Klavika Bold"/>
               </a:rPr>
-              <a:t>Need a first experiment idea?</a:t>
+              <a:t>What to try next</a:t>
             </a:r>
           </a:p>
         </p:txBody>
@@ -26118,7 +26178,7 @@
                 </a:solidFill>
                 <a:latin typeface="Klavika Regular"/>
               </a:rPr>
-              <a:t>Start with SFT on a Hugging Face set, then GRPO on math where answers are checkable.</a:t>
+              <a:t>Raise max_steps, or resume from outputs/checkpoint-15 as the notebook shows.</a:t>
             </a:r>
           </a:p>
         </p:txBody>
@@ -26965,7 +27025,7 @@
                 </a:solidFill>
                 <a:latin typeface="Klavika Bold"/>
               </a:rPr>
-              <a:t>QLoRA paper</a:t>
+              <a:t>Gemma 4 E2B</a:t>
             </a:r>
           </a:p>
         </p:txBody>
@@ -27007,7 +27067,7 @@
                 </a:solidFill>
                 <a:latin typeface="Consolas"/>
               </a:rPr>
-              <a:t>arxiv.org/abs/2305.14314</a:t>
+              <a:t>huggingface.co/unsloth/gemma-4-E2B-it</a:t>
             </a:r>
           </a:p>
         </p:txBody>
@@ -27049,7 +27109,7 @@
                 </a:solidFill>
                 <a:latin typeface="Klavika Regular"/>
               </a:rPr>
-              <a:t>4-bit finetuning, Dettmers et al.</a:t>
+              <a:t>The model used today</a:t>
             </a:r>
           </a:p>
         </p:txBody>
@@ -28367,7 +28427,7 @@
                 </a:solidFill>
                 <a:latin typeface="Klavika Regular"/>
               </a:rPr>
-              <a:t>Faster, leaner, no-code</a:t>
+              <a:t>Faster and leaner on one GPU</a:t>
             </a:r>
           </a:p>
         </p:txBody>
@@ -28759,7 +28819,7 @@
                 </a:solidFill>
                 <a:latin typeface="Klavika Bold"/>
               </a:rPr>
-              <a:t>AMD Radeon GPU</a:t>
+              <a:t>Radeon PRO W7900D</a:t>
             </a:r>
           </a:p>
         </p:txBody>
@@ -30324,7 +30384,7 @@
                 </a:solidFill>
                 <a:latin typeface="Klavika Bold"/>
               </a:rPr>
-              <a:t>YOUR</a:t>
+              <a:t>your</a:t>
             </a:r>
             <a:r>
               <a:rPr sz="1700" b="0">
@@ -30342,7 +30402,7 @@
                 </a:solidFill>
                 <a:latin typeface="Klavika Bold"/>
               </a:rPr>
-              <a:t>YOUR</a:t>
+              <a:t>your</a:t>
             </a:r>
             <a:r>
               <a:rPr sz="1700" b="0">
@@ -31290,7 +31350,7 @@
                 </a:solidFill>
                 <a:latin typeface="Klavika Regular"/>
               </a:rPr>
-              <a:t>Do one narrow task extremely well, cheaply, on a small model.</a:t>
+              <a:t>Do one narrow task well on a small, cheap model.</a:t>
             </a:r>
           </a:p>
         </p:txBody>
@@ -31435,7 +31495,7 @@
                 </a:solidFill>
                 <a:latin typeface="Klavika Regular"/>
               </a:rPr>
-              <a:t> than stuffing everything into a giant prompt or paying for an even bigger model. </a:t>
+              <a:t> than a very long prompt or a bigger model. </a:t>
             </a:r>
             <a:r>
               <a:rPr sz="1450" b="1" dirty="0">
@@ -31444,7 +31504,7 @@
                 </a:solidFill>
                 <a:latin typeface="Klavika Bold"/>
               </a:rPr>
-              <a:t>It lets a small model punch above its weight.</a:t>
+              <a:t>A small model can be enough.</a:t>
             </a:r>
           </a:p>
         </p:txBody>
@@ -31549,7 +31609,7 @@
                 </a:solidFill>
                 <a:latin typeface="Klavika Regular"/>
               </a:rPr>
-              <a:t>Parameter-efficient fine-tuning: freeze the giant model, train a tiny adapter.</a:t>
+              <a:t>Parameter-efficient fine-tuning: freeze the model, train a small adapter.</a:t>
             </a:r>
           </a:p>
         </p:txBody>
@@ -32319,7 +32379,7 @@
                 </a:solidFill>
                 <a:latin typeface="Klavika Bold"/>
               </a:rPr>
-              <a:t>~0.1%</a:t>
+              <a:t>1.16%</a:t>
             </a:r>
           </a:p>
         </p:txBody>
@@ -32361,7 +32421,7 @@
                 </a:solidFill>
                 <a:latin typeface="Klavika Regular"/>
               </a:rPr>
-              <a:t>of parameters trained</a:t>
+              <a:t>of Gemma 4 E2B trained today</a:t>
             </a:r>
           </a:p>
         </p:txBody>
@@ -33939,7 +33999,7 @@
                 </a:solidFill>
                 <a:latin typeface="Klavika Regular"/>
               </a:rPr>
-              <a:t>Same spine either way. The data step is what differs.</a:t>
+              <a:t>The steps are the same for both. Only the data step changes.</a:t>
             </a:r>
           </a:p>
         </p:txBody>

</xml_diff>